<commit_message>
prepare learn next.js #2
</commit_message>
<xml_diff>
--- a/learn_nextjs/2_App_Router/App_Router.pptx
+++ b/learn_nextjs/2_App_Router/App_Router.pptx
@@ -5,16 +5,17 @@
     <p:sldMasterId id="2147483648" r:id="rId4"/>
   </p:sldMasterIdLst>
   <p:notesMasterIdLst>
-    <p:notesMasterId r:id="rId9"/>
+    <p:notesMasterId r:id="rId10"/>
   </p:notesMasterIdLst>
   <p:handoutMasterIdLst>
-    <p:handoutMasterId r:id="rId10"/>
+    <p:handoutMasterId r:id="rId11"/>
   </p:handoutMasterIdLst>
   <p:sldIdLst>
-    <p:sldId id="256" r:id="rId5"/>
-    <p:sldId id="257" r:id="rId6"/>
-    <p:sldId id="276" r:id="rId7"/>
-    <p:sldId id="270" r:id="rId8"/>
+    <p:sldId id="276" r:id="rId5"/>
+    <p:sldId id="256" r:id="rId6"/>
+    <p:sldId id="257" r:id="rId7"/>
+    <p:sldId id="277" r:id="rId8"/>
+    <p:sldId id="270" r:id="rId9"/>
   </p:sldIdLst>
   <p:sldSz cx="12192000" cy="6858000"/>
   <p:notesSz cx="6858000" cy="9144000"/>
@@ -1703,30 +1704,87 @@
     <dgm:pt modelId="{3F8A6D25-EC33-4E79-9F36-36771A974919}">
       <dgm:prSet phldrT="[Text]" phldr="0" custT="1"/>
       <dgm:spPr>
-        <a:solidFill>
-          <a:schemeClr val="tx1">
-            <a:lumMod val="85000"/>
-          </a:schemeClr>
-        </a:solidFill>
+        <a:gradFill rotWithShape="0">
+          <a:gsLst>
+            <a:gs pos="0">
+              <a:srgbClr val="ACD433">
+                <a:hueOff val="0"/>
+                <a:satOff val="0"/>
+                <a:lumOff val="0"/>
+                <a:alphaOff val="0"/>
+                <a:tint val="98000"/>
+                <a:lumMod val="114000"/>
+              </a:srgbClr>
+            </a:gs>
+            <a:gs pos="100000">
+              <a:srgbClr val="ACD433">
+                <a:hueOff val="0"/>
+                <a:satOff val="0"/>
+                <a:lumOff val="0"/>
+                <a:alphaOff val="0"/>
+                <a:shade val="90000"/>
+                <a:lumMod val="84000"/>
+              </a:srgbClr>
+            </a:gs>
+          </a:gsLst>
+          <a:lin ang="5400000" scaled="0"/>
+        </a:gradFill>
+        <a:ln>
+          <a:noFill/>
+        </a:ln>
+        <a:effectLst>
+          <a:outerShdw blurRad="38100" dist="25400" dir="5400000" rotWithShape="0">
+            <a:srgbClr val="000000">
+              <a:alpha val="45000"/>
+            </a:srgbClr>
+          </a:outerShdw>
+        </a:effectLst>
+        <a:scene3d>
+          <a:camera prst="orthographicFront"/>
+          <a:lightRig rig="threePt" dir="t">
+            <a:rot lat="0" lon="0" rev="7500000"/>
+          </a:lightRig>
+        </a:scene3d>
+        <a:sp3d prstMaterial="plastic">
+          <a:bevelT w="127000" h="25400" prst="relaxedInset"/>
+        </a:sp3d>
       </dgm:spPr>
       <dgm:t>
-        <a:bodyPr/>
+        <a:bodyPr spcFirstLastPara="0" vert="horz" wrap="square" lIns="170688" tIns="85344" rIns="42672" bIns="85344" numCol="1" spcCol="1270" anchor="ctr" anchorCtr="0"/>
         <a:lstStyle/>
         <a:p>
+          <a:pPr marL="0" lvl="0" indent="0" algn="ctr" defTabSz="1422400">
+            <a:lnSpc>
+              <a:spcPct val="90000"/>
+            </a:lnSpc>
+            <a:spcBef>
+              <a:spcPct val="0"/>
+            </a:spcBef>
+            <a:spcAft>
+              <a:spcPct val="35000"/>
+            </a:spcAft>
+            <a:buNone/>
+          </a:pPr>
           <a:r>
-            <a:rPr lang="en-US" sz="3200" b="1">
+            <a:rPr lang="en-US" sz="3200" b="1" kern="1200">
               <a:solidFill>
                 <a:srgbClr val="00B050"/>
               </a:solidFill>
               <a:effectLst/>
+              <a:latin typeface="Century Gothic" panose="020B0502020202020204"/>
+              <a:ea typeface="+mn-ea"/>
+              <a:cs typeface="+mn-cs"/>
             </a:rPr>
             <a:t>App Router</a:t>
           </a:r>
-          <a:endParaRPr lang="en-US" sz="3200" b="1" dirty="0">
+          <a:endParaRPr lang="en-US" sz="3200" b="1" kern="1200" dirty="0">
             <a:solidFill>
               <a:srgbClr val="00B050"/>
             </a:solidFill>
             <a:effectLst/>
+            <a:latin typeface="Century Gothic" panose="020B0502020202020204"/>
+            <a:ea typeface="+mn-ea"/>
+            <a:cs typeface="+mn-cs"/>
           </a:endParaRPr>
         </a:p>
       </dgm:t>
@@ -1910,7 +1968,15 @@
           <dgm:bulletEnabled val="1"/>
         </dgm:presLayoutVars>
       </dgm:prSet>
-      <dgm:spPr/>
+      <dgm:spPr>
+        <a:xfrm>
+          <a:off x="2586569" y="431693"/>
+          <a:ext cx="3229188" cy="1291675"/>
+        </a:xfrm>
+        <a:prstGeom prst="chevron">
+          <a:avLst/>
+        </a:prstGeom>
+      </dgm:spPr>
     </dgm:pt>
     <dgm:pt modelId="{D7399875-5945-4082-A56B-0967B2FF1CAA}" type="pres">
       <dgm:prSet presAssocID="{F5C31149-F876-40A6-9FD4-9FC1A73D7103}" presName="parSpace" presStyleCnt="0"/>
@@ -2409,11 +2475,31 @@
         <a:prstGeom prst="chevron">
           <a:avLst/>
         </a:prstGeom>
-        <a:solidFill>
-          <a:schemeClr val="tx1">
-            <a:lumMod val="85000"/>
-          </a:schemeClr>
-        </a:solidFill>
+        <a:gradFill rotWithShape="0">
+          <a:gsLst>
+            <a:gs pos="0">
+              <a:srgbClr val="ACD433">
+                <a:hueOff val="0"/>
+                <a:satOff val="0"/>
+                <a:lumOff val="0"/>
+                <a:alphaOff val="0"/>
+                <a:tint val="98000"/>
+                <a:lumMod val="114000"/>
+              </a:srgbClr>
+            </a:gs>
+            <a:gs pos="100000">
+              <a:srgbClr val="ACD433">
+                <a:hueOff val="0"/>
+                <a:satOff val="0"/>
+                <a:lumOff val="0"/>
+                <a:alphaOff val="0"/>
+                <a:shade val="90000"/>
+                <a:lumMod val="84000"/>
+              </a:srgbClr>
+            </a:gs>
+          </a:gsLst>
+          <a:lin ang="5400000" scaled="0"/>
+        </a:gradFill>
         <a:ln>
           <a:noFill/>
         </a:ln>
@@ -2449,7 +2535,7 @@
         </a:fontRef>
       </dsp:style>
       <dsp:txBody>
-        <a:bodyPr spcFirstLastPara="0" vert="horz" wrap="square" lIns="128016" tIns="85344" rIns="42672" bIns="85344" numCol="1" spcCol="1270" anchor="ctr" anchorCtr="0">
+        <a:bodyPr spcFirstLastPara="0" vert="horz" wrap="square" lIns="170688" tIns="85344" rIns="42672" bIns="85344" numCol="1" spcCol="1270" anchor="ctr" anchorCtr="0">
           <a:noAutofit/>
         </a:bodyPr>
         <a:lstStyle/>
@@ -2472,6 +2558,9 @@
                 <a:srgbClr val="00B050"/>
               </a:solidFill>
               <a:effectLst/>
+              <a:latin typeface="Century Gothic" panose="020B0502020202020204"/>
+              <a:ea typeface="+mn-ea"/>
+              <a:cs typeface="+mn-cs"/>
             </a:rPr>
             <a:t>App Router</a:t>
           </a:r>
@@ -2480,6 +2569,9 @@
               <a:srgbClr val="00B050"/>
             </a:solidFill>
             <a:effectLst/>
+            <a:latin typeface="Century Gothic" panose="020B0502020202020204"/>
+            <a:ea typeface="+mn-ea"/>
+            <a:cs typeface="+mn-cs"/>
           </a:endParaRPr>
         </a:p>
       </dsp:txBody>
@@ -5901,7 +5993,7 @@
           <a:p>
             <a:fld id="{F6E59275-AFE1-4999-B78A-D0D76B9F2B0B}" type="datetimeFigureOut">
               <a:rPr lang="en-US" smtClean="0"/>
-              <a:t>1/21/2026</a:t>
+              <a:t>1/24/2026</a:t>
             </a:fld>
             <a:endParaRPr lang="en-US" dirty="0"/>
           </a:p>
@@ -6078,7 +6170,7 @@
           <a:p>
             <a:fld id="{B3EADD7A-FE61-48EE-BE0E-8546E5401374}" type="datetimeFigureOut">
               <a:rPr lang="en-US" smtClean="0"/>
-              <a:t>1/20/2026</a:t>
+              <a:t>1/24/2026</a:t>
             </a:fld>
             <a:endParaRPr lang="en-US" dirty="0"/>
           </a:p>
@@ -6350,6 +6442,114 @@
   <p:cSld>
     <p:spTree>
       <p:nvGrpSpPr>
+        <p:cNvPr id="1" name="">
+          <a:extLst>
+            <a:ext uri="{FF2B5EF4-FFF2-40B4-BE49-F238E27FC236}">
+              <a16:creationId xmlns:a16="http://schemas.microsoft.com/office/drawing/2014/main" id="{4EAC7126-4785-6F23-806A-94F4FA0E0FC3}"/>
+            </a:ext>
+          </a:extLst>
+        </p:cNvPr>
+        <p:cNvGrpSpPr/>
+        <p:nvPr/>
+      </p:nvGrpSpPr>
+      <p:grpSpPr>
+        <a:xfrm>
+          <a:off x="0" y="0"/>
+          <a:ext cx="0" cy="0"/>
+          <a:chOff x="0" y="0"/>
+          <a:chExt cx="0" cy="0"/>
+        </a:xfrm>
+      </p:grpSpPr>
+      <p:sp>
+        <p:nvSpPr>
+          <p:cNvPr id="2" name="Slide Image Placeholder 1">
+            <a:extLst>
+              <a:ext uri="{FF2B5EF4-FFF2-40B4-BE49-F238E27FC236}">
+                <a16:creationId xmlns:a16="http://schemas.microsoft.com/office/drawing/2014/main" id="{BFA150D2-105A-2F82-0ECB-F19BD7BEA00F}"/>
+              </a:ext>
+            </a:extLst>
+          </p:cNvPr>
+          <p:cNvSpPr>
+            <a:spLocks noGrp="1" noRot="1" noChangeAspect="1"/>
+          </p:cNvSpPr>
+          <p:nvPr>
+            <p:ph type="sldImg"/>
+          </p:nvPr>
+        </p:nvSpPr>
+        <p:spPr/>
+      </p:sp>
+      <p:sp>
+        <p:nvSpPr>
+          <p:cNvPr id="3" name="Notes Placeholder 2">
+            <a:extLst>
+              <a:ext uri="{FF2B5EF4-FFF2-40B4-BE49-F238E27FC236}">
+                <a16:creationId xmlns:a16="http://schemas.microsoft.com/office/drawing/2014/main" id="{588D1BEE-D27E-E195-D315-77C949C297E1}"/>
+              </a:ext>
+            </a:extLst>
+          </p:cNvPr>
+          <p:cNvSpPr>
+            <a:spLocks noGrp="1"/>
+          </p:cNvSpPr>
+          <p:nvPr>
+            <p:ph type="body" idx="1"/>
+          </p:nvPr>
+        </p:nvSpPr>
+        <p:spPr/>
+        <p:txBody>
+          <a:bodyPr/>
+          <a:lstStyle/>
+          <a:p>
+            <a:endParaRPr lang="en-US" dirty="0"/>
+          </a:p>
+        </p:txBody>
+      </p:sp>
+      <p:sp>
+        <p:nvSpPr>
+          <p:cNvPr id="4" name="Slide Number Placeholder 3">
+            <a:extLst>
+              <a:ext uri="{FF2B5EF4-FFF2-40B4-BE49-F238E27FC236}">
+                <a16:creationId xmlns:a16="http://schemas.microsoft.com/office/drawing/2014/main" id="{2D139FE7-EB62-CD28-CCC1-F88018C3681A}"/>
+              </a:ext>
+            </a:extLst>
+          </p:cNvPr>
+          <p:cNvSpPr>
+            <a:spLocks noGrp="1"/>
+          </p:cNvSpPr>
+          <p:nvPr>
+            <p:ph type="sldNum" sz="quarter" idx="5"/>
+          </p:nvPr>
+        </p:nvSpPr>
+        <p:spPr/>
+        <p:txBody>
+          <a:bodyPr/>
+          <a:lstStyle/>
+          <a:p>
+            <a:fld id="{EE000EEB-8338-48D7-8EE8-EE0082EF7602}" type="slidenum">
+              <a:rPr lang="en-US" smtClean="0"/>
+              <a:t>1</a:t>
+            </a:fld>
+            <a:endParaRPr lang="en-US" dirty="0"/>
+          </a:p>
+        </p:txBody>
+      </p:sp>
+    </p:spTree>
+    <p:extLst>
+      <p:ext uri="{BB962C8B-B14F-4D97-AF65-F5344CB8AC3E}">
+        <p14:creationId xmlns:p14="http://schemas.microsoft.com/office/powerpoint/2010/main" val="1215950728"/>
+      </p:ext>
+    </p:extLst>
+  </p:cSld>
+  <p:clrMapOvr>
+    <a:masterClrMapping/>
+  </p:clrMapOvr>
+</p:notes>
+</file>
+
+<file path=ppt/notesSlides/notesSlide2.xml><?xml version="1.0" encoding="utf-8"?>
+<p:notes xmlns:a="http://schemas.openxmlformats.org/drawingml/2006/main" xmlns:r="http://schemas.openxmlformats.org/officeDocument/2006/relationships" xmlns:p="http://schemas.openxmlformats.org/presentationml/2006/main">
+  <p:cSld>
+    <p:spTree>
+      <p:nvGrpSpPr>
         <p:cNvPr id="1" name=""/>
         <p:cNvGrpSpPr/>
         <p:nvPr/>
@@ -6410,7 +6610,7 @@
           <a:p>
             <a:fld id="{EE000EEB-8338-48D7-8EE8-EE0082EF7602}" type="slidenum">
               <a:rPr lang="en-US" smtClean="0"/>
-              <a:t>1</a:t>
+              <a:t>2</a:t>
             </a:fld>
             <a:endParaRPr lang="en-US" dirty="0"/>
           </a:p>
@@ -6429,7 +6629,7 @@
 </p:notes>
 </file>
 
-<file path=ppt/notesSlides/notesSlide2.xml><?xml version="1.0" encoding="utf-8"?>
+<file path=ppt/notesSlides/notesSlide3.xml><?xml version="1.0" encoding="utf-8"?>
 <p:notes xmlns:a="http://schemas.openxmlformats.org/drawingml/2006/main" xmlns:r="http://schemas.openxmlformats.org/officeDocument/2006/relationships" xmlns:p="http://schemas.openxmlformats.org/presentationml/2006/main">
   <p:cSld>
     <p:spTree>
@@ -6518,7 +6718,7 @@
           <a:p>
             <a:fld id="{EE000EEB-8338-48D7-8EE8-EE0082EF7602}" type="slidenum">
               <a:rPr lang="en-US" smtClean="0"/>
-              <a:t>2</a:t>
+              <a:t>3</a:t>
             </a:fld>
             <a:endParaRPr lang="en-US" dirty="0"/>
           </a:p>
@@ -6537,7 +6737,7 @@
 </p:notes>
 </file>
 
-<file path=ppt/notesSlides/notesSlide3.xml><?xml version="1.0" encoding="utf-8"?>
+<file path=ppt/notesSlides/notesSlide4.xml><?xml version="1.0" encoding="utf-8"?>
 <p:notes xmlns:a="http://schemas.openxmlformats.org/drawingml/2006/main" xmlns:r="http://schemas.openxmlformats.org/officeDocument/2006/relationships" xmlns:p="http://schemas.openxmlformats.org/presentationml/2006/main">
   <p:cSld>
     <p:spTree>
@@ -6545,7 +6745,7 @@
         <p:cNvPr id="1" name="">
           <a:extLst>
             <a:ext uri="{FF2B5EF4-FFF2-40B4-BE49-F238E27FC236}">
-              <a16:creationId xmlns:a16="http://schemas.microsoft.com/office/drawing/2014/main" id="{4EAC7126-4785-6F23-806A-94F4FA0E0FC3}"/>
+              <a16:creationId xmlns:a16="http://schemas.microsoft.com/office/drawing/2014/main" id="{2874FF35-9CC1-662F-C04B-06BB8FB9BE38}"/>
             </a:ext>
           </a:extLst>
         </p:cNvPr>
@@ -6565,7 +6765,7 @@
           <p:cNvPr id="2" name="Slide Image Placeholder 1">
             <a:extLst>
               <a:ext uri="{FF2B5EF4-FFF2-40B4-BE49-F238E27FC236}">
-                <a16:creationId xmlns:a16="http://schemas.microsoft.com/office/drawing/2014/main" id="{BFA150D2-105A-2F82-0ECB-F19BD7BEA00F}"/>
+                <a16:creationId xmlns:a16="http://schemas.microsoft.com/office/drawing/2014/main" id="{8BED8448-A4E1-7CD9-3902-0B9A90D73364}"/>
               </a:ext>
             </a:extLst>
           </p:cNvPr>
@@ -6583,7 +6783,7 @@
           <p:cNvPr id="3" name="Notes Placeholder 2">
             <a:extLst>
               <a:ext uri="{FF2B5EF4-FFF2-40B4-BE49-F238E27FC236}">
-                <a16:creationId xmlns:a16="http://schemas.microsoft.com/office/drawing/2014/main" id="{588D1BEE-D27E-E195-D315-77C949C297E1}"/>
+                <a16:creationId xmlns:a16="http://schemas.microsoft.com/office/drawing/2014/main" id="{A2C24DDA-3136-DAF9-BE11-BD505F7ADE7D}"/>
               </a:ext>
             </a:extLst>
           </p:cNvPr>
@@ -6608,7 +6808,7 @@
           <p:cNvPr id="4" name="Slide Number Placeholder 3">
             <a:extLst>
               <a:ext uri="{FF2B5EF4-FFF2-40B4-BE49-F238E27FC236}">
-                <a16:creationId xmlns:a16="http://schemas.microsoft.com/office/drawing/2014/main" id="{2D139FE7-EB62-CD28-CCC1-F88018C3681A}"/>
+                <a16:creationId xmlns:a16="http://schemas.microsoft.com/office/drawing/2014/main" id="{A3128D75-8D16-2FB4-3901-EE3D079BAAF2}"/>
               </a:ext>
             </a:extLst>
           </p:cNvPr>
@@ -6626,7 +6826,7 @@
           <a:p>
             <a:fld id="{EE000EEB-8338-48D7-8EE8-EE0082EF7602}" type="slidenum">
               <a:rPr lang="en-US" smtClean="0"/>
-              <a:t>3</a:t>
+              <a:t>4</a:t>
             </a:fld>
             <a:endParaRPr lang="en-US" dirty="0"/>
           </a:p>
@@ -6635,7 +6835,7 @@
     </p:spTree>
     <p:extLst>
       <p:ext uri="{BB962C8B-B14F-4D97-AF65-F5344CB8AC3E}">
-        <p14:creationId xmlns:p14="http://schemas.microsoft.com/office/powerpoint/2010/main" val="1215950728"/>
+        <p14:creationId xmlns:p14="http://schemas.microsoft.com/office/powerpoint/2010/main" val="2528888568"/>
       </p:ext>
     </p:extLst>
   </p:cSld>
@@ -6645,7 +6845,7 @@
 </p:notes>
 </file>
 
-<file path=ppt/notesSlides/notesSlide4.xml><?xml version="1.0" encoding="utf-8"?>
+<file path=ppt/notesSlides/notesSlide5.xml><?xml version="1.0" encoding="utf-8"?>
 <p:notes xmlns:a="http://schemas.openxmlformats.org/drawingml/2006/main" xmlns:r="http://schemas.openxmlformats.org/officeDocument/2006/relationships" xmlns:p="http://schemas.openxmlformats.org/presentationml/2006/main">
   <p:cSld>
     <p:spTree>
@@ -6734,7 +6934,7 @@
           <a:p>
             <a:fld id="{EE000EEB-8338-48D7-8EE8-EE0082EF7602}" type="slidenum">
               <a:rPr lang="en-US" smtClean="0"/>
-              <a:t>4</a:t>
+              <a:t>5</a:t>
             </a:fld>
             <a:endParaRPr lang="en-US" dirty="0"/>
           </a:p>
@@ -6936,7 +7136,7 @@
           <a:p>
             <a:fld id="{4AAD347D-5ACD-4C99-B74B-A9C85AD731AF}" type="datetimeFigureOut">
               <a:rPr lang="en-US" dirty="0"/>
-              <a:t>1/20/2026</a:t>
+              <a:t>1/24/2026</a:t>
             </a:fld>
             <a:endParaRPr lang="en-US" dirty="0"/>
           </a:p>
@@ -7206,7 +7406,7 @@
           <a:p>
             <a:fld id="{4509A250-FF31-4206-8172-F9D3106AACB1}" type="datetimeFigureOut">
               <a:rPr lang="en-US" dirty="0"/>
-              <a:t>1/20/2026</a:t>
+              <a:t>1/24/2026</a:t>
             </a:fld>
             <a:endParaRPr lang="en-US" dirty="0"/>
           </a:p>
@@ -7395,7 +7595,7 @@
           <a:p>
             <a:fld id="{4509A250-FF31-4206-8172-F9D3106AACB1}" type="datetimeFigureOut">
               <a:rPr lang="en-US" dirty="0"/>
-              <a:t>1/20/2026</a:t>
+              <a:t>1/24/2026</a:t>
             </a:fld>
             <a:endParaRPr lang="en-US" dirty="0"/>
           </a:p>
@@ -7658,7 +7858,7 @@
           <a:p>
             <a:fld id="{4509A250-FF31-4206-8172-F9D3106AACB1}" type="datetimeFigureOut">
               <a:rPr lang="en-US" dirty="0"/>
-              <a:t>1/20/2026</a:t>
+              <a:t>1/24/2026</a:t>
             </a:fld>
             <a:endParaRPr lang="en-US" dirty="0"/>
           </a:p>
@@ -7985,7 +8185,7 @@
           <a:p>
             <a:fld id="{4509A250-FF31-4206-8172-F9D3106AACB1}" type="datetimeFigureOut">
               <a:rPr lang="en-US" dirty="0"/>
-              <a:t>1/20/2026</a:t>
+              <a:t>1/24/2026</a:t>
             </a:fld>
             <a:endParaRPr lang="en-US" dirty="0"/>
           </a:p>
@@ -8590,7 +8790,7 @@
           <a:p>
             <a:fld id="{4509A250-FF31-4206-8172-F9D3106AACB1}" type="datetimeFigureOut">
               <a:rPr lang="en-US" dirty="0"/>
-              <a:t>1/20/2026</a:t>
+              <a:t>1/24/2026</a:t>
             </a:fld>
             <a:endParaRPr lang="en-US" dirty="0"/>
           </a:p>
@@ -9432,7 +9632,7 @@
           <a:p>
             <a:fld id="{4509A250-FF31-4206-8172-F9D3106AACB1}" type="datetimeFigureOut">
               <a:rPr lang="en-US" dirty="0"/>
-              <a:t>1/20/2026</a:t>
+              <a:t>1/24/2026</a:t>
             </a:fld>
             <a:endParaRPr lang="en-US" dirty="0"/>
           </a:p>
@@ -9597,7 +9797,7 @@
           <a:p>
             <a:fld id="{4509A250-FF31-4206-8172-F9D3106AACB1}" type="datetimeFigureOut">
               <a:rPr lang="en-US" dirty="0"/>
-              <a:t>1/20/2026</a:t>
+              <a:t>1/24/2026</a:t>
             </a:fld>
             <a:endParaRPr lang="en-US" dirty="0"/>
           </a:p>
@@ -9772,7 +9972,7 @@
           <a:p>
             <a:fld id="{4509A250-FF31-4206-8172-F9D3106AACB1}" type="datetimeFigureOut">
               <a:rPr lang="en-US" dirty="0"/>
-              <a:t>1/20/2026</a:t>
+              <a:t>1/24/2026</a:t>
             </a:fld>
             <a:endParaRPr lang="en-US" dirty="0"/>
           </a:p>
@@ -9937,7 +10137,7 @@
           <a:p>
             <a:fld id="{4509A250-FF31-4206-8172-F9D3106AACB1}" type="datetimeFigureOut">
               <a:rPr lang="en-US" dirty="0"/>
-              <a:t>1/20/2026</a:t>
+              <a:t>1/24/2026</a:t>
             </a:fld>
             <a:endParaRPr lang="en-US" dirty="0"/>
           </a:p>
@@ -10176,7 +10376,7 @@
           <a:p>
             <a:fld id="{4509A250-FF31-4206-8172-F9D3106AACB1}" type="datetimeFigureOut">
               <a:rPr lang="en-US" dirty="0"/>
-              <a:t>1/20/2026</a:t>
+              <a:t>1/24/2026</a:t>
             </a:fld>
             <a:endParaRPr lang="en-US" dirty="0"/>
           </a:p>
@@ -10463,7 +10663,7 @@
           <a:p>
             <a:fld id="{4509A250-FF31-4206-8172-F9D3106AACB1}" type="datetimeFigureOut">
               <a:rPr lang="en-US" dirty="0"/>
-              <a:t>1/20/2026</a:t>
+              <a:t>1/24/2026</a:t>
             </a:fld>
             <a:endParaRPr lang="en-US" dirty="0"/>
           </a:p>
@@ -10896,7 +11096,7 @@
           <a:p>
             <a:fld id="{4509A250-FF31-4206-8172-F9D3106AACB1}" type="datetimeFigureOut">
               <a:rPr lang="en-US" dirty="0"/>
-              <a:t>1/20/2026</a:t>
+              <a:t>1/24/2026</a:t>
             </a:fld>
             <a:endParaRPr lang="en-US" dirty="0"/>
           </a:p>
@@ -11009,7 +11209,7 @@
           <a:p>
             <a:fld id="{4509A250-FF31-4206-8172-F9D3106AACB1}" type="datetimeFigureOut">
               <a:rPr lang="en-US" dirty="0"/>
-              <a:t>1/20/2026</a:t>
+              <a:t>1/24/2026</a:t>
             </a:fld>
             <a:endParaRPr lang="en-US" dirty="0"/>
           </a:p>
@@ -11099,7 +11299,7 @@
           <a:p>
             <a:fld id="{4509A250-FF31-4206-8172-F9D3106AACB1}" type="datetimeFigureOut">
               <a:rPr lang="en-US" dirty="0"/>
-              <a:t>1/20/2026</a:t>
+              <a:t>1/24/2026</a:t>
             </a:fld>
             <a:endParaRPr lang="en-US" dirty="0"/>
           </a:p>
@@ -11373,7 +11573,7 @@
           <a:p>
             <a:fld id="{4509A250-FF31-4206-8172-F9D3106AACB1}" type="datetimeFigureOut">
               <a:rPr lang="en-US" dirty="0"/>
-              <a:t>1/20/2026</a:t>
+              <a:t>1/24/2026</a:t>
             </a:fld>
             <a:endParaRPr lang="en-US" dirty="0"/>
           </a:p>
@@ -11643,7 +11843,7 @@
           <a:p>
             <a:fld id="{4509A250-FF31-4206-8172-F9D3106AACB1}" type="datetimeFigureOut">
               <a:rPr lang="en-US" dirty="0"/>
-              <a:t>1/20/2026</a:t>
+              <a:t>1/24/2026</a:t>
             </a:fld>
             <a:endParaRPr lang="en-US" dirty="0"/>
           </a:p>
@@ -12081,7 +12281,7 @@
           <a:p>
             <a:fld id="{4509A250-FF31-4206-8172-F9D3106AACB1}" type="datetimeFigureOut">
               <a:rPr lang="en-US" dirty="0"/>
-              <a:t>1/20/2026</a:t>
+              <a:t>1/24/2026</a:t>
             </a:fld>
             <a:endParaRPr lang="en-US" dirty="0"/>
           </a:p>
@@ -12564,6 +12764,180 @@
 <file path=ppt/slides/slide1.xml><?xml version="1.0" encoding="utf-8"?>
 <p:sld xmlns:a="http://schemas.openxmlformats.org/drawingml/2006/main" xmlns:r="http://schemas.openxmlformats.org/officeDocument/2006/relationships" xmlns:p="http://schemas.openxmlformats.org/presentationml/2006/main">
   <p:cSld>
+    <p:spTree>
+      <p:nvGrpSpPr>
+        <p:cNvPr id="1" name="">
+          <a:extLst>
+            <a:ext uri="{FF2B5EF4-FFF2-40B4-BE49-F238E27FC236}">
+              <a16:creationId xmlns:a16="http://schemas.microsoft.com/office/drawing/2014/main" id="{0CC0224E-FBBF-DCF2-BCE0-F89D770B9121}"/>
+            </a:ext>
+          </a:extLst>
+        </p:cNvPr>
+        <p:cNvGrpSpPr/>
+        <p:nvPr/>
+      </p:nvGrpSpPr>
+      <p:grpSpPr>
+        <a:xfrm>
+          <a:off x="0" y="0"/>
+          <a:ext cx="0" cy="0"/>
+          <a:chOff x="0" y="0"/>
+          <a:chExt cx="0" cy="0"/>
+        </a:xfrm>
+      </p:grpSpPr>
+      <p:pic>
+        <p:nvPicPr>
+          <p:cNvPr id="5" name="Picture 4" descr="chain links">
+            <a:extLst>
+              <a:ext uri="{FF2B5EF4-FFF2-40B4-BE49-F238E27FC236}">
+                <a16:creationId xmlns:a16="http://schemas.microsoft.com/office/drawing/2014/main" id="{DD2F1915-0578-BFD3-9A84-EC539FE67EA3}"/>
+              </a:ext>
+            </a:extLst>
+          </p:cNvPr>
+          <p:cNvPicPr>
+            <a:picLocks noChangeAspect="1"/>
+          </p:cNvPicPr>
+          <p:nvPr/>
+        </p:nvPicPr>
+        <p:blipFill rotWithShape="1">
+          <a:blip r:embed="rId3">
+            <a:duotone>
+              <a:prstClr val="black"/>
+              <a:schemeClr val="accent5">
+                <a:tint val="45000"/>
+                <a:satMod val="400000"/>
+              </a:schemeClr>
+            </a:duotone>
+            <a:alphaModFix amt="25000"/>
+          </a:blip>
+          <a:srcRect t="23391" r="9091"/>
+          <a:stretch/>
+        </p:blipFill>
+        <p:spPr>
+          <a:xfrm>
+            <a:off x="0" y="10"/>
+            <a:ext cx="12191980" cy="6857990"/>
+          </a:xfrm>
+          <a:prstGeom prst="rect">
+            <a:avLst/>
+          </a:prstGeom>
+        </p:spPr>
+      </p:pic>
+      <p:pic>
+        <p:nvPicPr>
+          <p:cNvPr id="11" name="Picture 10" descr="A white circle with a blue circle with a blue circle with a blue circle with a white circle with a blue circle with a blue circle with a white circle with a blue circle with a blue circle&#10;&#10;AI-generated content may be incorrect.">
+            <a:extLst>
+              <a:ext uri="{FF2B5EF4-FFF2-40B4-BE49-F238E27FC236}">
+                <a16:creationId xmlns:a16="http://schemas.microsoft.com/office/drawing/2014/main" id="{0F598311-938F-38BB-7988-5E42EF16CBD5}"/>
+              </a:ext>
+            </a:extLst>
+          </p:cNvPr>
+          <p:cNvPicPr>
+            <a:picLocks noChangeAspect="1"/>
+          </p:cNvPicPr>
+          <p:nvPr/>
+        </p:nvPicPr>
+        <p:blipFill>
+          <a:blip r:embed="rId4"/>
+          <a:stretch>
+            <a:fillRect/>
+          </a:stretch>
+        </p:blipFill>
+        <p:spPr>
+          <a:xfrm>
+            <a:off x="3661894" y="1055718"/>
+            <a:ext cx="5675290" cy="3424467"/>
+          </a:xfrm>
+          <a:prstGeom prst="rect">
+            <a:avLst/>
+          </a:prstGeom>
+          <a:ln>
+            <a:noFill/>
+          </a:ln>
+          <a:effectLst>
+            <a:softEdge rad="112500"/>
+          </a:effectLst>
+        </p:spPr>
+      </p:pic>
+      <p:sp>
+        <p:nvSpPr>
+          <p:cNvPr id="2" name="Title 1">
+            <a:extLst>
+              <a:ext uri="{FF2B5EF4-FFF2-40B4-BE49-F238E27FC236}">
+                <a16:creationId xmlns:a16="http://schemas.microsoft.com/office/drawing/2014/main" id="{33C9C9B5-0B44-AD56-606E-CF46AAE42647}"/>
+              </a:ext>
+            </a:extLst>
+          </p:cNvPr>
+          <p:cNvSpPr>
+            <a:spLocks noGrp="1"/>
+          </p:cNvSpPr>
+          <p:nvPr>
+            <p:ph type="ctrTitle"/>
+          </p:nvPr>
+        </p:nvSpPr>
+        <p:spPr>
+          <a:xfrm>
+            <a:off x="217749" y="205956"/>
+            <a:ext cx="7602064" cy="1266497"/>
+          </a:xfrm>
+        </p:spPr>
+        <p:txBody>
+          <a:bodyPr anchor="ctr">
+            <a:normAutofit/>
+          </a:bodyPr>
+          <a:lstStyle/>
+          <a:p>
+            <a:r>
+              <a:rPr lang="en-US" altLang="zh-CN" sz="6000" b="1" dirty="0"/>
+              <a:t>Learn Next.js</a:t>
+            </a:r>
+            <a:endParaRPr lang="ru-RU" sz="6000" b="1" dirty="0"/>
+          </a:p>
+        </p:txBody>
+      </p:sp>
+      <p:graphicFrame>
+        <p:nvGraphicFramePr>
+          <p:cNvPr id="12" name="Diagram 11">
+            <a:extLst>
+              <a:ext uri="{FF2B5EF4-FFF2-40B4-BE49-F238E27FC236}">
+                <a16:creationId xmlns:a16="http://schemas.microsoft.com/office/drawing/2014/main" id="{0BA4EC0A-CB15-D8BB-A5A0-B712501C96D3}"/>
+              </a:ext>
+            </a:extLst>
+          </p:cNvPr>
+          <p:cNvGraphicFramePr/>
+          <p:nvPr>
+            <p:extLst>
+              <p:ext uri="{D42A27DB-BD31-4B8C-83A1-F6EECF244321}">
+                <p14:modId xmlns:p14="http://schemas.microsoft.com/office/powerpoint/2010/main" val="380498904"/>
+              </p:ext>
+            </p:extLst>
+          </p:nvPr>
+        </p:nvGraphicFramePr>
+        <p:xfrm>
+          <a:off x="652530" y="4211392"/>
+          <a:ext cx="10985677" cy="2155063"/>
+        </p:xfrm>
+        <a:graphic>
+          <a:graphicData uri="http://schemas.openxmlformats.org/drawingml/2006/diagram">
+            <dgm:relIds xmlns:dgm="http://schemas.openxmlformats.org/drawingml/2006/diagram" xmlns:r="http://schemas.openxmlformats.org/officeDocument/2006/relationships" r:dm="rId5" r:lo="rId6" r:qs="rId7" r:cs="rId8"/>
+          </a:graphicData>
+        </a:graphic>
+      </p:graphicFrame>
+    </p:spTree>
+    <p:extLst>
+      <p:ext uri="{BB962C8B-B14F-4D97-AF65-F5344CB8AC3E}">
+        <p14:creationId xmlns:p14="http://schemas.microsoft.com/office/powerpoint/2010/main" val="3303699240"/>
+      </p:ext>
+    </p:extLst>
+  </p:cSld>
+  <p:clrMapOvr>
+    <a:masterClrMapping/>
+  </p:clrMapOvr>
+</p:sld>
+</file>
+
+<file path=ppt/slides/slide2.xml><?xml version="1.0" encoding="utf-8"?>
+<p:sld xmlns:a="http://schemas.openxmlformats.org/drawingml/2006/main" xmlns:r="http://schemas.openxmlformats.org/officeDocument/2006/relationships" xmlns:p="http://schemas.openxmlformats.org/presentationml/2006/main">
+  <p:cSld>
     <p:bg>
       <p:bgPr>
         <a:blipFill rotWithShape="1">
@@ -13145,7 +13519,7 @@
         </p:nvSpPr>
         <p:spPr>
           <a:xfrm>
-            <a:off x="6816859" y="2915811"/>
+            <a:off x="6816859" y="2042508"/>
             <a:ext cx="4897822" cy="1266497"/>
           </a:xfrm>
         </p:spPr>
@@ -13235,7 +13609,7 @@
 </p:sld>
 </file>
 
-<file path=ppt/slides/slide2.xml><?xml version="1.0" encoding="utf-8"?>
+<file path=ppt/slides/slide3.xml><?xml version="1.0" encoding="utf-8"?>
 <p:sld xmlns:a="http://schemas.openxmlformats.org/drawingml/2006/main" xmlns:r="http://schemas.openxmlformats.org/officeDocument/2006/relationships" xmlns:p="http://schemas.openxmlformats.org/presentationml/2006/main">
   <p:cSld>
     <p:spTree>
@@ -13314,21 +13688,21 @@
         </p:nvSpPr>
         <p:spPr>
           <a:xfrm>
-            <a:off x="5065160" y="2139720"/>
+            <a:off x="5065159" y="1398922"/>
             <a:ext cx="7011227" cy="788415"/>
           </a:xfrm>
         </p:spPr>
         <p:txBody>
           <a:bodyPr>
-            <a:normAutofit/>
+            <a:normAutofit lnSpcReduction="10000"/>
           </a:bodyPr>
           <a:lstStyle/>
           <a:p>
             <a:r>
-              <a:rPr lang="en-US" altLang="zh-CN" sz="4400" b="1" dirty="0"/>
+              <a:rPr lang="en-US" altLang="zh-CN" sz="4800" b="1" dirty="0"/>
               <a:t>1. Getting Started</a:t>
             </a:r>
-            <a:endParaRPr lang="en-US" sz="4400" b="1" dirty="0"/>
+            <a:endParaRPr lang="en-US" sz="4800" b="1" dirty="0"/>
           </a:p>
         </p:txBody>
       </p:sp>
@@ -13348,7 +13722,7 @@
         </p:nvSpPr>
         <p:spPr>
           <a:xfrm>
-            <a:off x="4731248" y="0"/>
+            <a:off x="8570773" y="2419"/>
             <a:ext cx="2102069" cy="1447801"/>
           </a:xfrm>
           <a:prstGeom prst="rect">
@@ -13697,8 +14071,8 @@
         </p:nvSpPr>
         <p:spPr>
           <a:xfrm>
-            <a:off x="4474323" y="961696"/>
-            <a:ext cx="7602064" cy="1266497"/>
+            <a:off x="4011986" y="30293"/>
+            <a:ext cx="4741596" cy="1266497"/>
           </a:xfrm>
         </p:spPr>
         <p:txBody>
@@ -13717,10 +14091,10 @@
       </p:sp>
       <p:pic>
         <p:nvPicPr>
-          <p:cNvPr id="12" name="Picture 11">
+          <p:cNvPr id="8" name="Picture 7">
             <a:extLst>
               <a:ext uri="{FF2B5EF4-FFF2-40B4-BE49-F238E27FC236}">
-                <a16:creationId xmlns:a16="http://schemas.microsoft.com/office/drawing/2014/main" id="{A8CD8F92-5A26-6FA0-40AF-B8E58D2B6D9A}"/>
+                <a16:creationId xmlns:a16="http://schemas.microsoft.com/office/drawing/2014/main" id="{9DB10A20-E426-E955-9570-E22A7E2EE97E}"/>
               </a:ext>
             </a:extLst>
           </p:cNvPr>
@@ -13737,8 +14111,8 @@
         </p:blipFill>
         <p:spPr>
           <a:xfrm>
-            <a:off x="176129" y="2490518"/>
-            <a:ext cx="8596387" cy="4005009"/>
+            <a:off x="226031" y="2090603"/>
+            <a:ext cx="8897420" cy="4413955"/>
           </a:xfrm>
           <a:prstGeom prst="roundRect">
             <a:avLst>
@@ -13782,7 +14156,7 @@
 </p:sld>
 </file>
 
-<file path=ppt/slides/slide3.xml><?xml version="1.0" encoding="utf-8"?>
+<file path=ppt/slides/slide4.xml><?xml version="1.0" encoding="utf-8"?>
 <p:sld xmlns:a="http://schemas.openxmlformats.org/drawingml/2006/main" xmlns:r="http://schemas.openxmlformats.org/officeDocument/2006/relationships" xmlns:p="http://schemas.openxmlformats.org/presentationml/2006/main">
   <p:cSld>
     <p:spTree>
@@ -13790,7 +14164,7 @@
         <p:cNvPr id="1" name="">
           <a:extLst>
             <a:ext uri="{FF2B5EF4-FFF2-40B4-BE49-F238E27FC236}">
-              <a16:creationId xmlns:a16="http://schemas.microsoft.com/office/drawing/2014/main" id="{0CC0224E-FBBF-DCF2-BCE0-F89D770B9121}"/>
+              <a16:creationId xmlns:a16="http://schemas.microsoft.com/office/drawing/2014/main" id="{C1888C70-013E-E4B0-35AC-B37FDF955590}"/>
             </a:ext>
           </a:extLst>
         </p:cNvPr>
@@ -13810,7 +14184,7 @@
           <p:cNvPr id="5" name="Picture 4" descr="chain links">
             <a:extLst>
               <a:ext uri="{FF2B5EF4-FFF2-40B4-BE49-F238E27FC236}">
-                <a16:creationId xmlns:a16="http://schemas.microsoft.com/office/drawing/2014/main" id="{DD2F1915-0578-BFD3-9A84-EC539FE67EA3}"/>
+                <a16:creationId xmlns:a16="http://schemas.microsoft.com/office/drawing/2014/main" id="{303AF50B-B741-6B45-E1EA-64FFED3E2841}"/>
               </a:ext>
             </a:extLst>
           </p:cNvPr>
@@ -13843,12 +14217,300 @@
           </a:prstGeom>
         </p:spPr>
       </p:pic>
+      <p:sp>
+        <p:nvSpPr>
+          <p:cNvPr id="3" name="Subtitle 2">
+            <a:extLst>
+              <a:ext uri="{FF2B5EF4-FFF2-40B4-BE49-F238E27FC236}">
+                <a16:creationId xmlns:a16="http://schemas.microsoft.com/office/drawing/2014/main" id="{1614207A-E840-8E82-6644-D8AECCEA0E4C}"/>
+              </a:ext>
+            </a:extLst>
+          </p:cNvPr>
+          <p:cNvSpPr>
+            <a:spLocks noGrp="1"/>
+          </p:cNvSpPr>
+          <p:nvPr>
+            <p:ph type="subTitle" idx="1"/>
+          </p:nvPr>
+        </p:nvSpPr>
+        <p:spPr>
+          <a:xfrm>
+            <a:off x="5065159" y="1398922"/>
+            <a:ext cx="7011227" cy="788415"/>
+          </a:xfrm>
+        </p:spPr>
+        <p:txBody>
+          <a:bodyPr>
+            <a:normAutofit lnSpcReduction="10000"/>
+          </a:bodyPr>
+          <a:lstStyle/>
+          <a:p>
+            <a:r>
+              <a:rPr lang="en-US" altLang="zh-CN" sz="4800" b="1" dirty="0"/>
+              <a:t>2. CSS Styling</a:t>
+            </a:r>
+            <a:endParaRPr lang="en-US" sz="4800" b="1" dirty="0"/>
+          </a:p>
+        </p:txBody>
+      </p:sp>
+      <p:sp>
+        <p:nvSpPr>
+          <p:cNvPr id="7" name="Subtitle 2">
+            <a:extLst>
+              <a:ext uri="{FF2B5EF4-FFF2-40B4-BE49-F238E27FC236}">
+                <a16:creationId xmlns:a16="http://schemas.microsoft.com/office/drawing/2014/main" id="{4821D0EE-231E-E66E-3862-EEA8A7AB3567}"/>
+              </a:ext>
+            </a:extLst>
+          </p:cNvPr>
+          <p:cNvSpPr txBox="1">
+            <a:spLocks/>
+          </p:cNvSpPr>
+          <p:nvPr/>
+        </p:nvSpPr>
+        <p:spPr>
+          <a:xfrm>
+            <a:off x="8570773" y="2419"/>
+            <a:ext cx="2102069" cy="1447801"/>
+          </a:xfrm>
+          <a:prstGeom prst="rect">
+            <a:avLst/>
+          </a:prstGeom>
+        </p:spPr>
+        <p:txBody>
+          <a:bodyPr vert="horz" lIns="91440" tIns="45720" rIns="91440" bIns="45720" rtlCol="0" anchor="ctr">
+            <a:normAutofit fontScale="92500" lnSpcReduction="20000"/>
+          </a:bodyPr>
+          <a:lstStyle>
+            <a:lvl1pPr marL="0" indent="0" algn="l" defTabSz="457200" rtl="0" eaLnBrk="1" latinLnBrk="0" hangingPunct="1">
+              <a:spcBef>
+                <a:spcPts val="1000"/>
+              </a:spcBef>
+              <a:spcAft>
+                <a:spcPts val="0"/>
+              </a:spcAft>
+              <a:buClr>
+                <a:schemeClr val="accent1"/>
+              </a:buClr>
+              <a:buSzPct val="80000"/>
+              <a:buFont typeface="Wingdings 3" charset="2"/>
+              <a:buNone/>
+              <a:defRPr sz="2000" b="0" i="0" kern="1200" cap="all">
+                <a:solidFill>
+                  <a:schemeClr val="accent1"/>
+                </a:solidFill>
+                <a:latin typeface="+mj-lt"/>
+                <a:ea typeface="+mj-ea"/>
+                <a:cs typeface="+mj-cs"/>
+              </a:defRPr>
+            </a:lvl1pPr>
+            <a:lvl2pPr marL="457200" indent="0" algn="ctr" defTabSz="457200" rtl="0" eaLnBrk="1" latinLnBrk="0" hangingPunct="1">
+              <a:spcBef>
+                <a:spcPts val="1000"/>
+              </a:spcBef>
+              <a:spcAft>
+                <a:spcPts val="0"/>
+              </a:spcAft>
+              <a:buClr>
+                <a:schemeClr val="accent1"/>
+              </a:buClr>
+              <a:buSzPct val="80000"/>
+              <a:buFont typeface="Wingdings 3" charset="2"/>
+              <a:buNone/>
+              <a:defRPr sz="1800" b="0" i="0" kern="1200">
+                <a:solidFill>
+                  <a:schemeClr val="tx1">
+                    <a:tint val="75000"/>
+                  </a:schemeClr>
+                </a:solidFill>
+                <a:latin typeface="+mj-lt"/>
+                <a:ea typeface="+mj-ea"/>
+                <a:cs typeface="+mj-cs"/>
+              </a:defRPr>
+            </a:lvl2pPr>
+            <a:lvl3pPr marL="914400" indent="0" algn="ctr" defTabSz="457200" rtl="0" eaLnBrk="1" latinLnBrk="0" hangingPunct="1">
+              <a:spcBef>
+                <a:spcPts val="1000"/>
+              </a:spcBef>
+              <a:spcAft>
+                <a:spcPts val="0"/>
+              </a:spcAft>
+              <a:buClr>
+                <a:schemeClr val="accent1"/>
+              </a:buClr>
+              <a:buSzPct val="80000"/>
+              <a:buFont typeface="Wingdings 3" charset="2"/>
+              <a:buNone/>
+              <a:defRPr sz="1600" b="0" i="0" kern="1200">
+                <a:solidFill>
+                  <a:schemeClr val="tx1">
+                    <a:tint val="75000"/>
+                  </a:schemeClr>
+                </a:solidFill>
+                <a:latin typeface="+mj-lt"/>
+                <a:ea typeface="+mj-ea"/>
+                <a:cs typeface="+mj-cs"/>
+              </a:defRPr>
+            </a:lvl3pPr>
+            <a:lvl4pPr marL="1371600" indent="0" algn="ctr" defTabSz="457200" rtl="0" eaLnBrk="1" latinLnBrk="0" hangingPunct="1">
+              <a:spcBef>
+                <a:spcPts val="1000"/>
+              </a:spcBef>
+              <a:spcAft>
+                <a:spcPts val="0"/>
+              </a:spcAft>
+              <a:buClr>
+                <a:schemeClr val="accent1"/>
+              </a:buClr>
+              <a:buSzPct val="80000"/>
+              <a:buFont typeface="Wingdings 3" charset="2"/>
+              <a:buNone/>
+              <a:defRPr sz="1400" b="0" i="0" kern="1200">
+                <a:solidFill>
+                  <a:schemeClr val="tx1">
+                    <a:tint val="75000"/>
+                  </a:schemeClr>
+                </a:solidFill>
+                <a:latin typeface="+mj-lt"/>
+                <a:ea typeface="+mj-ea"/>
+                <a:cs typeface="+mj-cs"/>
+              </a:defRPr>
+            </a:lvl4pPr>
+            <a:lvl5pPr marL="1828800" indent="0" algn="ctr" defTabSz="457200" rtl="0" eaLnBrk="1" latinLnBrk="0" hangingPunct="1">
+              <a:spcBef>
+                <a:spcPts val="1000"/>
+              </a:spcBef>
+              <a:spcAft>
+                <a:spcPts val="0"/>
+              </a:spcAft>
+              <a:buClr>
+                <a:schemeClr val="accent1"/>
+              </a:buClr>
+              <a:buSzPct val="80000"/>
+              <a:buFont typeface="Wingdings 3" charset="2"/>
+              <a:buNone/>
+              <a:defRPr sz="1400" b="0" i="0" kern="1200">
+                <a:solidFill>
+                  <a:schemeClr val="tx1">
+                    <a:tint val="75000"/>
+                  </a:schemeClr>
+                </a:solidFill>
+                <a:latin typeface="+mj-lt"/>
+                <a:ea typeface="+mj-ea"/>
+                <a:cs typeface="+mj-cs"/>
+              </a:defRPr>
+            </a:lvl5pPr>
+            <a:lvl6pPr marL="2286000" indent="0" algn="ctr" defTabSz="457200" rtl="0" eaLnBrk="1" latinLnBrk="0" hangingPunct="1">
+              <a:spcBef>
+                <a:spcPts val="1000"/>
+              </a:spcBef>
+              <a:spcAft>
+                <a:spcPts val="0"/>
+              </a:spcAft>
+              <a:buClr>
+                <a:schemeClr val="accent1"/>
+              </a:buClr>
+              <a:buSzPct val="80000"/>
+              <a:buFont typeface="Wingdings 3" charset="2"/>
+              <a:buNone/>
+              <a:defRPr sz="1400" b="0" i="0" kern="1200">
+                <a:solidFill>
+                  <a:schemeClr val="tx1">
+                    <a:tint val="75000"/>
+                  </a:schemeClr>
+                </a:solidFill>
+                <a:latin typeface="+mj-lt"/>
+                <a:ea typeface="+mj-ea"/>
+                <a:cs typeface="+mj-cs"/>
+              </a:defRPr>
+            </a:lvl6pPr>
+            <a:lvl7pPr marL="2743200" indent="0" algn="ctr" defTabSz="457200" rtl="0" eaLnBrk="1" latinLnBrk="0" hangingPunct="1">
+              <a:spcBef>
+                <a:spcPts val="1000"/>
+              </a:spcBef>
+              <a:spcAft>
+                <a:spcPts val="0"/>
+              </a:spcAft>
+              <a:buClr>
+                <a:schemeClr val="accent1"/>
+              </a:buClr>
+              <a:buSzPct val="80000"/>
+              <a:buFont typeface="Wingdings 3" charset="2"/>
+              <a:buNone/>
+              <a:defRPr sz="1400" b="0" i="0" kern="1200">
+                <a:solidFill>
+                  <a:schemeClr val="tx1">
+                    <a:tint val="75000"/>
+                  </a:schemeClr>
+                </a:solidFill>
+                <a:latin typeface="+mj-lt"/>
+                <a:ea typeface="+mj-ea"/>
+                <a:cs typeface="+mj-cs"/>
+              </a:defRPr>
+            </a:lvl7pPr>
+            <a:lvl8pPr marL="3200400" indent="0" algn="ctr" defTabSz="457200" rtl="0" eaLnBrk="1" latinLnBrk="0" hangingPunct="1">
+              <a:spcBef>
+                <a:spcPts val="1000"/>
+              </a:spcBef>
+              <a:spcAft>
+                <a:spcPts val="0"/>
+              </a:spcAft>
+              <a:buClr>
+                <a:schemeClr val="accent1"/>
+              </a:buClr>
+              <a:buSzPct val="80000"/>
+              <a:buFont typeface="Wingdings 3" charset="2"/>
+              <a:buNone/>
+              <a:defRPr sz="1400" b="0" i="0" kern="1200">
+                <a:solidFill>
+                  <a:schemeClr val="tx1">
+                    <a:tint val="75000"/>
+                  </a:schemeClr>
+                </a:solidFill>
+                <a:latin typeface="+mj-lt"/>
+                <a:ea typeface="+mj-ea"/>
+                <a:cs typeface="+mj-cs"/>
+              </a:defRPr>
+            </a:lvl8pPr>
+            <a:lvl9pPr marL="3657600" indent="0" algn="ctr" defTabSz="457200" rtl="0" eaLnBrk="1" latinLnBrk="0" hangingPunct="1">
+              <a:spcBef>
+                <a:spcPts val="1000"/>
+              </a:spcBef>
+              <a:spcAft>
+                <a:spcPts val="0"/>
+              </a:spcAft>
+              <a:buClr>
+                <a:schemeClr val="accent1"/>
+              </a:buClr>
+              <a:buSzPct val="80000"/>
+              <a:buFont typeface="Wingdings 3" charset="2"/>
+              <a:buNone/>
+              <a:defRPr sz="1400" b="0" i="0" kern="1200">
+                <a:solidFill>
+                  <a:schemeClr val="tx1">
+                    <a:tint val="75000"/>
+                  </a:schemeClr>
+                </a:solidFill>
+                <a:latin typeface="+mj-lt"/>
+                <a:ea typeface="+mj-ea"/>
+                <a:cs typeface="+mj-cs"/>
+              </a:defRPr>
+            </a:lvl9pPr>
+          </a:lstStyle>
+          <a:p>
+            <a:pPr algn="ctr"/>
+            <a:r>
+              <a:rPr lang="en-US" sz="11500" b="1" dirty="0"/>
+              <a:t>01</a:t>
+            </a:r>
+          </a:p>
+        </p:txBody>
+      </p:sp>
       <p:pic>
         <p:nvPicPr>
-          <p:cNvPr id="11" name="Picture 10" descr="A white circle with a blue circle with a blue circle with a blue circle with a white circle with a blue circle with a blue circle with a white circle with a blue circle with a blue circle&#10;&#10;AI-generated content may be incorrect.">
+          <p:cNvPr id="4" name="Picture 3">
             <a:extLst>
               <a:ext uri="{FF2B5EF4-FFF2-40B4-BE49-F238E27FC236}">
-                <a16:creationId xmlns:a16="http://schemas.microsoft.com/office/drawing/2014/main" id="{0F598311-938F-38BB-7988-5E42EF16CBD5}"/>
+                <a16:creationId xmlns:a16="http://schemas.microsoft.com/office/drawing/2014/main" id="{D9340BB6-8185-95AC-92A3-8179751E9899}"/>
               </a:ext>
             </a:extLst>
           </p:cNvPr>
@@ -13865,8 +14527,8 @@
         </p:blipFill>
         <p:spPr>
           <a:xfrm>
-            <a:off x="3661894" y="1055718"/>
-            <a:ext cx="5675290" cy="3424467"/>
+            <a:off x="0" y="0"/>
+            <a:ext cx="5065160" cy="3226085"/>
           </a:xfrm>
           <a:prstGeom prst="rect">
             <a:avLst/>
@@ -13879,12 +14541,71 @@
           </a:effectLst>
         </p:spPr>
       </p:pic>
+      <p:pic>
+        <p:nvPicPr>
+          <p:cNvPr id="10" name="Picture 9">
+            <a:extLst>
+              <a:ext uri="{FF2B5EF4-FFF2-40B4-BE49-F238E27FC236}">
+                <a16:creationId xmlns:a16="http://schemas.microsoft.com/office/drawing/2014/main" id="{3A60BBC2-DFE3-3D7D-77C2-E41099BA84A4}"/>
+              </a:ext>
+            </a:extLst>
+          </p:cNvPr>
+          <p:cNvPicPr>
+            <a:picLocks noChangeAspect="1"/>
+          </p:cNvPicPr>
+          <p:nvPr/>
+        </p:nvPicPr>
+        <p:blipFill>
+          <a:blip r:embed="rId5"/>
+          <a:stretch>
+            <a:fillRect/>
+          </a:stretch>
+        </p:blipFill>
+        <p:spPr>
+          <a:xfrm>
+            <a:off x="10078948" y="5619964"/>
+            <a:ext cx="2150828" cy="988692"/>
+          </a:xfrm>
+          <a:prstGeom prst="rect">
+            <a:avLst/>
+          </a:prstGeom>
+          <a:solidFill>
+            <a:srgbClr val="FFFFFF">
+              <a:shade val="85000"/>
+            </a:srgbClr>
+          </a:solidFill>
+          <a:ln w="190500" cap="rnd">
+            <a:solidFill>
+              <a:srgbClr val="FFFFFF"/>
+            </a:solidFill>
+          </a:ln>
+          <a:effectLst>
+            <a:outerShdw blurRad="36195" dist="12700" dir="11400000" algn="tl" rotWithShape="0">
+              <a:srgbClr val="000000">
+                <a:alpha val="33000"/>
+              </a:srgbClr>
+            </a:outerShdw>
+          </a:effectLst>
+          <a:scene3d>
+            <a:camera prst="perspectiveContrastingLeftFacing">
+              <a:rot lat="540000" lon="2100000" rev="0"/>
+            </a:camera>
+            <a:lightRig rig="soft" dir="t"/>
+          </a:scene3d>
+          <a:sp3d contourW="12700" prstMaterial="matte">
+            <a:bevelT w="63500" h="50800"/>
+            <a:contourClr>
+              <a:srgbClr val="C0C0C0"/>
+            </a:contourClr>
+          </a:sp3d>
+        </p:spPr>
+      </p:pic>
       <p:sp>
         <p:nvSpPr>
           <p:cNvPr id="2" name="Title 1">
             <a:extLst>
               <a:ext uri="{FF2B5EF4-FFF2-40B4-BE49-F238E27FC236}">
-                <a16:creationId xmlns:a16="http://schemas.microsoft.com/office/drawing/2014/main" id="{33C9C9B5-0B44-AD56-606E-CF46AAE42647}"/>
+                <a16:creationId xmlns:a16="http://schemas.microsoft.com/office/drawing/2014/main" id="{AC7B7C93-BCED-F10C-E31D-56BDA9728641}"/>
               </a:ext>
             </a:extLst>
           </p:cNvPr>
@@ -13897,8 +14618,8 @@
         </p:nvSpPr>
         <p:spPr>
           <a:xfrm>
-            <a:off x="344498" y="575330"/>
-            <a:ext cx="7602064" cy="1266497"/>
+            <a:off x="4011986" y="30293"/>
+            <a:ext cx="4741596" cy="1266497"/>
           </a:xfrm>
         </p:spPr>
         <p:txBody>
@@ -13908,45 +14629,17 @@
           <a:lstStyle/>
           <a:p>
             <a:r>
-              <a:rPr lang="en-US" altLang="zh-CN" sz="6000" b="1" dirty="0"/>
-              <a:t>Learn Next.js</a:t>
+              <a:rPr lang="en-US" sz="6000" b="1" dirty="0"/>
+              <a:t>App Router</a:t>
             </a:r>
             <a:endParaRPr lang="ru-RU" sz="6000" b="1" dirty="0"/>
           </a:p>
         </p:txBody>
       </p:sp>
-      <p:graphicFrame>
-        <p:nvGraphicFramePr>
-          <p:cNvPr id="12" name="Diagram 11">
-            <a:extLst>
-              <a:ext uri="{FF2B5EF4-FFF2-40B4-BE49-F238E27FC236}">
-                <a16:creationId xmlns:a16="http://schemas.microsoft.com/office/drawing/2014/main" id="{0BA4EC0A-CB15-D8BB-A5A0-B712501C96D3}"/>
-              </a:ext>
-            </a:extLst>
-          </p:cNvPr>
-          <p:cNvGraphicFramePr/>
-          <p:nvPr>
-            <p:extLst>
-              <p:ext uri="{D42A27DB-BD31-4B8C-83A1-F6EECF244321}">
-                <p14:modId xmlns:p14="http://schemas.microsoft.com/office/powerpoint/2010/main" val="3974774323"/>
-              </p:ext>
-            </p:extLst>
-          </p:nvPr>
-        </p:nvGraphicFramePr>
-        <p:xfrm>
-          <a:off x="652530" y="4211392"/>
-          <a:ext cx="10985677" cy="2155063"/>
-        </p:xfrm>
-        <a:graphic>
-          <a:graphicData uri="http://schemas.openxmlformats.org/drawingml/2006/diagram">
-            <dgm:relIds xmlns:dgm="http://schemas.openxmlformats.org/drawingml/2006/diagram" xmlns:r="http://schemas.openxmlformats.org/officeDocument/2006/relationships" r:dm="rId5" r:lo="rId6" r:qs="rId7" r:cs="rId8"/>
-          </a:graphicData>
-        </a:graphic>
-      </p:graphicFrame>
     </p:spTree>
     <p:extLst>
       <p:ext uri="{BB962C8B-B14F-4D97-AF65-F5344CB8AC3E}">
-        <p14:creationId xmlns:p14="http://schemas.microsoft.com/office/powerpoint/2010/main" val="3303699240"/>
+        <p14:creationId xmlns:p14="http://schemas.microsoft.com/office/powerpoint/2010/main" val="1425094003"/>
       </p:ext>
     </p:extLst>
   </p:cSld>
@@ -13956,7 +14649,7 @@
 </p:sld>
 </file>
 
-<file path=ppt/slides/slide4.xml><?xml version="1.0" encoding="utf-8"?>
+<file path=ppt/slides/slide5.xml><?xml version="1.0" encoding="utf-8"?>
 <p:sld xmlns:a="http://schemas.openxmlformats.org/drawingml/2006/main" xmlns:r="http://schemas.openxmlformats.org/officeDocument/2006/relationships" xmlns:p="http://schemas.openxmlformats.org/presentationml/2006/main">
   <p:cSld>
     <p:spTree>
@@ -15088,12 +15781,12 @@
 </file>
 
 <file path=customXml/item1.xml><?xml version="1.0" encoding="utf-8"?>
-<p:properties xmlns:p="http://schemas.microsoft.com/office/2006/metadata/properties" xmlns:xsi="http://www.w3.org/2001/XMLSchema-instance" xmlns:pc="http://schemas.microsoft.com/office/infopath/2007/PartnerControls">
-  <documentManagement>
-    <Status xmlns="71af3243-3dd4-4a8d-8c0d-dd76da1f02a5">Not started</Status>
-    <MediaServiceKeyPoints xmlns="71af3243-3dd4-4a8d-8c0d-dd76da1f02a5" xsi:nil="true"/>
-  </documentManagement>
-</p:properties>
+<?mso-contentType ?>
+<FormTemplates xmlns="http://schemas.microsoft.com/sharepoint/v3/contenttype/forms">
+  <Display>DocumentLibraryForm</Display>
+  <Edit>DocumentLibraryForm</Edit>
+  <New>DocumentLibraryForm</New>
+</FormTemplates>
 </file>
 
 <file path=customXml/item2.xml><?xml version="1.0" encoding="utf-8"?>
@@ -15318,20 +16011,18 @@
 </file>
 
 <file path=customXml/item3.xml><?xml version="1.0" encoding="utf-8"?>
-<?mso-contentType ?>
-<FormTemplates xmlns="http://schemas.microsoft.com/sharepoint/v3/contenttype/forms">
-  <Display>DocumentLibraryForm</Display>
-  <Edit>DocumentLibraryForm</Edit>
-  <New>DocumentLibraryForm</New>
-</FormTemplates>
+<p:properties xmlns:p="http://schemas.microsoft.com/office/2006/metadata/properties" xmlns:xsi="http://www.w3.org/2001/XMLSchema-instance" xmlns:pc="http://schemas.microsoft.com/office/infopath/2007/PartnerControls">
+  <documentManagement>
+    <Status xmlns="71af3243-3dd4-4a8d-8c0d-dd76da1f02a5">Not started</Status>
+    <MediaServiceKeyPoints xmlns="71af3243-3dd4-4a8d-8c0d-dd76da1f02a5" xsi:nil="true"/>
+  </documentManagement>
+</p:properties>
 </file>
 
 <file path=customXml/itemProps1.xml><?xml version="1.0" encoding="utf-8"?>
-<ds:datastoreItem xmlns:ds="http://schemas.openxmlformats.org/officeDocument/2006/customXml" ds:itemID="{048C88F1-1664-415F-AFCE-F6CF45809817}">
+<ds:datastoreItem xmlns:ds="http://schemas.openxmlformats.org/officeDocument/2006/customXml" ds:itemID="{0D16958A-754B-4396-9457-FD7A427A37DD}">
   <ds:schemaRefs>
-    <ds:schemaRef ds:uri="http://schemas.microsoft.com/office/2006/metadata/properties"/>
-    <ds:schemaRef ds:uri="http://schemas.microsoft.com/office/infopath/2007/PartnerControls"/>
-    <ds:schemaRef ds:uri="71af3243-3dd4-4a8d-8c0d-dd76da1f02a5"/>
+    <ds:schemaRef ds:uri="http://schemas.microsoft.com/sharepoint/v3/contenttype/forms"/>
   </ds:schemaRefs>
 </ds:datastoreItem>
 </file>
@@ -15356,9 +16047,11 @@
 </file>
 
 <file path=customXml/itemProps3.xml><?xml version="1.0" encoding="utf-8"?>
-<ds:datastoreItem xmlns:ds="http://schemas.openxmlformats.org/officeDocument/2006/customXml" ds:itemID="{0D16958A-754B-4396-9457-FD7A427A37DD}">
+<ds:datastoreItem xmlns:ds="http://schemas.openxmlformats.org/officeDocument/2006/customXml" ds:itemID="{048C88F1-1664-415F-AFCE-F6CF45809817}">
   <ds:schemaRefs>
-    <ds:schemaRef ds:uri="http://schemas.microsoft.com/sharepoint/v3/contenttype/forms"/>
+    <ds:schemaRef ds:uri="http://schemas.microsoft.com/office/2006/metadata/properties"/>
+    <ds:schemaRef ds:uri="http://schemas.microsoft.com/office/infopath/2007/PartnerControls"/>
+    <ds:schemaRef ds:uri="71af3243-3dd4-4a8d-8c0d-dd76da1f02a5"/>
   </ds:schemaRefs>
 </ds:datastoreItem>
 </file>
</xml_diff>

<commit_message>
add ppt to repo
</commit_message>
<xml_diff>
--- a/learn_nextjs/2_App_Router/App_Router.pptx
+++ b/learn_nextjs/2_App_Router/App_Router.pptx
@@ -5,10 +5,10 @@
     <p:sldMasterId id="2147483648" r:id="rId4"/>
   </p:sldMasterIdLst>
   <p:notesMasterIdLst>
-    <p:notesMasterId r:id="rId10"/>
+    <p:notesMasterId r:id="rId11"/>
   </p:notesMasterIdLst>
   <p:handoutMasterIdLst>
-    <p:handoutMasterId r:id="rId11"/>
+    <p:handoutMasterId r:id="rId12"/>
   </p:handoutMasterIdLst>
   <p:sldIdLst>
     <p:sldId id="276" r:id="rId5"/>
@@ -16,6 +16,7 @@
     <p:sldId id="257" r:id="rId7"/>
     <p:sldId id="277" r:id="rId8"/>
     <p:sldId id="270" r:id="rId9"/>
+    <p:sldId id="278" r:id="rId10"/>
   </p:sldIdLst>
   <p:sldSz cx="12192000" cy="6858000"/>
   <p:notesSz cx="6858000" cy="9144000"/>
@@ -884,6 +885,753 @@
 </file>
 
 <file path=ppt/diagrams/colors2.xml><?xml version="1.0" encoding="utf-8"?>
+<dgm:colorsDef xmlns:dgm="http://schemas.openxmlformats.org/drawingml/2006/diagram" xmlns:a="http://schemas.openxmlformats.org/drawingml/2006/main" uniqueId="urn:microsoft.com/office/officeart/2005/8/colors/accent1_2">
+  <dgm:title val=""/>
+  <dgm:desc val=""/>
+  <dgm:catLst>
+    <dgm:cat type="accent1" pri="11200"/>
+  </dgm:catLst>
+  <dgm:styleLbl name="node0">
+    <dgm:fillClrLst meth="repeat">
+      <a:schemeClr val="accent1"/>
+    </dgm:fillClrLst>
+    <dgm:linClrLst meth="repeat">
+      <a:schemeClr val="lt1"/>
+    </dgm:linClrLst>
+    <dgm:effectClrLst/>
+    <dgm:txLinClrLst/>
+    <dgm:txFillClrLst/>
+    <dgm:txEffectClrLst/>
+  </dgm:styleLbl>
+  <dgm:styleLbl name="alignNode1">
+    <dgm:fillClrLst meth="repeat">
+      <a:schemeClr val="accent1"/>
+    </dgm:fillClrLst>
+    <dgm:linClrLst meth="repeat">
+      <a:schemeClr val="accent1"/>
+    </dgm:linClrLst>
+    <dgm:effectClrLst/>
+    <dgm:txLinClrLst/>
+    <dgm:txFillClrLst/>
+    <dgm:txEffectClrLst/>
+  </dgm:styleLbl>
+  <dgm:styleLbl name="node1">
+    <dgm:fillClrLst meth="repeat">
+      <a:schemeClr val="accent1"/>
+    </dgm:fillClrLst>
+    <dgm:linClrLst meth="repeat">
+      <a:schemeClr val="lt1"/>
+    </dgm:linClrLst>
+    <dgm:effectClrLst/>
+    <dgm:txLinClrLst/>
+    <dgm:txFillClrLst/>
+    <dgm:txEffectClrLst/>
+  </dgm:styleLbl>
+  <dgm:styleLbl name="lnNode1">
+    <dgm:fillClrLst meth="repeat">
+      <a:schemeClr val="accent1"/>
+    </dgm:fillClrLst>
+    <dgm:linClrLst meth="repeat">
+      <a:schemeClr val="lt1"/>
+    </dgm:linClrLst>
+    <dgm:effectClrLst/>
+    <dgm:txLinClrLst/>
+    <dgm:txFillClrLst/>
+    <dgm:txEffectClrLst/>
+  </dgm:styleLbl>
+  <dgm:styleLbl name="vennNode1">
+    <dgm:fillClrLst meth="repeat">
+      <a:schemeClr val="accent1">
+        <a:alpha val="50000"/>
+      </a:schemeClr>
+    </dgm:fillClrLst>
+    <dgm:linClrLst meth="repeat">
+      <a:schemeClr val="lt1"/>
+    </dgm:linClrLst>
+    <dgm:effectClrLst/>
+    <dgm:txLinClrLst/>
+    <dgm:txFillClrLst/>
+    <dgm:txEffectClrLst/>
+  </dgm:styleLbl>
+  <dgm:styleLbl name="node2">
+    <dgm:fillClrLst meth="repeat">
+      <a:schemeClr val="accent1"/>
+    </dgm:fillClrLst>
+    <dgm:linClrLst meth="repeat">
+      <a:schemeClr val="lt1"/>
+    </dgm:linClrLst>
+    <dgm:effectClrLst/>
+    <dgm:txLinClrLst/>
+    <dgm:txFillClrLst/>
+    <dgm:txEffectClrLst/>
+  </dgm:styleLbl>
+  <dgm:styleLbl name="node3">
+    <dgm:fillClrLst meth="repeat">
+      <a:schemeClr val="accent1"/>
+    </dgm:fillClrLst>
+    <dgm:linClrLst meth="repeat">
+      <a:schemeClr val="lt1"/>
+    </dgm:linClrLst>
+    <dgm:effectClrLst/>
+    <dgm:txLinClrLst/>
+    <dgm:txFillClrLst/>
+    <dgm:txEffectClrLst/>
+  </dgm:styleLbl>
+  <dgm:styleLbl name="node4">
+    <dgm:fillClrLst meth="repeat">
+      <a:schemeClr val="accent1"/>
+    </dgm:fillClrLst>
+    <dgm:linClrLst meth="repeat">
+      <a:schemeClr val="lt1"/>
+    </dgm:linClrLst>
+    <dgm:effectClrLst/>
+    <dgm:txLinClrLst/>
+    <dgm:txFillClrLst/>
+    <dgm:txEffectClrLst/>
+  </dgm:styleLbl>
+  <dgm:styleLbl name="fgImgPlace1">
+    <dgm:fillClrLst meth="repeat">
+      <a:schemeClr val="accent1">
+        <a:tint val="50000"/>
+      </a:schemeClr>
+    </dgm:fillClrLst>
+    <dgm:linClrLst meth="repeat">
+      <a:schemeClr val="lt1"/>
+    </dgm:linClrLst>
+    <dgm:effectClrLst/>
+    <dgm:txLinClrLst/>
+    <dgm:txFillClrLst meth="repeat">
+      <a:schemeClr val="lt1"/>
+    </dgm:txFillClrLst>
+    <dgm:txEffectClrLst/>
+  </dgm:styleLbl>
+  <dgm:styleLbl name="alignImgPlace1">
+    <dgm:fillClrLst meth="repeat">
+      <a:schemeClr val="accent1">
+        <a:tint val="50000"/>
+      </a:schemeClr>
+    </dgm:fillClrLst>
+    <dgm:linClrLst meth="repeat">
+      <a:schemeClr val="lt1"/>
+    </dgm:linClrLst>
+    <dgm:effectClrLst/>
+    <dgm:txLinClrLst/>
+    <dgm:txFillClrLst meth="repeat">
+      <a:schemeClr val="lt1"/>
+    </dgm:txFillClrLst>
+    <dgm:txEffectClrLst/>
+  </dgm:styleLbl>
+  <dgm:styleLbl name="bgImgPlace1">
+    <dgm:fillClrLst meth="repeat">
+      <a:schemeClr val="accent1">
+        <a:tint val="50000"/>
+      </a:schemeClr>
+    </dgm:fillClrLst>
+    <dgm:linClrLst meth="repeat">
+      <a:schemeClr val="lt1"/>
+    </dgm:linClrLst>
+    <dgm:effectClrLst/>
+    <dgm:txLinClrLst/>
+    <dgm:txFillClrLst meth="repeat">
+      <a:schemeClr val="lt1"/>
+    </dgm:txFillClrLst>
+    <dgm:txEffectClrLst/>
+  </dgm:styleLbl>
+  <dgm:styleLbl name="sibTrans2D1">
+    <dgm:fillClrLst meth="repeat">
+      <a:schemeClr val="accent1">
+        <a:tint val="60000"/>
+      </a:schemeClr>
+    </dgm:fillClrLst>
+    <dgm:linClrLst meth="repeat">
+      <a:schemeClr val="accent1">
+        <a:tint val="60000"/>
+      </a:schemeClr>
+    </dgm:linClrLst>
+    <dgm:effectClrLst/>
+    <dgm:txLinClrLst/>
+    <dgm:txFillClrLst/>
+    <dgm:txEffectClrLst/>
+  </dgm:styleLbl>
+  <dgm:styleLbl name="fgSibTrans2D1">
+    <dgm:fillClrLst meth="repeat">
+      <a:schemeClr val="accent1">
+        <a:tint val="60000"/>
+      </a:schemeClr>
+    </dgm:fillClrLst>
+    <dgm:linClrLst meth="repeat">
+      <a:schemeClr val="accent1">
+        <a:tint val="60000"/>
+      </a:schemeClr>
+    </dgm:linClrLst>
+    <dgm:effectClrLst/>
+    <dgm:txLinClrLst/>
+    <dgm:txFillClrLst/>
+    <dgm:txEffectClrLst/>
+  </dgm:styleLbl>
+  <dgm:styleLbl name="bgSibTrans2D1">
+    <dgm:fillClrLst meth="repeat">
+      <a:schemeClr val="accent1">
+        <a:tint val="60000"/>
+      </a:schemeClr>
+    </dgm:fillClrLst>
+    <dgm:linClrLst meth="repeat">
+      <a:schemeClr val="accent1">
+        <a:tint val="60000"/>
+      </a:schemeClr>
+    </dgm:linClrLst>
+    <dgm:effectClrLst/>
+    <dgm:txLinClrLst/>
+    <dgm:txFillClrLst/>
+    <dgm:txEffectClrLst/>
+  </dgm:styleLbl>
+  <dgm:styleLbl name="sibTrans1D1">
+    <dgm:fillClrLst meth="repeat">
+      <a:schemeClr val="accent1"/>
+    </dgm:fillClrLst>
+    <dgm:linClrLst meth="repeat">
+      <a:schemeClr val="accent1"/>
+    </dgm:linClrLst>
+    <dgm:effectClrLst/>
+    <dgm:txLinClrLst/>
+    <dgm:txFillClrLst meth="repeat">
+      <a:schemeClr val="tx1"/>
+    </dgm:txFillClrLst>
+    <dgm:txEffectClrLst/>
+  </dgm:styleLbl>
+  <dgm:styleLbl name="callout">
+    <dgm:fillClrLst meth="repeat">
+      <a:schemeClr val="accent1"/>
+    </dgm:fillClrLst>
+    <dgm:linClrLst meth="repeat">
+      <a:schemeClr val="accent1">
+        <a:tint val="50000"/>
+      </a:schemeClr>
+    </dgm:linClrLst>
+    <dgm:effectClrLst/>
+    <dgm:txLinClrLst/>
+    <dgm:txFillClrLst meth="repeat">
+      <a:schemeClr val="tx1"/>
+    </dgm:txFillClrLst>
+    <dgm:txEffectClrLst/>
+  </dgm:styleLbl>
+  <dgm:styleLbl name="asst0">
+    <dgm:fillClrLst meth="repeat">
+      <a:schemeClr val="accent1"/>
+    </dgm:fillClrLst>
+    <dgm:linClrLst meth="repeat">
+      <a:schemeClr val="lt1"/>
+    </dgm:linClrLst>
+    <dgm:effectClrLst/>
+    <dgm:txLinClrLst/>
+    <dgm:txFillClrLst/>
+    <dgm:txEffectClrLst/>
+  </dgm:styleLbl>
+  <dgm:styleLbl name="asst1">
+    <dgm:fillClrLst meth="repeat">
+      <a:schemeClr val="accent1"/>
+    </dgm:fillClrLst>
+    <dgm:linClrLst meth="repeat">
+      <a:schemeClr val="lt1"/>
+    </dgm:linClrLst>
+    <dgm:effectClrLst/>
+    <dgm:txLinClrLst/>
+    <dgm:txFillClrLst/>
+    <dgm:txEffectClrLst/>
+  </dgm:styleLbl>
+  <dgm:styleLbl name="asst2">
+    <dgm:fillClrLst meth="repeat">
+      <a:schemeClr val="accent1"/>
+    </dgm:fillClrLst>
+    <dgm:linClrLst meth="repeat">
+      <a:schemeClr val="lt1"/>
+    </dgm:linClrLst>
+    <dgm:effectClrLst/>
+    <dgm:txLinClrLst/>
+    <dgm:txFillClrLst/>
+    <dgm:txEffectClrLst/>
+  </dgm:styleLbl>
+  <dgm:styleLbl name="asst3">
+    <dgm:fillClrLst meth="repeat">
+      <a:schemeClr val="accent1"/>
+    </dgm:fillClrLst>
+    <dgm:linClrLst meth="repeat">
+      <a:schemeClr val="lt1"/>
+    </dgm:linClrLst>
+    <dgm:effectClrLst/>
+    <dgm:txLinClrLst/>
+    <dgm:txFillClrLst/>
+    <dgm:txEffectClrLst/>
+  </dgm:styleLbl>
+  <dgm:styleLbl name="asst4">
+    <dgm:fillClrLst meth="repeat">
+      <a:schemeClr val="accent1"/>
+    </dgm:fillClrLst>
+    <dgm:linClrLst meth="repeat">
+      <a:schemeClr val="lt1"/>
+    </dgm:linClrLst>
+    <dgm:effectClrLst/>
+    <dgm:txLinClrLst/>
+    <dgm:txFillClrLst/>
+    <dgm:txEffectClrLst/>
+  </dgm:styleLbl>
+  <dgm:styleLbl name="parChTrans2D1">
+    <dgm:fillClrLst meth="repeat">
+      <a:schemeClr val="accent1">
+        <a:tint val="60000"/>
+      </a:schemeClr>
+    </dgm:fillClrLst>
+    <dgm:linClrLst meth="repeat">
+      <a:schemeClr val="accent1">
+        <a:tint val="60000"/>
+      </a:schemeClr>
+    </dgm:linClrLst>
+    <dgm:effectClrLst/>
+    <dgm:txLinClrLst/>
+    <dgm:txFillClrLst meth="repeat">
+      <a:schemeClr val="lt1"/>
+    </dgm:txFillClrLst>
+    <dgm:txEffectClrLst/>
+  </dgm:styleLbl>
+  <dgm:styleLbl name="parChTrans2D2">
+    <dgm:fillClrLst meth="repeat">
+      <a:schemeClr val="accent1"/>
+    </dgm:fillClrLst>
+    <dgm:linClrLst meth="repeat">
+      <a:schemeClr val="accent1"/>
+    </dgm:linClrLst>
+    <dgm:effectClrLst/>
+    <dgm:txLinClrLst/>
+    <dgm:txFillClrLst meth="repeat">
+      <a:schemeClr val="lt1"/>
+    </dgm:txFillClrLst>
+    <dgm:txEffectClrLst/>
+  </dgm:styleLbl>
+  <dgm:styleLbl name="parChTrans2D3">
+    <dgm:fillClrLst meth="repeat">
+      <a:schemeClr val="accent1"/>
+    </dgm:fillClrLst>
+    <dgm:linClrLst meth="repeat">
+      <a:schemeClr val="accent1"/>
+    </dgm:linClrLst>
+    <dgm:effectClrLst/>
+    <dgm:txLinClrLst/>
+    <dgm:txFillClrLst meth="repeat">
+      <a:schemeClr val="lt1"/>
+    </dgm:txFillClrLst>
+    <dgm:txEffectClrLst/>
+  </dgm:styleLbl>
+  <dgm:styleLbl name="parChTrans2D4">
+    <dgm:fillClrLst meth="repeat">
+      <a:schemeClr val="accent1"/>
+    </dgm:fillClrLst>
+    <dgm:linClrLst meth="repeat">
+      <a:schemeClr val="accent1"/>
+    </dgm:linClrLst>
+    <dgm:effectClrLst/>
+    <dgm:txLinClrLst/>
+    <dgm:txFillClrLst meth="repeat">
+      <a:schemeClr val="lt1"/>
+    </dgm:txFillClrLst>
+    <dgm:txEffectClrLst/>
+  </dgm:styleLbl>
+  <dgm:styleLbl name="parChTrans1D1">
+    <dgm:fillClrLst meth="repeat">
+      <a:schemeClr val="accent1"/>
+    </dgm:fillClrLst>
+    <dgm:linClrLst meth="repeat">
+      <a:schemeClr val="accent1">
+        <a:shade val="60000"/>
+      </a:schemeClr>
+    </dgm:linClrLst>
+    <dgm:effectClrLst/>
+    <dgm:txLinClrLst/>
+    <dgm:txFillClrLst meth="repeat">
+      <a:schemeClr val="tx1"/>
+    </dgm:txFillClrLst>
+    <dgm:txEffectClrLst/>
+  </dgm:styleLbl>
+  <dgm:styleLbl name="parChTrans1D2">
+    <dgm:fillClrLst meth="repeat">
+      <a:schemeClr val="accent1"/>
+    </dgm:fillClrLst>
+    <dgm:linClrLst meth="repeat">
+      <a:schemeClr val="accent1">
+        <a:shade val="60000"/>
+      </a:schemeClr>
+    </dgm:linClrLst>
+    <dgm:effectClrLst/>
+    <dgm:txLinClrLst/>
+    <dgm:txFillClrLst meth="repeat">
+      <a:schemeClr val="tx1"/>
+    </dgm:txFillClrLst>
+    <dgm:txEffectClrLst/>
+  </dgm:styleLbl>
+  <dgm:styleLbl name="parChTrans1D3">
+    <dgm:fillClrLst meth="repeat">
+      <a:schemeClr val="accent1"/>
+    </dgm:fillClrLst>
+    <dgm:linClrLst meth="repeat">
+      <a:schemeClr val="accent1">
+        <a:shade val="80000"/>
+      </a:schemeClr>
+    </dgm:linClrLst>
+    <dgm:effectClrLst/>
+    <dgm:txLinClrLst/>
+    <dgm:txFillClrLst meth="repeat">
+      <a:schemeClr val="tx1"/>
+    </dgm:txFillClrLst>
+    <dgm:txEffectClrLst/>
+  </dgm:styleLbl>
+  <dgm:styleLbl name="parChTrans1D4">
+    <dgm:fillClrLst meth="repeat">
+      <a:schemeClr val="accent1"/>
+    </dgm:fillClrLst>
+    <dgm:linClrLst meth="repeat">
+      <a:schemeClr val="accent1">
+        <a:shade val="80000"/>
+      </a:schemeClr>
+    </dgm:linClrLst>
+    <dgm:effectClrLst/>
+    <dgm:txLinClrLst/>
+    <dgm:txFillClrLst meth="repeat">
+      <a:schemeClr val="tx1"/>
+    </dgm:txFillClrLst>
+    <dgm:txEffectClrLst/>
+  </dgm:styleLbl>
+  <dgm:styleLbl name="fgAcc1">
+    <dgm:fillClrLst meth="repeat">
+      <a:schemeClr val="lt1">
+        <a:alpha val="90000"/>
+      </a:schemeClr>
+    </dgm:fillClrLst>
+    <dgm:linClrLst meth="repeat">
+      <a:schemeClr val="accent1"/>
+    </dgm:linClrLst>
+    <dgm:effectClrLst/>
+    <dgm:txLinClrLst/>
+    <dgm:txFillClrLst meth="repeat">
+      <a:schemeClr val="dk1"/>
+    </dgm:txFillClrLst>
+    <dgm:txEffectClrLst/>
+  </dgm:styleLbl>
+  <dgm:styleLbl name="conFgAcc1">
+    <dgm:fillClrLst meth="repeat">
+      <a:schemeClr val="lt1">
+        <a:alpha val="90000"/>
+      </a:schemeClr>
+    </dgm:fillClrLst>
+    <dgm:linClrLst meth="repeat">
+      <a:schemeClr val="accent1"/>
+    </dgm:linClrLst>
+    <dgm:effectClrLst/>
+    <dgm:txLinClrLst/>
+    <dgm:txFillClrLst meth="repeat">
+      <a:schemeClr val="dk1"/>
+    </dgm:txFillClrLst>
+    <dgm:txEffectClrLst/>
+  </dgm:styleLbl>
+  <dgm:styleLbl name="alignAcc1">
+    <dgm:fillClrLst meth="repeat">
+      <a:schemeClr val="lt1">
+        <a:alpha val="90000"/>
+      </a:schemeClr>
+    </dgm:fillClrLst>
+    <dgm:linClrLst meth="repeat">
+      <a:schemeClr val="accent1"/>
+    </dgm:linClrLst>
+    <dgm:effectClrLst/>
+    <dgm:txLinClrLst/>
+    <dgm:txFillClrLst meth="repeat">
+      <a:schemeClr val="dk1"/>
+    </dgm:txFillClrLst>
+    <dgm:txEffectClrLst/>
+  </dgm:styleLbl>
+  <dgm:styleLbl name="trAlignAcc1">
+    <dgm:fillClrLst meth="repeat">
+      <a:schemeClr val="lt1">
+        <a:alpha val="40000"/>
+      </a:schemeClr>
+    </dgm:fillClrLst>
+    <dgm:linClrLst meth="repeat">
+      <a:schemeClr val="accent1"/>
+    </dgm:linClrLst>
+    <dgm:effectClrLst/>
+    <dgm:txLinClrLst/>
+    <dgm:txFillClrLst meth="repeat">
+      <a:schemeClr val="dk1"/>
+    </dgm:txFillClrLst>
+    <dgm:txEffectClrLst/>
+  </dgm:styleLbl>
+  <dgm:styleLbl name="bgAcc1">
+    <dgm:fillClrLst meth="repeat">
+      <a:schemeClr val="lt1">
+        <a:alpha val="90000"/>
+      </a:schemeClr>
+    </dgm:fillClrLst>
+    <dgm:linClrLst meth="repeat">
+      <a:schemeClr val="accent1"/>
+    </dgm:linClrLst>
+    <dgm:effectClrLst/>
+    <dgm:txLinClrLst/>
+    <dgm:txFillClrLst meth="repeat">
+      <a:schemeClr val="dk1"/>
+    </dgm:txFillClrLst>
+    <dgm:txEffectClrLst/>
+  </dgm:styleLbl>
+  <dgm:styleLbl name="solidFgAcc1">
+    <dgm:fillClrLst meth="repeat">
+      <a:schemeClr val="lt1"/>
+    </dgm:fillClrLst>
+    <dgm:linClrLst meth="repeat">
+      <a:schemeClr val="accent1"/>
+    </dgm:linClrLst>
+    <dgm:effectClrLst/>
+    <dgm:txLinClrLst/>
+    <dgm:txFillClrLst meth="repeat">
+      <a:schemeClr val="dk1"/>
+    </dgm:txFillClrLst>
+    <dgm:txEffectClrLst/>
+  </dgm:styleLbl>
+  <dgm:styleLbl name="solidAlignAcc1">
+    <dgm:fillClrLst meth="repeat">
+      <a:schemeClr val="lt1"/>
+    </dgm:fillClrLst>
+    <dgm:linClrLst meth="repeat">
+      <a:schemeClr val="accent1"/>
+    </dgm:linClrLst>
+    <dgm:effectClrLst/>
+    <dgm:txLinClrLst/>
+    <dgm:txFillClrLst meth="repeat">
+      <a:schemeClr val="dk1"/>
+    </dgm:txFillClrLst>
+    <dgm:txEffectClrLst/>
+  </dgm:styleLbl>
+  <dgm:styleLbl name="solidBgAcc1">
+    <dgm:fillClrLst meth="repeat">
+      <a:schemeClr val="lt1"/>
+    </dgm:fillClrLst>
+    <dgm:linClrLst meth="repeat">
+      <a:schemeClr val="accent1"/>
+    </dgm:linClrLst>
+    <dgm:effectClrLst/>
+    <dgm:txLinClrLst/>
+    <dgm:txFillClrLst meth="repeat">
+      <a:schemeClr val="dk1"/>
+    </dgm:txFillClrLst>
+    <dgm:txEffectClrLst/>
+  </dgm:styleLbl>
+  <dgm:styleLbl name="fgAccFollowNode1">
+    <dgm:fillClrLst meth="repeat">
+      <a:schemeClr val="accent1">
+        <a:alpha val="90000"/>
+        <a:tint val="40000"/>
+      </a:schemeClr>
+    </dgm:fillClrLst>
+    <dgm:linClrLst meth="repeat">
+      <a:schemeClr val="accent1">
+        <a:alpha val="90000"/>
+        <a:tint val="40000"/>
+      </a:schemeClr>
+    </dgm:linClrLst>
+    <dgm:effectClrLst/>
+    <dgm:txLinClrLst/>
+    <dgm:txFillClrLst meth="repeat">
+      <a:schemeClr val="dk1"/>
+    </dgm:txFillClrLst>
+    <dgm:txEffectClrLst/>
+  </dgm:styleLbl>
+  <dgm:styleLbl name="alignAccFollowNode1">
+    <dgm:fillClrLst meth="repeat">
+      <a:schemeClr val="accent1">
+        <a:alpha val="90000"/>
+        <a:tint val="40000"/>
+      </a:schemeClr>
+    </dgm:fillClrLst>
+    <dgm:linClrLst meth="repeat">
+      <a:schemeClr val="accent1">
+        <a:alpha val="90000"/>
+        <a:tint val="40000"/>
+      </a:schemeClr>
+    </dgm:linClrLst>
+    <dgm:effectClrLst/>
+    <dgm:txLinClrLst/>
+    <dgm:txFillClrLst meth="repeat">
+      <a:schemeClr val="dk1"/>
+    </dgm:txFillClrLst>
+    <dgm:txEffectClrLst/>
+  </dgm:styleLbl>
+  <dgm:styleLbl name="bgAccFollowNode1">
+    <dgm:fillClrLst meth="repeat">
+      <a:schemeClr val="accent1">
+        <a:alpha val="90000"/>
+        <a:tint val="40000"/>
+      </a:schemeClr>
+    </dgm:fillClrLst>
+    <dgm:linClrLst meth="repeat">
+      <a:schemeClr val="accent1">
+        <a:alpha val="90000"/>
+        <a:tint val="40000"/>
+      </a:schemeClr>
+    </dgm:linClrLst>
+    <dgm:effectClrLst/>
+    <dgm:txLinClrLst/>
+    <dgm:txFillClrLst meth="repeat">
+      <a:schemeClr val="dk1"/>
+    </dgm:txFillClrLst>
+    <dgm:txEffectClrLst/>
+  </dgm:styleLbl>
+  <dgm:styleLbl name="fgAcc0">
+    <dgm:fillClrLst meth="repeat">
+      <a:schemeClr val="lt1">
+        <a:alpha val="90000"/>
+      </a:schemeClr>
+    </dgm:fillClrLst>
+    <dgm:linClrLst meth="repeat">
+      <a:schemeClr val="accent1"/>
+    </dgm:linClrLst>
+    <dgm:effectClrLst/>
+    <dgm:txLinClrLst/>
+    <dgm:txFillClrLst meth="repeat">
+      <a:schemeClr val="dk1"/>
+    </dgm:txFillClrLst>
+    <dgm:txEffectClrLst/>
+  </dgm:styleLbl>
+  <dgm:styleLbl name="fgAcc2">
+    <dgm:fillClrLst meth="repeat">
+      <a:schemeClr val="lt1">
+        <a:alpha val="90000"/>
+      </a:schemeClr>
+    </dgm:fillClrLst>
+    <dgm:linClrLst meth="repeat">
+      <a:schemeClr val="accent1"/>
+    </dgm:linClrLst>
+    <dgm:effectClrLst/>
+    <dgm:txLinClrLst/>
+    <dgm:txFillClrLst meth="repeat">
+      <a:schemeClr val="dk1"/>
+    </dgm:txFillClrLst>
+    <dgm:txEffectClrLst/>
+  </dgm:styleLbl>
+  <dgm:styleLbl name="fgAcc3">
+    <dgm:fillClrLst meth="repeat">
+      <a:schemeClr val="lt1">
+        <a:alpha val="90000"/>
+      </a:schemeClr>
+    </dgm:fillClrLst>
+    <dgm:linClrLst meth="repeat">
+      <a:schemeClr val="accent1"/>
+    </dgm:linClrLst>
+    <dgm:effectClrLst/>
+    <dgm:txLinClrLst/>
+    <dgm:txFillClrLst meth="repeat">
+      <a:schemeClr val="dk1"/>
+    </dgm:txFillClrLst>
+    <dgm:txEffectClrLst/>
+  </dgm:styleLbl>
+  <dgm:styleLbl name="fgAcc4">
+    <dgm:fillClrLst meth="repeat">
+      <a:schemeClr val="lt1">
+        <a:alpha val="90000"/>
+      </a:schemeClr>
+    </dgm:fillClrLst>
+    <dgm:linClrLst meth="repeat">
+      <a:schemeClr val="accent1"/>
+    </dgm:linClrLst>
+    <dgm:effectClrLst/>
+    <dgm:txLinClrLst/>
+    <dgm:txFillClrLst meth="repeat">
+      <a:schemeClr val="dk1"/>
+    </dgm:txFillClrLst>
+    <dgm:txEffectClrLst/>
+  </dgm:styleLbl>
+  <dgm:styleLbl name="bgShp">
+    <dgm:fillClrLst meth="repeat">
+      <a:schemeClr val="accent1">
+        <a:tint val="40000"/>
+      </a:schemeClr>
+    </dgm:fillClrLst>
+    <dgm:linClrLst meth="repeat">
+      <a:schemeClr val="accent1"/>
+    </dgm:linClrLst>
+    <dgm:effectClrLst/>
+    <dgm:txLinClrLst/>
+    <dgm:txFillClrLst meth="repeat">
+      <a:schemeClr val="dk1"/>
+    </dgm:txFillClrLst>
+    <dgm:txEffectClrLst/>
+  </dgm:styleLbl>
+  <dgm:styleLbl name="dkBgShp">
+    <dgm:fillClrLst meth="repeat">
+      <a:schemeClr val="accent1">
+        <a:shade val="80000"/>
+      </a:schemeClr>
+    </dgm:fillClrLst>
+    <dgm:linClrLst meth="repeat">
+      <a:schemeClr val="accent1"/>
+    </dgm:linClrLst>
+    <dgm:effectClrLst/>
+    <dgm:txLinClrLst/>
+    <dgm:txFillClrLst meth="repeat">
+      <a:schemeClr val="lt1"/>
+    </dgm:txFillClrLst>
+    <dgm:txEffectClrLst/>
+  </dgm:styleLbl>
+  <dgm:styleLbl name="trBgShp">
+    <dgm:fillClrLst meth="repeat">
+      <a:schemeClr val="accent1">
+        <a:tint val="50000"/>
+        <a:alpha val="40000"/>
+      </a:schemeClr>
+    </dgm:fillClrLst>
+    <dgm:linClrLst meth="repeat">
+      <a:schemeClr val="accent1"/>
+    </dgm:linClrLst>
+    <dgm:effectClrLst/>
+    <dgm:txLinClrLst/>
+    <dgm:txFillClrLst meth="repeat">
+      <a:schemeClr val="lt1"/>
+    </dgm:txFillClrLst>
+    <dgm:txEffectClrLst/>
+  </dgm:styleLbl>
+  <dgm:styleLbl name="fgShp">
+    <dgm:fillClrLst meth="repeat">
+      <a:schemeClr val="accent1">
+        <a:tint val="60000"/>
+      </a:schemeClr>
+    </dgm:fillClrLst>
+    <dgm:linClrLst meth="repeat">
+      <a:schemeClr val="lt1"/>
+    </dgm:linClrLst>
+    <dgm:effectClrLst/>
+    <dgm:txLinClrLst/>
+    <dgm:txFillClrLst meth="repeat">
+      <a:schemeClr val="dk1"/>
+    </dgm:txFillClrLst>
+    <dgm:txEffectClrLst/>
+  </dgm:styleLbl>
+  <dgm:styleLbl name="revTx">
+    <dgm:fillClrLst meth="repeat">
+      <a:schemeClr val="lt1">
+        <a:alpha val="0"/>
+      </a:schemeClr>
+    </dgm:fillClrLst>
+    <dgm:linClrLst meth="repeat">
+      <a:schemeClr val="dk1">
+        <a:alpha val="0"/>
+      </a:schemeClr>
+    </dgm:linClrLst>
+    <dgm:effectClrLst/>
+    <dgm:txLinClrLst/>
+    <dgm:txFillClrLst meth="repeat">
+      <a:schemeClr val="tx1"/>
+    </dgm:txFillClrLst>
+    <dgm:txEffectClrLst/>
+  </dgm:styleLbl>
+</dgm:colorsDef>
+</file>
+
+<file path=ppt/diagrams/colors3.xml><?xml version="1.0" encoding="utf-8"?>
 <dgm:colorsDef xmlns:dgm="http://schemas.openxmlformats.org/drawingml/2006/diagram" xmlns:a="http://schemas.openxmlformats.org/drawingml/2006/main" uniqueId="urn:microsoft.com/office/officeart/2005/8/colors/accent1_2">
   <dgm:title val=""/>
   <dgm:desc val=""/>
@@ -2032,6 +2780,317 @@
 </file>
 
 <file path=ppt/diagrams/data2.xml><?xml version="1.0" encoding="utf-8"?>
+<dgm:dataModel xmlns:dgm="http://schemas.openxmlformats.org/drawingml/2006/diagram" xmlns:a="http://schemas.openxmlformats.org/drawingml/2006/main">
+  <dgm:ptLst>
+    <dgm:pt modelId="{1BAF38FA-668C-42FF-833B-8125D0660C5A}" type="doc">
+      <dgm:prSet loTypeId="urn:microsoft.com/office/officeart/2005/8/layout/hChevron3" loCatId="process" qsTypeId="urn:microsoft.com/office/officeart/2005/8/quickstyle/simple1" qsCatId="simple" csTypeId="urn:microsoft.com/office/officeart/2005/8/colors/accent1_2" csCatId="accent1" phldr="1"/>
+      <dgm:spPr/>
+      <dgm:t>
+        <a:bodyPr/>
+        <a:lstStyle/>
+        <a:p>
+          <a:endParaRPr lang="en-US"/>
+        </a:p>
+      </dgm:t>
+    </dgm:pt>
+    <dgm:pt modelId="{02F2DEB5-04B2-43B0-AE1F-484092092F8C}">
+      <dgm:prSet phldrT="[Text]" phldr="0"/>
+      <dgm:spPr>
+        <a:ln>
+          <a:solidFill>
+            <a:schemeClr val="accent6">
+              <a:lumMod val="75000"/>
+            </a:schemeClr>
+          </a:solidFill>
+        </a:ln>
+      </dgm:spPr>
+      <dgm:t>
+        <a:bodyPr/>
+        <a:lstStyle/>
+        <a:p>
+          <a:endParaRPr lang="en-US"/>
+        </a:p>
+      </dgm:t>
+    </dgm:pt>
+    <dgm:pt modelId="{086CFFA7-5016-4BB1-BF31-ADB78F91B03E}" type="parTrans" cxnId="{CFE9B22D-431F-42D5-A9DD-A34070B50E6D}">
+      <dgm:prSet/>
+      <dgm:spPr/>
+      <dgm:t>
+        <a:bodyPr/>
+        <a:lstStyle/>
+        <a:p>
+          <a:endParaRPr lang="en-US"/>
+        </a:p>
+      </dgm:t>
+    </dgm:pt>
+    <dgm:pt modelId="{98B402DD-A062-43D3-B135-4A9AE401840E}" type="sibTrans" cxnId="{CFE9B22D-431F-42D5-A9DD-A34070B50E6D}">
+      <dgm:prSet/>
+      <dgm:spPr/>
+      <dgm:t>
+        <a:bodyPr/>
+        <a:lstStyle/>
+        <a:p>
+          <a:endParaRPr lang="en-US"/>
+        </a:p>
+      </dgm:t>
+    </dgm:pt>
+    <dgm:pt modelId="{3F8A6D25-EC33-4E79-9F36-36771A974919}">
+      <dgm:prSet phldrT="[Text]" phldr="0" custT="1"/>
+      <dgm:spPr>
+        <a:solidFill>
+          <a:srgbClr val="ACD433">
+            <a:hueOff val="0"/>
+            <a:satOff val="0"/>
+            <a:lumOff val="0"/>
+            <a:alphaOff val="0"/>
+          </a:srgbClr>
+        </a:solidFill>
+        <a:ln w="19050" cap="rnd" cmpd="sng" algn="ctr">
+          <a:solidFill>
+            <a:schemeClr val="accent6">
+              <a:lumMod val="75000"/>
+            </a:schemeClr>
+          </a:solidFill>
+          <a:prstDash val="solid"/>
+        </a:ln>
+        <a:effectLst/>
+      </dgm:spPr>
+      <dgm:t>
+        <a:bodyPr spcFirstLastPara="0" vert="horz" wrap="square" lIns="261366" tIns="130683" rIns="65342" bIns="130683" numCol="1" spcCol="1270" anchor="ctr" anchorCtr="0"/>
+        <a:lstStyle/>
+        <a:p>
+          <a:pPr marL="0" lvl="0" indent="0" algn="ctr" defTabSz="2178050">
+            <a:lnSpc>
+              <a:spcPct val="90000"/>
+            </a:lnSpc>
+            <a:spcBef>
+              <a:spcPct val="0"/>
+            </a:spcBef>
+            <a:spcAft>
+              <a:spcPct val="35000"/>
+            </a:spcAft>
+            <a:buNone/>
+          </a:pPr>
+          <a:endParaRPr lang="en-US" sz="4900" kern="1200" dirty="0">
+            <a:solidFill>
+              <a:prstClr val="white"/>
+            </a:solidFill>
+            <a:latin typeface="Century Gothic" panose="020B0502020202020204"/>
+            <a:ea typeface="+mn-ea"/>
+            <a:cs typeface="+mn-cs"/>
+          </a:endParaRPr>
+        </a:p>
+      </dgm:t>
+    </dgm:pt>
+    <dgm:pt modelId="{2214299D-707F-429C-A23D-9EE2F39CF74A}" type="parTrans" cxnId="{0C42CAF2-971C-4068-B645-A373CE11E869}">
+      <dgm:prSet/>
+      <dgm:spPr/>
+      <dgm:t>
+        <a:bodyPr/>
+        <a:lstStyle/>
+        <a:p>
+          <a:endParaRPr lang="en-US"/>
+        </a:p>
+      </dgm:t>
+    </dgm:pt>
+    <dgm:pt modelId="{F5C31149-F876-40A6-9FD4-9FC1A73D7103}" type="sibTrans" cxnId="{0C42CAF2-971C-4068-B645-A373CE11E869}">
+      <dgm:prSet/>
+      <dgm:spPr/>
+      <dgm:t>
+        <a:bodyPr/>
+        <a:lstStyle/>
+        <a:p>
+          <a:endParaRPr lang="en-US"/>
+        </a:p>
+      </dgm:t>
+    </dgm:pt>
+    <dgm:pt modelId="{2A8D39A9-50C8-4D4F-B033-79DECE006E66}">
+      <dgm:prSet phldrT="[Text]" phldr="0"/>
+      <dgm:spPr>
+        <a:solidFill>
+          <a:schemeClr val="tx1">
+            <a:lumMod val="95000"/>
+          </a:schemeClr>
+        </a:solidFill>
+        <a:ln>
+          <a:solidFill>
+            <a:schemeClr val="accent6">
+              <a:lumMod val="75000"/>
+            </a:schemeClr>
+          </a:solidFill>
+        </a:ln>
+      </dgm:spPr>
+      <dgm:t>
+        <a:bodyPr/>
+        <a:lstStyle/>
+        <a:p>
+          <a:endParaRPr lang="en-US" dirty="0"/>
+        </a:p>
+      </dgm:t>
+    </dgm:pt>
+    <dgm:pt modelId="{315C08A7-84C9-4B75-B41E-C170BAF53261}" type="parTrans" cxnId="{2667F885-9801-44B0-94AB-28C9292F3E74}">
+      <dgm:prSet/>
+      <dgm:spPr/>
+      <dgm:t>
+        <a:bodyPr/>
+        <a:lstStyle/>
+        <a:p>
+          <a:endParaRPr lang="en-US"/>
+        </a:p>
+      </dgm:t>
+    </dgm:pt>
+    <dgm:pt modelId="{55984B9E-0D3F-4FAD-8385-14CE83ECD63D}" type="sibTrans" cxnId="{2667F885-9801-44B0-94AB-28C9292F3E74}">
+      <dgm:prSet/>
+      <dgm:spPr/>
+      <dgm:t>
+        <a:bodyPr/>
+        <a:lstStyle/>
+        <a:p>
+          <a:endParaRPr lang="en-US"/>
+        </a:p>
+      </dgm:t>
+    </dgm:pt>
+    <dgm:pt modelId="{6D71B52B-3920-4F69-82CF-D2F6B276680D}">
+      <dgm:prSet phldrT="[Text]" phldr="0"/>
+      <dgm:spPr>
+        <a:solidFill>
+          <a:schemeClr val="tx1">
+            <a:lumMod val="95000"/>
+          </a:schemeClr>
+        </a:solidFill>
+        <a:ln>
+          <a:solidFill>
+            <a:schemeClr val="accent6">
+              <a:lumMod val="75000"/>
+            </a:schemeClr>
+          </a:solidFill>
+        </a:ln>
+      </dgm:spPr>
+      <dgm:t>
+        <a:bodyPr/>
+        <a:lstStyle/>
+        <a:p>
+          <a:endParaRPr lang="en-US" dirty="0"/>
+        </a:p>
+      </dgm:t>
+    </dgm:pt>
+    <dgm:pt modelId="{D523D338-016A-4C79-9BD8-F4C65FDC3E4A}" type="parTrans" cxnId="{92E5502B-D54D-4966-9E24-506A6D560BD2}">
+      <dgm:prSet/>
+      <dgm:spPr/>
+      <dgm:t>
+        <a:bodyPr/>
+        <a:lstStyle/>
+        <a:p>
+          <a:endParaRPr lang="en-US"/>
+        </a:p>
+      </dgm:t>
+    </dgm:pt>
+    <dgm:pt modelId="{CD4D0C60-FE61-48F8-A8F6-566EF2190D5C}" type="sibTrans" cxnId="{92E5502B-D54D-4966-9E24-506A6D560BD2}">
+      <dgm:prSet/>
+      <dgm:spPr/>
+      <dgm:t>
+        <a:bodyPr/>
+        <a:lstStyle/>
+        <a:p>
+          <a:endParaRPr lang="en-US"/>
+        </a:p>
+      </dgm:t>
+    </dgm:pt>
+    <dgm:pt modelId="{CDD65885-70A5-408A-AD16-60B5296FD84F}" type="pres">
+      <dgm:prSet presAssocID="{1BAF38FA-668C-42FF-833B-8125D0660C5A}" presName="Name0" presStyleCnt="0">
+        <dgm:presLayoutVars>
+          <dgm:dir/>
+          <dgm:resizeHandles val="exact"/>
+        </dgm:presLayoutVars>
+      </dgm:prSet>
+      <dgm:spPr/>
+    </dgm:pt>
+    <dgm:pt modelId="{3B3B9CF9-ACCC-4AAF-B159-A5ECCE9F91FA}" type="pres">
+      <dgm:prSet presAssocID="{02F2DEB5-04B2-43B0-AE1F-484092092F8C}" presName="parTxOnly" presStyleLbl="node1" presStyleIdx="0" presStyleCnt="4">
+        <dgm:presLayoutVars>
+          <dgm:bulletEnabled val="1"/>
+        </dgm:presLayoutVars>
+      </dgm:prSet>
+      <dgm:spPr/>
+    </dgm:pt>
+    <dgm:pt modelId="{5EA737B2-FAEA-4E29-B7AB-D4AF56C6722A}" type="pres">
+      <dgm:prSet presAssocID="{98B402DD-A062-43D3-B135-4A9AE401840E}" presName="parSpace" presStyleCnt="0"/>
+      <dgm:spPr/>
+    </dgm:pt>
+    <dgm:pt modelId="{927287C2-A3D7-40DA-9CC5-879018D16C6C}" type="pres">
+      <dgm:prSet presAssocID="{3F8A6D25-EC33-4E79-9F36-36771A974919}" presName="parTxOnly" presStyleLbl="node1" presStyleIdx="1" presStyleCnt="4">
+        <dgm:presLayoutVars>
+          <dgm:bulletEnabled val="1"/>
+        </dgm:presLayoutVars>
+      </dgm:prSet>
+      <dgm:spPr>
+        <a:xfrm>
+          <a:off x="1913731" y="226207"/>
+          <a:ext cx="2389187" cy="955675"/>
+        </a:xfrm>
+        <a:prstGeom prst="chevron">
+          <a:avLst/>
+        </a:prstGeom>
+      </dgm:spPr>
+    </dgm:pt>
+    <dgm:pt modelId="{D7399875-5945-4082-A56B-0967B2FF1CAA}" type="pres">
+      <dgm:prSet presAssocID="{F5C31149-F876-40A6-9FD4-9FC1A73D7103}" presName="parSpace" presStyleCnt="0"/>
+      <dgm:spPr/>
+    </dgm:pt>
+    <dgm:pt modelId="{0FFC9F85-D342-4563-A0C2-89C6B83FD375}" type="pres">
+      <dgm:prSet presAssocID="{2A8D39A9-50C8-4D4F-B033-79DECE006E66}" presName="parTxOnly" presStyleLbl="node1" presStyleIdx="2" presStyleCnt="4">
+        <dgm:presLayoutVars>
+          <dgm:bulletEnabled val="1"/>
+        </dgm:presLayoutVars>
+      </dgm:prSet>
+      <dgm:spPr/>
+    </dgm:pt>
+    <dgm:pt modelId="{00AD2CC1-E211-4CFF-A9B2-67FC64D14459}" type="pres">
+      <dgm:prSet presAssocID="{55984B9E-0D3F-4FAD-8385-14CE83ECD63D}" presName="parSpace" presStyleCnt="0"/>
+      <dgm:spPr/>
+    </dgm:pt>
+    <dgm:pt modelId="{903FC15E-8A12-4ACF-90BF-441209C11D87}" type="pres">
+      <dgm:prSet presAssocID="{6D71B52B-3920-4F69-82CF-D2F6B276680D}" presName="parTxOnly" presStyleLbl="node1" presStyleIdx="3" presStyleCnt="4">
+        <dgm:presLayoutVars>
+          <dgm:bulletEnabled val="1"/>
+        </dgm:presLayoutVars>
+      </dgm:prSet>
+      <dgm:spPr/>
+    </dgm:pt>
+  </dgm:ptLst>
+  <dgm:cxnLst>
+    <dgm:cxn modelId="{347BB41C-FC86-4550-A2CB-D58B80B9751F}" type="presOf" srcId="{2A8D39A9-50C8-4D4F-B033-79DECE006E66}" destId="{0FFC9F85-D342-4563-A0C2-89C6B83FD375}" srcOrd="0" destOrd="0" presId="urn:microsoft.com/office/officeart/2005/8/layout/hChevron3"/>
+    <dgm:cxn modelId="{92E5502B-D54D-4966-9E24-506A6D560BD2}" srcId="{1BAF38FA-668C-42FF-833B-8125D0660C5A}" destId="{6D71B52B-3920-4F69-82CF-D2F6B276680D}" srcOrd="3" destOrd="0" parTransId="{D523D338-016A-4C79-9BD8-F4C65FDC3E4A}" sibTransId="{CD4D0C60-FE61-48F8-A8F6-566EF2190D5C}"/>
+    <dgm:cxn modelId="{CFE9B22D-431F-42D5-A9DD-A34070B50E6D}" srcId="{1BAF38FA-668C-42FF-833B-8125D0660C5A}" destId="{02F2DEB5-04B2-43B0-AE1F-484092092F8C}" srcOrd="0" destOrd="0" parTransId="{086CFFA7-5016-4BB1-BF31-ADB78F91B03E}" sibTransId="{98B402DD-A062-43D3-B135-4A9AE401840E}"/>
+    <dgm:cxn modelId="{7E7A1337-859F-4F61-9A78-82F7E8764017}" type="presOf" srcId="{3F8A6D25-EC33-4E79-9F36-36771A974919}" destId="{927287C2-A3D7-40DA-9CC5-879018D16C6C}" srcOrd="0" destOrd="0" presId="urn:microsoft.com/office/officeart/2005/8/layout/hChevron3"/>
+    <dgm:cxn modelId="{C8B7E64E-D047-4A1C-842A-C4653D06E0DB}" type="presOf" srcId="{1BAF38FA-668C-42FF-833B-8125D0660C5A}" destId="{CDD65885-70A5-408A-AD16-60B5296FD84F}" srcOrd="0" destOrd="0" presId="urn:microsoft.com/office/officeart/2005/8/layout/hChevron3"/>
+    <dgm:cxn modelId="{69FDE357-9944-440F-9DEB-FDD0AD8A9BFE}" type="presOf" srcId="{6D71B52B-3920-4F69-82CF-D2F6B276680D}" destId="{903FC15E-8A12-4ACF-90BF-441209C11D87}" srcOrd="0" destOrd="0" presId="urn:microsoft.com/office/officeart/2005/8/layout/hChevron3"/>
+    <dgm:cxn modelId="{2667F885-9801-44B0-94AB-28C9292F3E74}" srcId="{1BAF38FA-668C-42FF-833B-8125D0660C5A}" destId="{2A8D39A9-50C8-4D4F-B033-79DECE006E66}" srcOrd="2" destOrd="0" parTransId="{315C08A7-84C9-4B75-B41E-C170BAF53261}" sibTransId="{55984B9E-0D3F-4FAD-8385-14CE83ECD63D}"/>
+    <dgm:cxn modelId="{0C42CAF2-971C-4068-B645-A373CE11E869}" srcId="{1BAF38FA-668C-42FF-833B-8125D0660C5A}" destId="{3F8A6D25-EC33-4E79-9F36-36771A974919}" srcOrd="1" destOrd="0" parTransId="{2214299D-707F-429C-A23D-9EE2F39CF74A}" sibTransId="{F5C31149-F876-40A6-9FD4-9FC1A73D7103}"/>
+    <dgm:cxn modelId="{3020AFFF-29FB-4253-9067-BC7D344E83A9}" type="presOf" srcId="{02F2DEB5-04B2-43B0-AE1F-484092092F8C}" destId="{3B3B9CF9-ACCC-4AAF-B159-A5ECCE9F91FA}" srcOrd="0" destOrd="0" presId="urn:microsoft.com/office/officeart/2005/8/layout/hChevron3"/>
+    <dgm:cxn modelId="{E191ADB3-48DE-4471-9D7B-B06436C72291}" type="presParOf" srcId="{CDD65885-70A5-408A-AD16-60B5296FD84F}" destId="{3B3B9CF9-ACCC-4AAF-B159-A5ECCE9F91FA}" srcOrd="0" destOrd="0" presId="urn:microsoft.com/office/officeart/2005/8/layout/hChevron3"/>
+    <dgm:cxn modelId="{F6ECF3E2-766C-40B1-9FEF-D2B9A3751F52}" type="presParOf" srcId="{CDD65885-70A5-408A-AD16-60B5296FD84F}" destId="{5EA737B2-FAEA-4E29-B7AB-D4AF56C6722A}" srcOrd="1" destOrd="0" presId="urn:microsoft.com/office/officeart/2005/8/layout/hChevron3"/>
+    <dgm:cxn modelId="{5F4A39DD-EE71-415A-B0B3-627A8BABEDC4}" type="presParOf" srcId="{CDD65885-70A5-408A-AD16-60B5296FD84F}" destId="{927287C2-A3D7-40DA-9CC5-879018D16C6C}" srcOrd="2" destOrd="0" presId="urn:microsoft.com/office/officeart/2005/8/layout/hChevron3"/>
+    <dgm:cxn modelId="{4E7C4957-7013-4E83-83C2-B10253353E78}" type="presParOf" srcId="{CDD65885-70A5-408A-AD16-60B5296FD84F}" destId="{D7399875-5945-4082-A56B-0967B2FF1CAA}" srcOrd="3" destOrd="0" presId="urn:microsoft.com/office/officeart/2005/8/layout/hChevron3"/>
+    <dgm:cxn modelId="{FB86EB6A-5434-47EA-AB12-3A0CDAB33EE4}" type="presParOf" srcId="{CDD65885-70A5-408A-AD16-60B5296FD84F}" destId="{0FFC9F85-D342-4563-A0C2-89C6B83FD375}" srcOrd="4" destOrd="0" presId="urn:microsoft.com/office/officeart/2005/8/layout/hChevron3"/>
+    <dgm:cxn modelId="{78C80DD3-464A-4A52-99A1-54586C54E2F3}" type="presParOf" srcId="{CDD65885-70A5-408A-AD16-60B5296FD84F}" destId="{00AD2CC1-E211-4CFF-A9B2-67FC64D14459}" srcOrd="5" destOrd="0" presId="urn:microsoft.com/office/officeart/2005/8/layout/hChevron3"/>
+    <dgm:cxn modelId="{6ACBF150-7D73-4DED-A989-4E37B02A320F}" type="presParOf" srcId="{CDD65885-70A5-408A-AD16-60B5296FD84F}" destId="{903FC15E-8A12-4ACF-90BF-441209C11D87}" srcOrd="6" destOrd="0" presId="urn:microsoft.com/office/officeart/2005/8/layout/hChevron3"/>
+  </dgm:cxnLst>
+  <dgm:bg/>
+  <dgm:whole>
+    <a:ln>
+      <a:noFill/>
+    </a:ln>
+  </dgm:whole>
+  <dgm:extLst>
+    <a:ext uri="http://schemas.microsoft.com/office/drawing/2008/diagram">
+      <dsp:dataModelExt xmlns:dsp="http://schemas.microsoft.com/office/drawing/2008/diagram" relId="rId9" minVer="http://schemas.openxmlformats.org/drawingml/2006/diagram"/>
+    </a:ext>
+  </dgm:extLst>
+</dgm:dataModel>
+</file>
+
+<file path=ppt/diagrams/data3.xml><?xml version="1.0" encoding="utf-8"?>
 <dgm:dataModel xmlns:dgm="http://schemas.openxmlformats.org/drawingml/2006/diagram" xmlns:a="http://schemas.openxmlformats.org/drawingml/2006/main">
   <dgm:ptLst>
     <dgm:pt modelId="{1BAF38FA-668C-42FF-833B-8125D0660C5A}" type="doc">
@@ -3059,6 +4118,303 @@
 </dsp:drawing>
 </file>
 
+<file path=ppt/diagrams/drawing3.xml><?xml version="1.0" encoding="utf-8"?>
+<dsp:drawing xmlns:dgm="http://schemas.openxmlformats.org/drawingml/2006/diagram" xmlns:dsp="http://schemas.microsoft.com/office/drawing/2008/diagram" xmlns:a="http://schemas.openxmlformats.org/drawingml/2006/main">
+  <dsp:spTree>
+    <dsp:nvGrpSpPr>
+      <dsp:cNvPr id="0" name=""/>
+      <dsp:cNvGrpSpPr/>
+    </dsp:nvGrpSpPr>
+    <dsp:grpSpPr/>
+    <dsp:sp modelId="{3B3B9CF9-ACCC-4AAF-B159-A5ECCE9F91FA}">
+      <dsp:nvSpPr>
+        <dsp:cNvPr id="0" name=""/>
+        <dsp:cNvSpPr/>
+      </dsp:nvSpPr>
+      <dsp:spPr>
+        <a:xfrm>
+          <a:off x="2381" y="226207"/>
+          <a:ext cx="2389187" cy="955675"/>
+        </a:xfrm>
+        <a:prstGeom prst="homePlate">
+          <a:avLst/>
+        </a:prstGeom>
+        <a:solidFill>
+          <a:schemeClr val="accent1">
+            <a:hueOff val="0"/>
+            <a:satOff val="0"/>
+            <a:lumOff val="0"/>
+            <a:alphaOff val="0"/>
+          </a:schemeClr>
+        </a:solidFill>
+        <a:ln w="19050" cap="rnd" cmpd="sng" algn="ctr">
+          <a:solidFill>
+            <a:schemeClr val="accent6">
+              <a:lumMod val="75000"/>
+            </a:schemeClr>
+          </a:solidFill>
+          <a:prstDash val="solid"/>
+        </a:ln>
+        <a:effectLst/>
+      </dsp:spPr>
+      <dsp:style>
+        <a:lnRef idx="2">
+          <a:scrgbClr r="0" g="0" b="0"/>
+        </a:lnRef>
+        <a:fillRef idx="1">
+          <a:scrgbClr r="0" g="0" b="0"/>
+        </a:fillRef>
+        <a:effectRef idx="0">
+          <a:scrgbClr r="0" g="0" b="0"/>
+        </a:effectRef>
+        <a:fontRef idx="minor">
+          <a:schemeClr val="lt1"/>
+        </a:fontRef>
+      </dsp:style>
+      <dsp:txBody>
+        <a:bodyPr spcFirstLastPara="0" vert="horz" wrap="square" lIns="261366" tIns="130683" rIns="65342" bIns="130683" numCol="1" spcCol="1270" anchor="ctr" anchorCtr="0">
+          <a:noAutofit/>
+        </a:bodyPr>
+        <a:lstStyle/>
+        <a:p>
+          <a:pPr marL="0" lvl="0" indent="0" algn="ctr" defTabSz="2178050">
+            <a:lnSpc>
+              <a:spcPct val="90000"/>
+            </a:lnSpc>
+            <a:spcBef>
+              <a:spcPct val="0"/>
+            </a:spcBef>
+            <a:spcAft>
+              <a:spcPct val="35000"/>
+            </a:spcAft>
+            <a:buNone/>
+          </a:pPr>
+          <a:endParaRPr lang="en-US" sz="4900" kern="1200"/>
+        </a:p>
+      </dsp:txBody>
+      <dsp:txXfrm>
+        <a:off x="2381" y="226207"/>
+        <a:ext cx="2150268" cy="955675"/>
+      </dsp:txXfrm>
+    </dsp:sp>
+    <dsp:sp modelId="{927287C2-A3D7-40DA-9CC5-879018D16C6C}">
+      <dsp:nvSpPr>
+        <dsp:cNvPr id="0" name=""/>
+        <dsp:cNvSpPr/>
+      </dsp:nvSpPr>
+      <dsp:spPr>
+        <a:xfrm>
+          <a:off x="1913731" y="226207"/>
+          <a:ext cx="2389187" cy="955675"/>
+        </a:xfrm>
+        <a:prstGeom prst="chevron">
+          <a:avLst/>
+        </a:prstGeom>
+        <a:solidFill>
+          <a:srgbClr val="ACD433">
+            <a:hueOff val="0"/>
+            <a:satOff val="0"/>
+            <a:lumOff val="0"/>
+            <a:alphaOff val="0"/>
+          </a:srgbClr>
+        </a:solidFill>
+        <a:ln w="19050" cap="rnd" cmpd="sng" algn="ctr">
+          <a:solidFill>
+            <a:schemeClr val="accent6">
+              <a:lumMod val="75000"/>
+            </a:schemeClr>
+          </a:solidFill>
+          <a:prstDash val="solid"/>
+        </a:ln>
+        <a:effectLst/>
+      </dsp:spPr>
+      <dsp:style>
+        <a:lnRef idx="2">
+          <a:scrgbClr r="0" g="0" b="0"/>
+        </a:lnRef>
+        <a:fillRef idx="1">
+          <a:scrgbClr r="0" g="0" b="0"/>
+        </a:fillRef>
+        <a:effectRef idx="0">
+          <a:scrgbClr r="0" g="0" b="0"/>
+        </a:effectRef>
+        <a:fontRef idx="minor">
+          <a:schemeClr val="lt1"/>
+        </a:fontRef>
+      </dsp:style>
+      <dsp:txBody>
+        <a:bodyPr spcFirstLastPara="0" vert="horz" wrap="square" lIns="261366" tIns="130683" rIns="65342" bIns="130683" numCol="1" spcCol="1270" anchor="ctr" anchorCtr="0">
+          <a:noAutofit/>
+        </a:bodyPr>
+        <a:lstStyle/>
+        <a:p>
+          <a:pPr marL="0" lvl="0" indent="0" algn="ctr" defTabSz="2178050">
+            <a:lnSpc>
+              <a:spcPct val="90000"/>
+            </a:lnSpc>
+            <a:spcBef>
+              <a:spcPct val="0"/>
+            </a:spcBef>
+            <a:spcAft>
+              <a:spcPct val="35000"/>
+            </a:spcAft>
+            <a:buNone/>
+          </a:pPr>
+          <a:endParaRPr lang="en-US" sz="4900" kern="1200" dirty="0">
+            <a:solidFill>
+              <a:prstClr val="white"/>
+            </a:solidFill>
+            <a:latin typeface="Century Gothic" panose="020B0502020202020204"/>
+            <a:ea typeface="+mn-ea"/>
+            <a:cs typeface="+mn-cs"/>
+          </a:endParaRPr>
+        </a:p>
+      </dsp:txBody>
+      <dsp:txXfrm>
+        <a:off x="2391569" y="226207"/>
+        <a:ext cx="1433512" cy="955675"/>
+      </dsp:txXfrm>
+    </dsp:sp>
+    <dsp:sp modelId="{0FFC9F85-D342-4563-A0C2-89C6B83FD375}">
+      <dsp:nvSpPr>
+        <dsp:cNvPr id="0" name=""/>
+        <dsp:cNvSpPr/>
+      </dsp:nvSpPr>
+      <dsp:spPr>
+        <a:xfrm>
+          <a:off x="3825081" y="226207"/>
+          <a:ext cx="2389187" cy="955675"/>
+        </a:xfrm>
+        <a:prstGeom prst="chevron">
+          <a:avLst/>
+        </a:prstGeom>
+        <a:solidFill>
+          <a:schemeClr val="tx1">
+            <a:lumMod val="95000"/>
+          </a:schemeClr>
+        </a:solidFill>
+        <a:ln w="19050" cap="rnd" cmpd="sng" algn="ctr">
+          <a:solidFill>
+            <a:schemeClr val="accent6">
+              <a:lumMod val="75000"/>
+            </a:schemeClr>
+          </a:solidFill>
+          <a:prstDash val="solid"/>
+        </a:ln>
+        <a:effectLst/>
+      </dsp:spPr>
+      <dsp:style>
+        <a:lnRef idx="2">
+          <a:scrgbClr r="0" g="0" b="0"/>
+        </a:lnRef>
+        <a:fillRef idx="1">
+          <a:scrgbClr r="0" g="0" b="0"/>
+        </a:fillRef>
+        <a:effectRef idx="0">
+          <a:scrgbClr r="0" g="0" b="0"/>
+        </a:effectRef>
+        <a:fontRef idx="minor">
+          <a:schemeClr val="lt1"/>
+        </a:fontRef>
+      </dsp:style>
+      <dsp:txBody>
+        <a:bodyPr spcFirstLastPara="0" vert="horz" wrap="square" lIns="196025" tIns="130683" rIns="65342" bIns="130683" numCol="1" spcCol="1270" anchor="ctr" anchorCtr="0">
+          <a:noAutofit/>
+        </a:bodyPr>
+        <a:lstStyle/>
+        <a:p>
+          <a:pPr marL="0" lvl="0" indent="0" algn="ctr" defTabSz="2178050">
+            <a:lnSpc>
+              <a:spcPct val="90000"/>
+            </a:lnSpc>
+            <a:spcBef>
+              <a:spcPct val="0"/>
+            </a:spcBef>
+            <a:spcAft>
+              <a:spcPct val="35000"/>
+            </a:spcAft>
+            <a:buNone/>
+          </a:pPr>
+          <a:endParaRPr lang="en-US" sz="4900" kern="1200" dirty="0"/>
+        </a:p>
+      </dsp:txBody>
+      <dsp:txXfrm>
+        <a:off x="4302919" y="226207"/>
+        <a:ext cx="1433512" cy="955675"/>
+      </dsp:txXfrm>
+    </dsp:sp>
+    <dsp:sp modelId="{903FC15E-8A12-4ACF-90BF-441209C11D87}">
+      <dsp:nvSpPr>
+        <dsp:cNvPr id="0" name=""/>
+        <dsp:cNvSpPr/>
+      </dsp:nvSpPr>
+      <dsp:spPr>
+        <a:xfrm>
+          <a:off x="5736431" y="226207"/>
+          <a:ext cx="2389187" cy="955675"/>
+        </a:xfrm>
+        <a:prstGeom prst="chevron">
+          <a:avLst/>
+        </a:prstGeom>
+        <a:solidFill>
+          <a:schemeClr val="tx1">
+            <a:lumMod val="95000"/>
+          </a:schemeClr>
+        </a:solidFill>
+        <a:ln w="19050" cap="rnd" cmpd="sng" algn="ctr">
+          <a:solidFill>
+            <a:schemeClr val="accent6">
+              <a:lumMod val="75000"/>
+            </a:schemeClr>
+          </a:solidFill>
+          <a:prstDash val="solid"/>
+        </a:ln>
+        <a:effectLst/>
+      </dsp:spPr>
+      <dsp:style>
+        <a:lnRef idx="2">
+          <a:scrgbClr r="0" g="0" b="0"/>
+        </a:lnRef>
+        <a:fillRef idx="1">
+          <a:scrgbClr r="0" g="0" b="0"/>
+        </a:fillRef>
+        <a:effectRef idx="0">
+          <a:scrgbClr r="0" g="0" b="0"/>
+        </a:effectRef>
+        <a:fontRef idx="minor">
+          <a:schemeClr val="lt1"/>
+        </a:fontRef>
+      </dsp:style>
+      <dsp:txBody>
+        <a:bodyPr spcFirstLastPara="0" vert="horz" wrap="square" lIns="196025" tIns="130683" rIns="65342" bIns="130683" numCol="1" spcCol="1270" anchor="ctr" anchorCtr="0">
+          <a:noAutofit/>
+        </a:bodyPr>
+        <a:lstStyle/>
+        <a:p>
+          <a:pPr marL="0" lvl="0" indent="0" algn="ctr" defTabSz="2178050">
+            <a:lnSpc>
+              <a:spcPct val="90000"/>
+            </a:lnSpc>
+            <a:spcBef>
+              <a:spcPct val="0"/>
+            </a:spcBef>
+            <a:spcAft>
+              <a:spcPct val="35000"/>
+            </a:spcAft>
+            <a:buNone/>
+          </a:pPr>
+          <a:endParaRPr lang="en-US" sz="4900" kern="1200" dirty="0"/>
+        </a:p>
+      </dsp:txBody>
+      <dsp:txXfrm>
+        <a:off x="6214269" y="226207"/>
+        <a:ext cx="1433512" cy="955675"/>
+      </dsp:txXfrm>
+    </dsp:sp>
+  </dsp:spTree>
+</dsp:drawing>
+</file>
+
 <file path=ppt/diagrams/layout1.xml><?xml version="1.0" encoding="utf-8"?>
 <dgm:layoutDef xmlns:dgm="http://schemas.openxmlformats.org/drawingml/2006/diagram" xmlns:a="http://schemas.openxmlformats.org/drawingml/2006/main" uniqueId="urn:microsoft.com/office/officeart/2005/8/layout/hChevron3">
   <dgm:title val=""/>
@@ -3603,6 +4959,278 @@
 </dgm:layoutDef>
 </file>
 
+<file path=ppt/diagrams/layout3.xml><?xml version="1.0" encoding="utf-8"?>
+<dgm:layoutDef xmlns:dgm="http://schemas.openxmlformats.org/drawingml/2006/diagram" xmlns:a="http://schemas.openxmlformats.org/drawingml/2006/main" uniqueId="urn:microsoft.com/office/officeart/2005/8/layout/hChevron3">
+  <dgm:title val=""/>
+  <dgm:desc val=""/>
+  <dgm:catLst>
+    <dgm:cat type="process" pri="10000"/>
+  </dgm:catLst>
+  <dgm:sampData useDef="1">
+    <dgm:dataModel>
+      <dgm:ptLst/>
+      <dgm:bg/>
+      <dgm:whole/>
+    </dgm:dataModel>
+  </dgm:sampData>
+  <dgm:styleData>
+    <dgm:dataModel>
+      <dgm:ptLst>
+        <dgm:pt modelId="0" type="doc"/>
+        <dgm:pt modelId="1"/>
+        <dgm:pt modelId="2"/>
+      </dgm:ptLst>
+      <dgm:cxnLst>
+        <dgm:cxn modelId="3" srcId="0" destId="1" srcOrd="0" destOrd="0"/>
+        <dgm:cxn modelId="4" srcId="0" destId="2" srcOrd="1" destOrd="0"/>
+      </dgm:cxnLst>
+      <dgm:bg/>
+      <dgm:whole/>
+    </dgm:dataModel>
+  </dgm:styleData>
+  <dgm:clrData>
+    <dgm:dataModel>
+      <dgm:ptLst>
+        <dgm:pt modelId="0" type="doc"/>
+        <dgm:pt modelId="1"/>
+        <dgm:pt modelId="2"/>
+        <dgm:pt modelId="3"/>
+        <dgm:pt modelId="4"/>
+      </dgm:ptLst>
+      <dgm:cxnLst>
+        <dgm:cxn modelId="5" srcId="0" destId="1" srcOrd="0" destOrd="0"/>
+        <dgm:cxn modelId="6" srcId="0" destId="2" srcOrd="1" destOrd="0"/>
+        <dgm:cxn modelId="7" srcId="0" destId="3" srcOrd="2" destOrd="0"/>
+        <dgm:cxn modelId="8" srcId="0" destId="4" srcOrd="3" destOrd="0"/>
+      </dgm:cxnLst>
+      <dgm:bg/>
+      <dgm:whole/>
+    </dgm:dataModel>
+  </dgm:clrData>
+  <dgm:layoutNode name="Name0">
+    <dgm:varLst>
+      <dgm:dir/>
+      <dgm:resizeHandles val="exact"/>
+    </dgm:varLst>
+    <dgm:choose name="Name1">
+      <dgm:if name="Name2" func="var" arg="dir" op="equ" val="norm">
+        <dgm:alg type="lin"/>
+      </dgm:if>
+      <dgm:else name="Name3">
+        <dgm:alg type="lin">
+          <dgm:param type="linDir" val="fromR"/>
+        </dgm:alg>
+      </dgm:else>
+    </dgm:choose>
+    <dgm:shape xmlns:r="http://schemas.openxmlformats.org/officeDocument/2006/relationships" r:blip="">
+      <dgm:adjLst/>
+    </dgm:shape>
+    <dgm:presOf/>
+    <dgm:choose name="Name4">
+      <dgm:if name="Name5" axis="root des" func="maxDepth" op="gte" val="2">
+        <dgm:constrLst>
+          <dgm:constr type="w" for="ch" forName="parAndChTx" refType="w"/>
+          <dgm:constr type="primFontSz" for="ch" ptType="node" op="equ"/>
+          <dgm:constr type="w" for="ch" forName="parAndChSpace" refType="w" refFor="ch" refForName="parAndChTx" fact="-0.2"/>
+          <dgm:constr type="w" for="ch" ptType="sibTrans" op="equ"/>
+        </dgm:constrLst>
+        <dgm:ruleLst/>
+        <dgm:forEach name="Name6" axis="ch" ptType="node">
+          <dgm:layoutNode name="parAndChTx">
+            <dgm:varLst>
+              <dgm:bulletEnabled val="1"/>
+            </dgm:varLst>
+            <dgm:alg type="tx"/>
+            <dgm:choose name="Name7">
+              <dgm:if name="Name8" func="var" arg="dir" op="equ" val="norm">
+                <dgm:choose name="Name9">
+                  <dgm:if name="Name10" axis="self" ptType="node" func="pos" op="equ" val="1">
+                    <dgm:shape xmlns:r="http://schemas.openxmlformats.org/officeDocument/2006/relationships" type="homePlate" r:blip="">
+                      <dgm:adjLst>
+                        <dgm:adj idx="1" val="0.25"/>
+                      </dgm:adjLst>
+                    </dgm:shape>
+                    <dgm:presOf axis="desOrSelf" ptType="node"/>
+                    <dgm:constrLst>
+                      <dgm:constr type="h" refType="w" op="equ" fact="0.8"/>
+                      <dgm:constr type="primFontSz" val="65"/>
+                      <dgm:constr type="tMarg" refType="primFontSz" fact="0.2"/>
+                      <dgm:constr type="bMarg" refType="primFontSz" fact="0.2"/>
+                      <dgm:constr type="lMarg" refType="w" fact="0.1"/>
+                      <dgm:constr type="rMarg" refType="w" fact="0.4"/>
+                    </dgm:constrLst>
+                  </dgm:if>
+                  <dgm:else name="Name11">
+                    <dgm:shape xmlns:r="http://schemas.openxmlformats.org/officeDocument/2006/relationships" type="chevron" r:blip="">
+                      <dgm:adjLst>
+                        <dgm:adj idx="1" val="0.25"/>
+                      </dgm:adjLst>
+                    </dgm:shape>
+                    <dgm:presOf axis="desOrSelf" ptType="node"/>
+                    <dgm:constrLst>
+                      <dgm:constr type="h" refType="w" op="equ" fact="0.8"/>
+                      <dgm:constr type="primFontSz" val="65"/>
+                      <dgm:constr type="tMarg" refType="primFontSz" fact="0.2"/>
+                      <dgm:constr type="bMarg" refType="primFontSz" fact="0.2"/>
+                      <dgm:constr type="lMarg" refType="w" fact="0.1"/>
+                      <dgm:constr type="rMarg" refType="w" fact="0.1"/>
+                    </dgm:constrLst>
+                  </dgm:else>
+                </dgm:choose>
+              </dgm:if>
+              <dgm:else name="Name12">
+                <dgm:choose name="Name13">
+                  <dgm:if name="Name14" axis="self" ptType="node" func="pos" op="equ" val="1">
+                    <dgm:shape xmlns:r="http://schemas.openxmlformats.org/officeDocument/2006/relationships" rot="180" type="homePlate" r:blip="">
+                      <dgm:adjLst>
+                        <dgm:adj idx="1" val="0.25"/>
+                      </dgm:adjLst>
+                    </dgm:shape>
+                    <dgm:presOf axis="desOrSelf" ptType="node"/>
+                    <dgm:constrLst>
+                      <dgm:constr type="h" refType="w" op="equ" fact="0.8"/>
+                      <dgm:constr type="primFontSz" val="65"/>
+                      <dgm:constr type="tMarg" refType="primFontSz" fact="0.2"/>
+                      <dgm:constr type="bMarg" refType="primFontSz" fact="0.2"/>
+                      <dgm:constr type="lMarg" refType="w" fact="0.4"/>
+                      <dgm:constr type="rMarg" refType="w" fact="0.1"/>
+                    </dgm:constrLst>
+                  </dgm:if>
+                  <dgm:else name="Name15">
+                    <dgm:shape xmlns:r="http://schemas.openxmlformats.org/officeDocument/2006/relationships" rot="180" type="chevron" r:blip="">
+                      <dgm:adjLst>
+                        <dgm:adj idx="1" val="0.25"/>
+                      </dgm:adjLst>
+                    </dgm:shape>
+                    <dgm:presOf axis="desOrSelf" ptType="node"/>
+                    <dgm:constrLst>
+                      <dgm:constr type="h" refType="w" op="equ" fact="0.8"/>
+                      <dgm:constr type="primFontSz" val="65"/>
+                      <dgm:constr type="tMarg" refType="primFontSz" fact="0.2"/>
+                      <dgm:constr type="bMarg" refType="primFontSz" fact="0.2"/>
+                      <dgm:constr type="lMarg" refType="w" fact="0.1"/>
+                      <dgm:constr type="rMarg" refType="w" fact="0.1"/>
+                    </dgm:constrLst>
+                  </dgm:else>
+                </dgm:choose>
+              </dgm:else>
+            </dgm:choose>
+            <dgm:ruleLst>
+              <dgm:rule type="primFontSz" val="5" fact="NaN" max="NaN"/>
+            </dgm:ruleLst>
+          </dgm:layoutNode>
+          <dgm:forEach name="Name16" axis="followSib" ptType="sibTrans" cnt="1">
+            <dgm:layoutNode name="parAndChSpace">
+              <dgm:alg type="sp"/>
+              <dgm:shape xmlns:r="http://schemas.openxmlformats.org/officeDocument/2006/relationships" r:blip="">
+                <dgm:adjLst/>
+              </dgm:shape>
+              <dgm:presOf/>
+              <dgm:constrLst/>
+              <dgm:ruleLst/>
+            </dgm:layoutNode>
+          </dgm:forEach>
+        </dgm:forEach>
+      </dgm:if>
+      <dgm:else name="Name17">
+        <dgm:constrLst>
+          <dgm:constr type="w" for="ch" forName="parTxOnly" refType="w"/>
+          <dgm:constr type="primFontSz" for="ch" ptType="node" op="equ"/>
+          <dgm:constr type="w" for="ch" forName="parSpace" refType="w" refFor="ch" refForName="parTxOnly" fact="-0.2"/>
+          <dgm:constr type="w" for="ch" ptType="sibTrans" op="equ"/>
+        </dgm:constrLst>
+        <dgm:ruleLst/>
+        <dgm:forEach name="Name18" axis="ch" ptType="node">
+          <dgm:layoutNode name="parTxOnly">
+            <dgm:varLst>
+              <dgm:bulletEnabled val="1"/>
+            </dgm:varLst>
+            <dgm:alg type="tx"/>
+            <dgm:presOf axis="desOrSelf" ptType="node"/>
+            <dgm:choose name="Name19">
+              <dgm:if name="Name20" func="var" arg="dir" op="equ" val="norm">
+                <dgm:choose name="Name21">
+                  <dgm:if name="Name22" axis="self" ptType="node" func="pos" op="equ" val="1">
+                    <dgm:shape xmlns:r="http://schemas.openxmlformats.org/officeDocument/2006/relationships" type="homePlate" r:blip="">
+                      <dgm:adjLst/>
+                    </dgm:shape>
+                    <dgm:constrLst>
+                      <dgm:constr type="h" refType="w" op="equ" fact="0.4"/>
+                      <dgm:constr type="primFontSz" val="65"/>
+                      <dgm:constr type="tMarg" refType="primFontSz" fact="0.21"/>
+                      <dgm:constr type="bMarg" refType="primFontSz" fact="0.21"/>
+                      <dgm:constr type="lMarg" refType="primFontSz" fact="0.42"/>
+                      <dgm:constr type="rMarg" refType="primFontSz" fact="0.105"/>
+                    </dgm:constrLst>
+                  </dgm:if>
+                  <dgm:else name="Name23">
+                    <dgm:shape xmlns:r="http://schemas.openxmlformats.org/officeDocument/2006/relationships" type="chevron" r:blip="">
+                      <dgm:adjLst/>
+                    </dgm:shape>
+                    <dgm:constrLst>
+                      <dgm:constr type="h" refType="w" op="equ" fact="0.4"/>
+                      <dgm:constr type="primFontSz" val="65"/>
+                      <dgm:constr type="tMarg" refType="primFontSz" fact="0.21"/>
+                      <dgm:constr type="bMarg" refType="primFontSz" fact="0.21"/>
+                      <dgm:constr type="lMarg" refType="primFontSz" fact="0.315"/>
+                      <dgm:constr type="rMarg" refType="primFontSz" fact="0.105"/>
+                    </dgm:constrLst>
+                  </dgm:else>
+                </dgm:choose>
+              </dgm:if>
+              <dgm:else name="Name24">
+                <dgm:choose name="Name25">
+                  <dgm:if name="Name26" axis="self" ptType="node" func="pos" op="equ" val="1">
+                    <dgm:shape xmlns:r="http://schemas.openxmlformats.org/officeDocument/2006/relationships" rot="180" type="homePlate" r:blip="">
+                      <dgm:adjLst/>
+                    </dgm:shape>
+                    <dgm:constrLst>
+                      <dgm:constr type="h" refType="w" op="equ" fact="0.4"/>
+                      <dgm:constr type="primFontSz" val="65"/>
+                      <dgm:constr type="tMarg" refType="primFontSz" fact="0.21"/>
+                      <dgm:constr type="bMarg" refType="primFontSz" fact="0.21"/>
+                      <dgm:constr type="lMarg" refType="primFontSz" fact="0.105"/>
+                      <dgm:constr type="rMarg" refType="primFontSz" fact="0.42"/>
+                    </dgm:constrLst>
+                  </dgm:if>
+                  <dgm:else name="Name27">
+                    <dgm:shape xmlns:r="http://schemas.openxmlformats.org/officeDocument/2006/relationships" rot="180" type="chevron" r:blip="">
+                      <dgm:adjLst/>
+                    </dgm:shape>
+                    <dgm:constrLst>
+                      <dgm:constr type="h" refType="w" op="equ" fact="0.4"/>
+                      <dgm:constr type="primFontSz" val="65"/>
+                      <dgm:constr type="tMarg" refType="primFontSz" fact="0.21"/>
+                      <dgm:constr type="bMarg" refType="primFontSz" fact="0.21"/>
+                      <dgm:constr type="lMarg" refType="primFontSz" fact="0.105"/>
+                      <dgm:constr type="rMarg" refType="primFontSz" fact="0.315"/>
+                    </dgm:constrLst>
+                  </dgm:else>
+                </dgm:choose>
+              </dgm:else>
+            </dgm:choose>
+            <dgm:ruleLst>
+              <dgm:rule type="primFontSz" val="5" fact="NaN" max="NaN"/>
+            </dgm:ruleLst>
+          </dgm:layoutNode>
+          <dgm:forEach name="Name28" axis="followSib" ptType="sibTrans" cnt="1">
+            <dgm:layoutNode name="parSpace">
+              <dgm:alg type="sp"/>
+              <dgm:shape xmlns:r="http://schemas.openxmlformats.org/officeDocument/2006/relationships" r:blip="">
+                <dgm:adjLst/>
+              </dgm:shape>
+              <dgm:presOf/>
+              <dgm:constrLst/>
+              <dgm:ruleLst/>
+            </dgm:layoutNode>
+          </dgm:forEach>
+        </dgm:forEach>
+      </dgm:else>
+    </dgm:choose>
+  </dgm:layoutNode>
+</dgm:layoutDef>
+</file>
+
 <file path=ppt/diagrams/quickStyle1.xml><?xml version="1.0" encoding="utf-8"?>
 <dgm:styleDef xmlns:dgm="http://schemas.openxmlformats.org/drawingml/2006/diagram" xmlns:a="http://schemas.openxmlformats.org/drawingml/2006/main" uniqueId="urn:microsoft.com/office/officeart/2005/8/quickstyle/3d2">
   <dgm:title val=""/>
@@ -4866,6 +6494,1040 @@
 </file>
 
 <file path=ppt/diagrams/quickStyle2.xml><?xml version="1.0" encoding="utf-8"?>
+<dgm:styleDef xmlns:dgm="http://schemas.openxmlformats.org/drawingml/2006/diagram" xmlns:a="http://schemas.openxmlformats.org/drawingml/2006/main" uniqueId="urn:microsoft.com/office/officeart/2005/8/quickstyle/simple1">
+  <dgm:title val=""/>
+  <dgm:desc val=""/>
+  <dgm:catLst>
+    <dgm:cat type="simple" pri="10100"/>
+  </dgm:catLst>
+  <dgm:scene3d>
+    <a:camera prst="orthographicFront"/>
+    <a:lightRig rig="threePt" dir="t"/>
+  </dgm:scene3d>
+  <dgm:styleLbl name="node0">
+    <dgm:scene3d>
+      <a:camera prst="orthographicFront"/>
+      <a:lightRig rig="threePt" dir="t"/>
+    </dgm:scene3d>
+    <dgm:sp3d/>
+    <dgm:txPr/>
+    <dgm:style>
+      <a:lnRef idx="2">
+        <a:scrgbClr r="0" g="0" b="0"/>
+      </a:lnRef>
+      <a:fillRef idx="1">
+        <a:scrgbClr r="0" g="0" b="0"/>
+      </a:fillRef>
+      <a:effectRef idx="0">
+        <a:scrgbClr r="0" g="0" b="0"/>
+      </a:effectRef>
+      <a:fontRef idx="minor">
+        <a:schemeClr val="lt1"/>
+      </a:fontRef>
+    </dgm:style>
+  </dgm:styleLbl>
+  <dgm:styleLbl name="lnNode1">
+    <dgm:scene3d>
+      <a:camera prst="orthographicFront"/>
+      <a:lightRig rig="threePt" dir="t"/>
+    </dgm:scene3d>
+    <dgm:sp3d/>
+    <dgm:txPr/>
+    <dgm:style>
+      <a:lnRef idx="2">
+        <a:scrgbClr r="0" g="0" b="0"/>
+      </a:lnRef>
+      <a:fillRef idx="1">
+        <a:scrgbClr r="0" g="0" b="0"/>
+      </a:fillRef>
+      <a:effectRef idx="0">
+        <a:scrgbClr r="0" g="0" b="0"/>
+      </a:effectRef>
+      <a:fontRef idx="minor">
+        <a:schemeClr val="lt1"/>
+      </a:fontRef>
+    </dgm:style>
+  </dgm:styleLbl>
+  <dgm:styleLbl name="vennNode1">
+    <dgm:scene3d>
+      <a:camera prst="orthographicFront"/>
+      <a:lightRig rig="threePt" dir="t"/>
+    </dgm:scene3d>
+    <dgm:sp3d/>
+    <dgm:txPr/>
+    <dgm:style>
+      <a:lnRef idx="2">
+        <a:scrgbClr r="0" g="0" b="0"/>
+      </a:lnRef>
+      <a:fillRef idx="1">
+        <a:scrgbClr r="0" g="0" b="0"/>
+      </a:fillRef>
+      <a:effectRef idx="0">
+        <a:scrgbClr r="0" g="0" b="0"/>
+      </a:effectRef>
+      <a:fontRef idx="minor">
+        <a:schemeClr val="tx1"/>
+      </a:fontRef>
+    </dgm:style>
+  </dgm:styleLbl>
+  <dgm:styleLbl name="alignNode1">
+    <dgm:scene3d>
+      <a:camera prst="orthographicFront"/>
+      <a:lightRig rig="threePt" dir="t"/>
+    </dgm:scene3d>
+    <dgm:sp3d/>
+    <dgm:txPr/>
+    <dgm:style>
+      <a:lnRef idx="2">
+        <a:scrgbClr r="0" g="0" b="0"/>
+      </a:lnRef>
+      <a:fillRef idx="1">
+        <a:scrgbClr r="0" g="0" b="0"/>
+      </a:fillRef>
+      <a:effectRef idx="0">
+        <a:scrgbClr r="0" g="0" b="0"/>
+      </a:effectRef>
+      <a:fontRef idx="minor">
+        <a:schemeClr val="lt1"/>
+      </a:fontRef>
+    </dgm:style>
+  </dgm:styleLbl>
+  <dgm:styleLbl name="node1">
+    <dgm:scene3d>
+      <a:camera prst="orthographicFront"/>
+      <a:lightRig rig="threePt" dir="t"/>
+    </dgm:scene3d>
+    <dgm:sp3d/>
+    <dgm:txPr/>
+    <dgm:style>
+      <a:lnRef idx="2">
+        <a:scrgbClr r="0" g="0" b="0"/>
+      </a:lnRef>
+      <a:fillRef idx="1">
+        <a:scrgbClr r="0" g="0" b="0"/>
+      </a:fillRef>
+      <a:effectRef idx="0">
+        <a:scrgbClr r="0" g="0" b="0"/>
+      </a:effectRef>
+      <a:fontRef idx="minor">
+        <a:schemeClr val="lt1"/>
+      </a:fontRef>
+    </dgm:style>
+  </dgm:styleLbl>
+  <dgm:styleLbl name="node2">
+    <dgm:scene3d>
+      <a:camera prst="orthographicFront"/>
+      <a:lightRig rig="threePt" dir="t"/>
+    </dgm:scene3d>
+    <dgm:sp3d/>
+    <dgm:txPr/>
+    <dgm:style>
+      <a:lnRef idx="2">
+        <a:scrgbClr r="0" g="0" b="0"/>
+      </a:lnRef>
+      <a:fillRef idx="1">
+        <a:scrgbClr r="0" g="0" b="0"/>
+      </a:fillRef>
+      <a:effectRef idx="0">
+        <a:scrgbClr r="0" g="0" b="0"/>
+      </a:effectRef>
+      <a:fontRef idx="minor">
+        <a:schemeClr val="lt1"/>
+      </a:fontRef>
+    </dgm:style>
+  </dgm:styleLbl>
+  <dgm:styleLbl name="node3">
+    <dgm:scene3d>
+      <a:camera prst="orthographicFront"/>
+      <a:lightRig rig="threePt" dir="t"/>
+    </dgm:scene3d>
+    <dgm:sp3d/>
+    <dgm:txPr/>
+    <dgm:style>
+      <a:lnRef idx="2">
+        <a:scrgbClr r="0" g="0" b="0"/>
+      </a:lnRef>
+      <a:fillRef idx="1">
+        <a:scrgbClr r="0" g="0" b="0"/>
+      </a:fillRef>
+      <a:effectRef idx="0">
+        <a:scrgbClr r="0" g="0" b="0"/>
+      </a:effectRef>
+      <a:fontRef idx="minor">
+        <a:schemeClr val="lt1"/>
+      </a:fontRef>
+    </dgm:style>
+  </dgm:styleLbl>
+  <dgm:styleLbl name="node4">
+    <dgm:scene3d>
+      <a:camera prst="orthographicFront"/>
+      <a:lightRig rig="threePt" dir="t"/>
+    </dgm:scene3d>
+    <dgm:sp3d/>
+    <dgm:txPr/>
+    <dgm:style>
+      <a:lnRef idx="2">
+        <a:scrgbClr r="0" g="0" b="0"/>
+      </a:lnRef>
+      <a:fillRef idx="1">
+        <a:scrgbClr r="0" g="0" b="0"/>
+      </a:fillRef>
+      <a:effectRef idx="0">
+        <a:scrgbClr r="0" g="0" b="0"/>
+      </a:effectRef>
+      <a:fontRef idx="minor">
+        <a:schemeClr val="lt1"/>
+      </a:fontRef>
+    </dgm:style>
+  </dgm:styleLbl>
+  <dgm:styleLbl name="fgImgPlace1">
+    <dgm:scene3d>
+      <a:camera prst="orthographicFront"/>
+      <a:lightRig rig="threePt" dir="t"/>
+    </dgm:scene3d>
+    <dgm:sp3d/>
+    <dgm:txPr/>
+    <dgm:style>
+      <a:lnRef idx="2">
+        <a:scrgbClr r="0" g="0" b="0"/>
+      </a:lnRef>
+      <a:fillRef idx="1">
+        <a:scrgbClr r="0" g="0" b="0"/>
+      </a:fillRef>
+      <a:effectRef idx="0">
+        <a:scrgbClr r="0" g="0" b="0"/>
+      </a:effectRef>
+      <a:fontRef idx="minor"/>
+    </dgm:style>
+  </dgm:styleLbl>
+  <dgm:styleLbl name="alignImgPlace1">
+    <dgm:scene3d>
+      <a:camera prst="orthographicFront"/>
+      <a:lightRig rig="threePt" dir="t"/>
+    </dgm:scene3d>
+    <dgm:sp3d/>
+    <dgm:txPr/>
+    <dgm:style>
+      <a:lnRef idx="2">
+        <a:scrgbClr r="0" g="0" b="0"/>
+      </a:lnRef>
+      <a:fillRef idx="1">
+        <a:scrgbClr r="0" g="0" b="0"/>
+      </a:fillRef>
+      <a:effectRef idx="0">
+        <a:scrgbClr r="0" g="0" b="0"/>
+      </a:effectRef>
+      <a:fontRef idx="minor"/>
+    </dgm:style>
+  </dgm:styleLbl>
+  <dgm:styleLbl name="bgImgPlace1">
+    <dgm:scene3d>
+      <a:camera prst="orthographicFront"/>
+      <a:lightRig rig="threePt" dir="t"/>
+    </dgm:scene3d>
+    <dgm:sp3d/>
+    <dgm:txPr/>
+    <dgm:style>
+      <a:lnRef idx="2">
+        <a:scrgbClr r="0" g="0" b="0"/>
+      </a:lnRef>
+      <a:fillRef idx="1">
+        <a:scrgbClr r="0" g="0" b="0"/>
+      </a:fillRef>
+      <a:effectRef idx="0">
+        <a:scrgbClr r="0" g="0" b="0"/>
+      </a:effectRef>
+      <a:fontRef idx="minor"/>
+    </dgm:style>
+  </dgm:styleLbl>
+  <dgm:styleLbl name="sibTrans2D1">
+    <dgm:scene3d>
+      <a:camera prst="orthographicFront"/>
+      <a:lightRig rig="threePt" dir="t"/>
+    </dgm:scene3d>
+    <dgm:sp3d/>
+    <dgm:txPr/>
+    <dgm:style>
+      <a:lnRef idx="0">
+        <a:scrgbClr r="0" g="0" b="0"/>
+      </a:lnRef>
+      <a:fillRef idx="1">
+        <a:scrgbClr r="0" g="0" b="0"/>
+      </a:fillRef>
+      <a:effectRef idx="0">
+        <a:scrgbClr r="0" g="0" b="0"/>
+      </a:effectRef>
+      <a:fontRef idx="minor">
+        <a:schemeClr val="lt1"/>
+      </a:fontRef>
+    </dgm:style>
+  </dgm:styleLbl>
+  <dgm:styleLbl name="fgSibTrans2D1">
+    <dgm:scene3d>
+      <a:camera prst="orthographicFront"/>
+      <a:lightRig rig="threePt" dir="t"/>
+    </dgm:scene3d>
+    <dgm:sp3d/>
+    <dgm:txPr/>
+    <dgm:style>
+      <a:lnRef idx="0">
+        <a:scrgbClr r="0" g="0" b="0"/>
+      </a:lnRef>
+      <a:fillRef idx="1">
+        <a:scrgbClr r="0" g="0" b="0"/>
+      </a:fillRef>
+      <a:effectRef idx="0">
+        <a:scrgbClr r="0" g="0" b="0"/>
+      </a:effectRef>
+      <a:fontRef idx="minor">
+        <a:schemeClr val="lt1"/>
+      </a:fontRef>
+    </dgm:style>
+  </dgm:styleLbl>
+  <dgm:styleLbl name="bgSibTrans2D1">
+    <dgm:scene3d>
+      <a:camera prst="orthographicFront"/>
+      <a:lightRig rig="threePt" dir="t"/>
+    </dgm:scene3d>
+    <dgm:sp3d/>
+    <dgm:txPr/>
+    <dgm:style>
+      <a:lnRef idx="0">
+        <a:scrgbClr r="0" g="0" b="0"/>
+      </a:lnRef>
+      <a:fillRef idx="1">
+        <a:scrgbClr r="0" g="0" b="0"/>
+      </a:fillRef>
+      <a:effectRef idx="0">
+        <a:scrgbClr r="0" g="0" b="0"/>
+      </a:effectRef>
+      <a:fontRef idx="minor">
+        <a:schemeClr val="lt1"/>
+      </a:fontRef>
+    </dgm:style>
+  </dgm:styleLbl>
+  <dgm:styleLbl name="sibTrans1D1">
+    <dgm:scene3d>
+      <a:camera prst="orthographicFront"/>
+      <a:lightRig rig="threePt" dir="t"/>
+    </dgm:scene3d>
+    <dgm:sp3d/>
+    <dgm:txPr/>
+    <dgm:style>
+      <a:lnRef idx="1">
+        <a:scrgbClr r="0" g="0" b="0"/>
+      </a:lnRef>
+      <a:fillRef idx="0">
+        <a:scrgbClr r="0" g="0" b="0"/>
+      </a:fillRef>
+      <a:effectRef idx="0">
+        <a:scrgbClr r="0" g="0" b="0"/>
+      </a:effectRef>
+      <a:fontRef idx="minor"/>
+    </dgm:style>
+  </dgm:styleLbl>
+  <dgm:styleLbl name="callout">
+    <dgm:scene3d>
+      <a:camera prst="orthographicFront"/>
+      <a:lightRig rig="threePt" dir="t"/>
+    </dgm:scene3d>
+    <dgm:sp3d/>
+    <dgm:txPr/>
+    <dgm:style>
+      <a:lnRef idx="2">
+        <a:scrgbClr r="0" g="0" b="0"/>
+      </a:lnRef>
+      <a:fillRef idx="1">
+        <a:scrgbClr r="0" g="0" b="0"/>
+      </a:fillRef>
+      <a:effectRef idx="0">
+        <a:scrgbClr r="0" g="0" b="0"/>
+      </a:effectRef>
+      <a:fontRef idx="minor"/>
+    </dgm:style>
+  </dgm:styleLbl>
+  <dgm:styleLbl name="asst0">
+    <dgm:scene3d>
+      <a:camera prst="orthographicFront"/>
+      <a:lightRig rig="threePt" dir="t"/>
+    </dgm:scene3d>
+    <dgm:sp3d/>
+    <dgm:txPr/>
+    <dgm:style>
+      <a:lnRef idx="2">
+        <a:scrgbClr r="0" g="0" b="0"/>
+      </a:lnRef>
+      <a:fillRef idx="1">
+        <a:scrgbClr r="0" g="0" b="0"/>
+      </a:fillRef>
+      <a:effectRef idx="0">
+        <a:scrgbClr r="0" g="0" b="0"/>
+      </a:effectRef>
+      <a:fontRef idx="minor">
+        <a:schemeClr val="lt1"/>
+      </a:fontRef>
+    </dgm:style>
+  </dgm:styleLbl>
+  <dgm:styleLbl name="asst1">
+    <dgm:scene3d>
+      <a:camera prst="orthographicFront"/>
+      <a:lightRig rig="threePt" dir="t"/>
+    </dgm:scene3d>
+    <dgm:sp3d/>
+    <dgm:txPr/>
+    <dgm:style>
+      <a:lnRef idx="2">
+        <a:scrgbClr r="0" g="0" b="0"/>
+      </a:lnRef>
+      <a:fillRef idx="1">
+        <a:scrgbClr r="0" g="0" b="0"/>
+      </a:fillRef>
+      <a:effectRef idx="0">
+        <a:scrgbClr r="0" g="0" b="0"/>
+      </a:effectRef>
+      <a:fontRef idx="minor">
+        <a:schemeClr val="lt1"/>
+      </a:fontRef>
+    </dgm:style>
+  </dgm:styleLbl>
+  <dgm:styleLbl name="asst2">
+    <dgm:scene3d>
+      <a:camera prst="orthographicFront"/>
+      <a:lightRig rig="threePt" dir="t"/>
+    </dgm:scene3d>
+    <dgm:sp3d/>
+    <dgm:txPr/>
+    <dgm:style>
+      <a:lnRef idx="2">
+        <a:scrgbClr r="0" g="0" b="0"/>
+      </a:lnRef>
+      <a:fillRef idx="1">
+        <a:scrgbClr r="0" g="0" b="0"/>
+      </a:fillRef>
+      <a:effectRef idx="0">
+        <a:scrgbClr r="0" g="0" b="0"/>
+      </a:effectRef>
+      <a:fontRef idx="minor">
+        <a:schemeClr val="lt1"/>
+      </a:fontRef>
+    </dgm:style>
+  </dgm:styleLbl>
+  <dgm:styleLbl name="asst3">
+    <dgm:scene3d>
+      <a:camera prst="orthographicFront"/>
+      <a:lightRig rig="threePt" dir="t"/>
+    </dgm:scene3d>
+    <dgm:sp3d/>
+    <dgm:txPr/>
+    <dgm:style>
+      <a:lnRef idx="2">
+        <a:scrgbClr r="0" g="0" b="0"/>
+      </a:lnRef>
+      <a:fillRef idx="1">
+        <a:scrgbClr r="0" g="0" b="0"/>
+      </a:fillRef>
+      <a:effectRef idx="0">
+        <a:scrgbClr r="0" g="0" b="0"/>
+      </a:effectRef>
+      <a:fontRef idx="minor">
+        <a:schemeClr val="lt1"/>
+      </a:fontRef>
+    </dgm:style>
+  </dgm:styleLbl>
+  <dgm:styleLbl name="asst4">
+    <dgm:scene3d>
+      <a:camera prst="orthographicFront"/>
+      <a:lightRig rig="threePt" dir="t"/>
+    </dgm:scene3d>
+    <dgm:sp3d/>
+    <dgm:txPr/>
+    <dgm:style>
+      <a:lnRef idx="2">
+        <a:scrgbClr r="0" g="0" b="0"/>
+      </a:lnRef>
+      <a:fillRef idx="1">
+        <a:scrgbClr r="0" g="0" b="0"/>
+      </a:fillRef>
+      <a:effectRef idx="0">
+        <a:scrgbClr r="0" g="0" b="0"/>
+      </a:effectRef>
+      <a:fontRef idx="minor">
+        <a:schemeClr val="lt1"/>
+      </a:fontRef>
+    </dgm:style>
+  </dgm:styleLbl>
+  <dgm:styleLbl name="parChTrans2D1">
+    <dgm:scene3d>
+      <a:camera prst="orthographicFront"/>
+      <a:lightRig rig="threePt" dir="t"/>
+    </dgm:scene3d>
+    <dgm:sp3d/>
+    <dgm:txPr/>
+    <dgm:style>
+      <a:lnRef idx="2">
+        <a:scrgbClr r="0" g="0" b="0"/>
+      </a:lnRef>
+      <a:fillRef idx="1">
+        <a:scrgbClr r="0" g="0" b="0"/>
+      </a:fillRef>
+      <a:effectRef idx="0">
+        <a:scrgbClr r="0" g="0" b="0"/>
+      </a:effectRef>
+      <a:fontRef idx="minor">
+        <a:schemeClr val="lt1"/>
+      </a:fontRef>
+    </dgm:style>
+  </dgm:styleLbl>
+  <dgm:styleLbl name="parChTrans2D2">
+    <dgm:scene3d>
+      <a:camera prst="orthographicFront"/>
+      <a:lightRig rig="threePt" dir="t"/>
+    </dgm:scene3d>
+    <dgm:sp3d/>
+    <dgm:txPr/>
+    <dgm:style>
+      <a:lnRef idx="2">
+        <a:scrgbClr r="0" g="0" b="0"/>
+      </a:lnRef>
+      <a:fillRef idx="1">
+        <a:scrgbClr r="0" g="0" b="0"/>
+      </a:fillRef>
+      <a:effectRef idx="0">
+        <a:scrgbClr r="0" g="0" b="0"/>
+      </a:effectRef>
+      <a:fontRef idx="minor">
+        <a:schemeClr val="lt1"/>
+      </a:fontRef>
+    </dgm:style>
+  </dgm:styleLbl>
+  <dgm:styleLbl name="parChTrans2D3">
+    <dgm:scene3d>
+      <a:camera prst="orthographicFront"/>
+      <a:lightRig rig="threePt" dir="t"/>
+    </dgm:scene3d>
+    <dgm:sp3d/>
+    <dgm:txPr/>
+    <dgm:style>
+      <a:lnRef idx="2">
+        <a:scrgbClr r="0" g="0" b="0"/>
+      </a:lnRef>
+      <a:fillRef idx="1">
+        <a:scrgbClr r="0" g="0" b="0"/>
+      </a:fillRef>
+      <a:effectRef idx="0">
+        <a:scrgbClr r="0" g="0" b="0"/>
+      </a:effectRef>
+      <a:fontRef idx="minor">
+        <a:schemeClr val="lt1"/>
+      </a:fontRef>
+    </dgm:style>
+  </dgm:styleLbl>
+  <dgm:styleLbl name="parChTrans2D4">
+    <dgm:scene3d>
+      <a:camera prst="orthographicFront"/>
+      <a:lightRig rig="threePt" dir="t"/>
+    </dgm:scene3d>
+    <dgm:sp3d/>
+    <dgm:txPr/>
+    <dgm:style>
+      <a:lnRef idx="2">
+        <a:scrgbClr r="0" g="0" b="0"/>
+      </a:lnRef>
+      <a:fillRef idx="1">
+        <a:scrgbClr r="0" g="0" b="0"/>
+      </a:fillRef>
+      <a:effectRef idx="0">
+        <a:scrgbClr r="0" g="0" b="0"/>
+      </a:effectRef>
+      <a:fontRef idx="minor">
+        <a:schemeClr val="lt1"/>
+      </a:fontRef>
+    </dgm:style>
+  </dgm:styleLbl>
+  <dgm:styleLbl name="parChTrans1D1">
+    <dgm:scene3d>
+      <a:camera prst="orthographicFront"/>
+      <a:lightRig rig="threePt" dir="t"/>
+    </dgm:scene3d>
+    <dgm:sp3d/>
+    <dgm:txPr/>
+    <dgm:style>
+      <a:lnRef idx="2">
+        <a:scrgbClr r="0" g="0" b="0"/>
+      </a:lnRef>
+      <a:fillRef idx="0">
+        <a:scrgbClr r="0" g="0" b="0"/>
+      </a:fillRef>
+      <a:effectRef idx="0">
+        <a:scrgbClr r="0" g="0" b="0"/>
+      </a:effectRef>
+      <a:fontRef idx="minor"/>
+    </dgm:style>
+  </dgm:styleLbl>
+  <dgm:styleLbl name="parChTrans1D2">
+    <dgm:scene3d>
+      <a:camera prst="orthographicFront"/>
+      <a:lightRig rig="threePt" dir="t"/>
+    </dgm:scene3d>
+    <dgm:sp3d/>
+    <dgm:txPr/>
+    <dgm:style>
+      <a:lnRef idx="2">
+        <a:scrgbClr r="0" g="0" b="0"/>
+      </a:lnRef>
+      <a:fillRef idx="0">
+        <a:scrgbClr r="0" g="0" b="0"/>
+      </a:fillRef>
+      <a:effectRef idx="0">
+        <a:scrgbClr r="0" g="0" b="0"/>
+      </a:effectRef>
+      <a:fontRef idx="minor"/>
+    </dgm:style>
+  </dgm:styleLbl>
+  <dgm:styleLbl name="parChTrans1D3">
+    <dgm:scene3d>
+      <a:camera prst="orthographicFront"/>
+      <a:lightRig rig="threePt" dir="t"/>
+    </dgm:scene3d>
+    <dgm:sp3d/>
+    <dgm:txPr/>
+    <dgm:style>
+      <a:lnRef idx="2">
+        <a:scrgbClr r="0" g="0" b="0"/>
+      </a:lnRef>
+      <a:fillRef idx="0">
+        <a:scrgbClr r="0" g="0" b="0"/>
+      </a:fillRef>
+      <a:effectRef idx="0">
+        <a:scrgbClr r="0" g="0" b="0"/>
+      </a:effectRef>
+      <a:fontRef idx="minor"/>
+    </dgm:style>
+  </dgm:styleLbl>
+  <dgm:styleLbl name="parChTrans1D4">
+    <dgm:scene3d>
+      <a:camera prst="orthographicFront"/>
+      <a:lightRig rig="threePt" dir="t"/>
+    </dgm:scene3d>
+    <dgm:sp3d/>
+    <dgm:txPr/>
+    <dgm:style>
+      <a:lnRef idx="2">
+        <a:scrgbClr r="0" g="0" b="0"/>
+      </a:lnRef>
+      <a:fillRef idx="0">
+        <a:scrgbClr r="0" g="0" b="0"/>
+      </a:fillRef>
+      <a:effectRef idx="0">
+        <a:scrgbClr r="0" g="0" b="0"/>
+      </a:effectRef>
+      <a:fontRef idx="minor"/>
+    </dgm:style>
+  </dgm:styleLbl>
+  <dgm:styleLbl name="fgAcc1">
+    <dgm:scene3d>
+      <a:camera prst="orthographicFront"/>
+      <a:lightRig rig="threePt" dir="t"/>
+    </dgm:scene3d>
+    <dgm:sp3d/>
+    <dgm:txPr/>
+    <dgm:style>
+      <a:lnRef idx="2">
+        <a:scrgbClr r="0" g="0" b="0"/>
+      </a:lnRef>
+      <a:fillRef idx="1">
+        <a:scrgbClr r="0" g="0" b="0"/>
+      </a:fillRef>
+      <a:effectRef idx="0">
+        <a:scrgbClr r="0" g="0" b="0"/>
+      </a:effectRef>
+      <a:fontRef idx="minor"/>
+    </dgm:style>
+  </dgm:styleLbl>
+  <dgm:styleLbl name="conFgAcc1">
+    <dgm:scene3d>
+      <a:camera prst="orthographicFront"/>
+      <a:lightRig rig="threePt" dir="t"/>
+    </dgm:scene3d>
+    <dgm:sp3d/>
+    <dgm:txPr/>
+    <dgm:style>
+      <a:lnRef idx="2">
+        <a:scrgbClr r="0" g="0" b="0"/>
+      </a:lnRef>
+      <a:fillRef idx="1">
+        <a:scrgbClr r="0" g="0" b="0"/>
+      </a:fillRef>
+      <a:effectRef idx="0">
+        <a:scrgbClr r="0" g="0" b="0"/>
+      </a:effectRef>
+      <a:fontRef idx="minor"/>
+    </dgm:style>
+  </dgm:styleLbl>
+  <dgm:styleLbl name="alignAcc1">
+    <dgm:scene3d>
+      <a:camera prst="orthographicFront"/>
+      <a:lightRig rig="threePt" dir="t"/>
+    </dgm:scene3d>
+    <dgm:sp3d/>
+    <dgm:txPr/>
+    <dgm:style>
+      <a:lnRef idx="2">
+        <a:scrgbClr r="0" g="0" b="0"/>
+      </a:lnRef>
+      <a:fillRef idx="1">
+        <a:scrgbClr r="0" g="0" b="0"/>
+      </a:fillRef>
+      <a:effectRef idx="0">
+        <a:scrgbClr r="0" g="0" b="0"/>
+      </a:effectRef>
+      <a:fontRef idx="minor"/>
+    </dgm:style>
+  </dgm:styleLbl>
+  <dgm:styleLbl name="trAlignAcc1">
+    <dgm:scene3d>
+      <a:camera prst="orthographicFront"/>
+      <a:lightRig rig="threePt" dir="t"/>
+    </dgm:scene3d>
+    <dgm:sp3d/>
+    <dgm:txPr/>
+    <dgm:style>
+      <a:lnRef idx="1">
+        <a:scrgbClr r="0" g="0" b="0"/>
+      </a:lnRef>
+      <a:fillRef idx="1">
+        <a:scrgbClr r="0" g="0" b="0"/>
+      </a:fillRef>
+      <a:effectRef idx="0">
+        <a:scrgbClr r="0" g="0" b="0"/>
+      </a:effectRef>
+      <a:fontRef idx="minor"/>
+    </dgm:style>
+  </dgm:styleLbl>
+  <dgm:styleLbl name="bgAcc1">
+    <dgm:scene3d>
+      <a:camera prst="orthographicFront"/>
+      <a:lightRig rig="threePt" dir="t"/>
+    </dgm:scene3d>
+    <dgm:sp3d/>
+    <dgm:txPr/>
+    <dgm:style>
+      <a:lnRef idx="2">
+        <a:scrgbClr r="0" g="0" b="0"/>
+      </a:lnRef>
+      <a:fillRef idx="1">
+        <a:scrgbClr r="0" g="0" b="0"/>
+      </a:fillRef>
+      <a:effectRef idx="0">
+        <a:scrgbClr r="0" g="0" b="0"/>
+      </a:effectRef>
+      <a:fontRef idx="minor"/>
+    </dgm:style>
+  </dgm:styleLbl>
+  <dgm:styleLbl name="solidFgAcc1">
+    <dgm:scene3d>
+      <a:camera prst="orthographicFront"/>
+      <a:lightRig rig="threePt" dir="t"/>
+    </dgm:scene3d>
+    <dgm:sp3d/>
+    <dgm:txPr/>
+    <dgm:style>
+      <a:lnRef idx="2">
+        <a:scrgbClr r="0" g="0" b="0"/>
+      </a:lnRef>
+      <a:fillRef idx="1">
+        <a:scrgbClr r="0" g="0" b="0"/>
+      </a:fillRef>
+      <a:effectRef idx="0">
+        <a:scrgbClr r="0" g="0" b="0"/>
+      </a:effectRef>
+      <a:fontRef idx="minor"/>
+    </dgm:style>
+  </dgm:styleLbl>
+  <dgm:styleLbl name="solidAlignAcc1">
+    <dgm:scene3d>
+      <a:camera prst="orthographicFront"/>
+      <a:lightRig rig="threePt" dir="t"/>
+    </dgm:scene3d>
+    <dgm:sp3d/>
+    <dgm:txPr/>
+    <dgm:style>
+      <a:lnRef idx="2">
+        <a:scrgbClr r="0" g="0" b="0"/>
+      </a:lnRef>
+      <a:fillRef idx="1">
+        <a:scrgbClr r="0" g="0" b="0"/>
+      </a:fillRef>
+      <a:effectRef idx="0">
+        <a:scrgbClr r="0" g="0" b="0"/>
+      </a:effectRef>
+      <a:fontRef idx="minor"/>
+    </dgm:style>
+  </dgm:styleLbl>
+  <dgm:styleLbl name="solidBgAcc1">
+    <dgm:scene3d>
+      <a:camera prst="orthographicFront"/>
+      <a:lightRig rig="threePt" dir="t"/>
+    </dgm:scene3d>
+    <dgm:sp3d/>
+    <dgm:txPr/>
+    <dgm:style>
+      <a:lnRef idx="2">
+        <a:scrgbClr r="0" g="0" b="0"/>
+      </a:lnRef>
+      <a:fillRef idx="1">
+        <a:scrgbClr r="0" g="0" b="0"/>
+      </a:fillRef>
+      <a:effectRef idx="0">
+        <a:scrgbClr r="0" g="0" b="0"/>
+      </a:effectRef>
+      <a:fontRef idx="minor"/>
+    </dgm:style>
+  </dgm:styleLbl>
+  <dgm:styleLbl name="fgAccFollowNode1">
+    <dgm:scene3d>
+      <a:camera prst="orthographicFront"/>
+      <a:lightRig rig="threePt" dir="t"/>
+    </dgm:scene3d>
+    <dgm:sp3d/>
+    <dgm:txPr/>
+    <dgm:style>
+      <a:lnRef idx="2">
+        <a:scrgbClr r="0" g="0" b="0"/>
+      </a:lnRef>
+      <a:fillRef idx="1">
+        <a:scrgbClr r="0" g="0" b="0"/>
+      </a:fillRef>
+      <a:effectRef idx="0">
+        <a:scrgbClr r="0" g="0" b="0"/>
+      </a:effectRef>
+      <a:fontRef idx="minor"/>
+    </dgm:style>
+  </dgm:styleLbl>
+  <dgm:styleLbl name="alignAccFollowNode1">
+    <dgm:scene3d>
+      <a:camera prst="orthographicFront"/>
+      <a:lightRig rig="threePt" dir="t"/>
+    </dgm:scene3d>
+    <dgm:sp3d/>
+    <dgm:txPr/>
+    <dgm:style>
+      <a:lnRef idx="2">
+        <a:scrgbClr r="0" g="0" b="0"/>
+      </a:lnRef>
+      <a:fillRef idx="1">
+        <a:scrgbClr r="0" g="0" b="0"/>
+      </a:fillRef>
+      <a:effectRef idx="0">
+        <a:scrgbClr r="0" g="0" b="0"/>
+      </a:effectRef>
+      <a:fontRef idx="minor"/>
+    </dgm:style>
+  </dgm:styleLbl>
+  <dgm:styleLbl name="bgAccFollowNode1">
+    <dgm:scene3d>
+      <a:camera prst="orthographicFront"/>
+      <a:lightRig rig="threePt" dir="t"/>
+    </dgm:scene3d>
+    <dgm:sp3d/>
+    <dgm:txPr/>
+    <dgm:style>
+      <a:lnRef idx="2">
+        <a:scrgbClr r="0" g="0" b="0"/>
+      </a:lnRef>
+      <a:fillRef idx="1">
+        <a:scrgbClr r="0" g="0" b="0"/>
+      </a:fillRef>
+      <a:effectRef idx="0">
+        <a:scrgbClr r="0" g="0" b="0"/>
+      </a:effectRef>
+      <a:fontRef idx="minor"/>
+    </dgm:style>
+  </dgm:styleLbl>
+  <dgm:styleLbl name="fgAcc0">
+    <dgm:scene3d>
+      <a:camera prst="orthographicFront"/>
+      <a:lightRig rig="threePt" dir="t"/>
+    </dgm:scene3d>
+    <dgm:sp3d/>
+    <dgm:txPr/>
+    <dgm:style>
+      <a:lnRef idx="2">
+        <a:scrgbClr r="0" g="0" b="0"/>
+      </a:lnRef>
+      <a:fillRef idx="1">
+        <a:scrgbClr r="0" g="0" b="0"/>
+      </a:fillRef>
+      <a:effectRef idx="0">
+        <a:scrgbClr r="0" g="0" b="0"/>
+      </a:effectRef>
+      <a:fontRef idx="minor"/>
+    </dgm:style>
+  </dgm:styleLbl>
+  <dgm:styleLbl name="fgAcc2">
+    <dgm:scene3d>
+      <a:camera prst="orthographicFront"/>
+      <a:lightRig rig="threePt" dir="t"/>
+    </dgm:scene3d>
+    <dgm:sp3d/>
+    <dgm:txPr/>
+    <dgm:style>
+      <a:lnRef idx="2">
+        <a:scrgbClr r="0" g="0" b="0"/>
+      </a:lnRef>
+      <a:fillRef idx="1">
+        <a:scrgbClr r="0" g="0" b="0"/>
+      </a:fillRef>
+      <a:effectRef idx="0">
+        <a:scrgbClr r="0" g="0" b="0"/>
+      </a:effectRef>
+      <a:fontRef idx="minor"/>
+    </dgm:style>
+  </dgm:styleLbl>
+  <dgm:styleLbl name="fgAcc3">
+    <dgm:scene3d>
+      <a:camera prst="orthographicFront"/>
+      <a:lightRig rig="threePt" dir="t"/>
+    </dgm:scene3d>
+    <dgm:sp3d/>
+    <dgm:txPr/>
+    <dgm:style>
+      <a:lnRef idx="2">
+        <a:scrgbClr r="0" g="0" b="0"/>
+      </a:lnRef>
+      <a:fillRef idx="1">
+        <a:scrgbClr r="0" g="0" b="0"/>
+      </a:fillRef>
+      <a:effectRef idx="0">
+        <a:scrgbClr r="0" g="0" b="0"/>
+      </a:effectRef>
+      <a:fontRef idx="minor"/>
+    </dgm:style>
+  </dgm:styleLbl>
+  <dgm:styleLbl name="fgAcc4">
+    <dgm:scene3d>
+      <a:camera prst="orthographicFront"/>
+      <a:lightRig rig="threePt" dir="t"/>
+    </dgm:scene3d>
+    <dgm:sp3d/>
+    <dgm:txPr/>
+    <dgm:style>
+      <a:lnRef idx="2">
+        <a:scrgbClr r="0" g="0" b="0"/>
+      </a:lnRef>
+      <a:fillRef idx="1">
+        <a:scrgbClr r="0" g="0" b="0"/>
+      </a:fillRef>
+      <a:effectRef idx="0">
+        <a:scrgbClr r="0" g="0" b="0"/>
+      </a:effectRef>
+      <a:fontRef idx="minor"/>
+    </dgm:style>
+  </dgm:styleLbl>
+  <dgm:styleLbl name="bgShp">
+    <dgm:scene3d>
+      <a:camera prst="orthographicFront"/>
+      <a:lightRig rig="threePt" dir="t"/>
+    </dgm:scene3d>
+    <dgm:sp3d/>
+    <dgm:txPr/>
+    <dgm:style>
+      <a:lnRef idx="0">
+        <a:scrgbClr r="0" g="0" b="0"/>
+      </a:lnRef>
+      <a:fillRef idx="1">
+        <a:scrgbClr r="0" g="0" b="0"/>
+      </a:fillRef>
+      <a:effectRef idx="0">
+        <a:scrgbClr r="0" g="0" b="0"/>
+      </a:effectRef>
+      <a:fontRef idx="minor"/>
+    </dgm:style>
+  </dgm:styleLbl>
+  <dgm:styleLbl name="dkBgShp">
+    <dgm:scene3d>
+      <a:camera prst="orthographicFront"/>
+      <a:lightRig rig="threePt" dir="t"/>
+    </dgm:scene3d>
+    <dgm:sp3d/>
+    <dgm:txPr/>
+    <dgm:style>
+      <a:lnRef idx="0">
+        <a:scrgbClr r="0" g="0" b="0"/>
+      </a:lnRef>
+      <a:fillRef idx="1">
+        <a:scrgbClr r="0" g="0" b="0"/>
+      </a:fillRef>
+      <a:effectRef idx="0">
+        <a:scrgbClr r="0" g="0" b="0"/>
+      </a:effectRef>
+      <a:fontRef idx="minor"/>
+    </dgm:style>
+  </dgm:styleLbl>
+  <dgm:styleLbl name="trBgShp">
+    <dgm:scene3d>
+      <a:camera prst="orthographicFront"/>
+      <a:lightRig rig="threePt" dir="t"/>
+    </dgm:scene3d>
+    <dgm:sp3d/>
+    <dgm:txPr/>
+    <dgm:style>
+      <a:lnRef idx="0">
+        <a:scrgbClr r="0" g="0" b="0"/>
+      </a:lnRef>
+      <a:fillRef idx="1">
+        <a:scrgbClr r="0" g="0" b="0"/>
+      </a:fillRef>
+      <a:effectRef idx="0">
+        <a:scrgbClr r="0" g="0" b="0"/>
+      </a:effectRef>
+      <a:fontRef idx="minor"/>
+    </dgm:style>
+  </dgm:styleLbl>
+  <dgm:styleLbl name="fgShp">
+    <dgm:scene3d>
+      <a:camera prst="orthographicFront"/>
+      <a:lightRig rig="threePt" dir="t"/>
+    </dgm:scene3d>
+    <dgm:sp3d/>
+    <dgm:txPr/>
+    <dgm:style>
+      <a:lnRef idx="2">
+        <a:scrgbClr r="0" g="0" b="0"/>
+      </a:lnRef>
+      <a:fillRef idx="1">
+        <a:scrgbClr r="0" g="0" b="0"/>
+      </a:fillRef>
+      <a:effectRef idx="0">
+        <a:scrgbClr r="0" g="0" b="0"/>
+      </a:effectRef>
+      <a:fontRef idx="minor"/>
+    </dgm:style>
+  </dgm:styleLbl>
+  <dgm:styleLbl name="revTx">
+    <dgm:scene3d>
+      <a:camera prst="orthographicFront"/>
+      <a:lightRig rig="threePt" dir="t"/>
+    </dgm:scene3d>
+    <dgm:sp3d/>
+    <dgm:txPr/>
+    <dgm:style>
+      <a:lnRef idx="0">
+        <a:scrgbClr r="0" g="0" b="0"/>
+      </a:lnRef>
+      <a:fillRef idx="0">
+        <a:scrgbClr r="0" g="0" b="0"/>
+      </a:fillRef>
+      <a:effectRef idx="0">
+        <a:scrgbClr r="0" g="0" b="0"/>
+      </a:effectRef>
+      <a:fontRef idx="minor"/>
+    </dgm:style>
+  </dgm:styleLbl>
+</dgm:styleDef>
+</file>
+
+<file path=ppt/diagrams/quickStyle3.xml><?xml version="1.0" encoding="utf-8"?>
 <dgm:styleDef xmlns:dgm="http://schemas.openxmlformats.org/drawingml/2006/diagram" xmlns:a="http://schemas.openxmlformats.org/drawingml/2006/main" uniqueId="urn:microsoft.com/office/officeart/2005/8/quickstyle/simple1">
   <dgm:title val=""/>
   <dgm:desc val=""/>
@@ -6944,6 +9606,114 @@
     <p:extLst>
       <p:ext uri="{BB962C8B-B14F-4D97-AF65-F5344CB8AC3E}">
         <p14:creationId xmlns:p14="http://schemas.microsoft.com/office/powerpoint/2010/main" val="2206855608"/>
+      </p:ext>
+    </p:extLst>
+  </p:cSld>
+  <p:clrMapOvr>
+    <a:masterClrMapping/>
+  </p:clrMapOvr>
+</p:notes>
+</file>
+
+<file path=ppt/notesSlides/notesSlide6.xml><?xml version="1.0" encoding="utf-8"?>
+<p:notes xmlns:a="http://schemas.openxmlformats.org/drawingml/2006/main" xmlns:r="http://schemas.openxmlformats.org/officeDocument/2006/relationships" xmlns:p="http://schemas.openxmlformats.org/presentationml/2006/main">
+  <p:cSld>
+    <p:spTree>
+      <p:nvGrpSpPr>
+        <p:cNvPr id="1" name="">
+          <a:extLst>
+            <a:ext uri="{FF2B5EF4-FFF2-40B4-BE49-F238E27FC236}">
+              <a16:creationId xmlns:a16="http://schemas.microsoft.com/office/drawing/2014/main" id="{CC92FA0D-0222-ECB5-4EEC-A6F98D9220D8}"/>
+            </a:ext>
+          </a:extLst>
+        </p:cNvPr>
+        <p:cNvGrpSpPr/>
+        <p:nvPr/>
+      </p:nvGrpSpPr>
+      <p:grpSpPr>
+        <a:xfrm>
+          <a:off x="0" y="0"/>
+          <a:ext cx="0" cy="0"/>
+          <a:chOff x="0" y="0"/>
+          <a:chExt cx="0" cy="0"/>
+        </a:xfrm>
+      </p:grpSpPr>
+      <p:sp>
+        <p:nvSpPr>
+          <p:cNvPr id="2" name="Slide Image Placeholder 1">
+            <a:extLst>
+              <a:ext uri="{FF2B5EF4-FFF2-40B4-BE49-F238E27FC236}">
+                <a16:creationId xmlns:a16="http://schemas.microsoft.com/office/drawing/2014/main" id="{78E3CA61-C078-B0F9-5D5C-538F58DF3472}"/>
+              </a:ext>
+            </a:extLst>
+          </p:cNvPr>
+          <p:cNvSpPr>
+            <a:spLocks noGrp="1" noRot="1" noChangeAspect="1"/>
+          </p:cNvSpPr>
+          <p:nvPr>
+            <p:ph type="sldImg"/>
+          </p:nvPr>
+        </p:nvSpPr>
+        <p:spPr/>
+      </p:sp>
+      <p:sp>
+        <p:nvSpPr>
+          <p:cNvPr id="3" name="Notes Placeholder 2">
+            <a:extLst>
+              <a:ext uri="{FF2B5EF4-FFF2-40B4-BE49-F238E27FC236}">
+                <a16:creationId xmlns:a16="http://schemas.microsoft.com/office/drawing/2014/main" id="{86328CB7-DB05-40F8-BAD4-4098275D7AF4}"/>
+              </a:ext>
+            </a:extLst>
+          </p:cNvPr>
+          <p:cNvSpPr>
+            <a:spLocks noGrp="1"/>
+          </p:cNvSpPr>
+          <p:nvPr>
+            <p:ph type="body" idx="1"/>
+          </p:nvPr>
+        </p:nvSpPr>
+        <p:spPr/>
+        <p:txBody>
+          <a:bodyPr/>
+          <a:lstStyle/>
+          <a:p>
+            <a:endParaRPr lang="en-US" dirty="0"/>
+          </a:p>
+        </p:txBody>
+      </p:sp>
+      <p:sp>
+        <p:nvSpPr>
+          <p:cNvPr id="4" name="Slide Number Placeholder 3">
+            <a:extLst>
+              <a:ext uri="{FF2B5EF4-FFF2-40B4-BE49-F238E27FC236}">
+                <a16:creationId xmlns:a16="http://schemas.microsoft.com/office/drawing/2014/main" id="{56F40C18-A1F7-9F81-2FAD-19698786A1E4}"/>
+              </a:ext>
+            </a:extLst>
+          </p:cNvPr>
+          <p:cNvSpPr>
+            <a:spLocks noGrp="1"/>
+          </p:cNvSpPr>
+          <p:nvPr>
+            <p:ph type="sldNum" sz="quarter" idx="5"/>
+          </p:nvPr>
+        </p:nvSpPr>
+        <p:spPr/>
+        <p:txBody>
+          <a:bodyPr/>
+          <a:lstStyle/>
+          <a:p>
+            <a:fld id="{EE000EEB-8338-48D7-8EE8-EE0082EF7602}" type="slidenum">
+              <a:rPr lang="en-US" smtClean="0"/>
+              <a:t>6</a:t>
+            </a:fld>
+            <a:endParaRPr lang="en-US" dirty="0"/>
+          </a:p>
+        </p:txBody>
+      </p:sp>
+    </p:spTree>
+    <p:extLst>
+      <p:ext uri="{BB962C8B-B14F-4D97-AF65-F5344CB8AC3E}">
+        <p14:creationId xmlns:p14="http://schemas.microsoft.com/office/powerpoint/2010/main" val="2231218762"/>
       </p:ext>
     </p:extLst>
   </p:cSld>
@@ -14925,6 +17695,276 @@
 </p:sld>
 </file>
 
+<file path=ppt/slides/slide6.xml><?xml version="1.0" encoding="utf-8"?>
+<p:sld xmlns:a="http://schemas.openxmlformats.org/drawingml/2006/main" xmlns:r="http://schemas.openxmlformats.org/officeDocument/2006/relationships" xmlns:p="http://schemas.openxmlformats.org/presentationml/2006/main">
+  <p:cSld>
+    <p:spTree>
+      <p:nvGrpSpPr>
+        <p:cNvPr id="1" name="">
+          <a:extLst>
+            <a:ext uri="{FF2B5EF4-FFF2-40B4-BE49-F238E27FC236}">
+              <a16:creationId xmlns:a16="http://schemas.microsoft.com/office/drawing/2014/main" id="{0726B810-4562-CF05-B49F-67ABC0BABEC8}"/>
+            </a:ext>
+          </a:extLst>
+        </p:cNvPr>
+        <p:cNvGrpSpPr/>
+        <p:nvPr/>
+      </p:nvGrpSpPr>
+      <p:grpSpPr>
+        <a:xfrm>
+          <a:off x="0" y="0"/>
+          <a:ext cx="0" cy="0"/>
+          <a:chOff x="0" y="0"/>
+          <a:chExt cx="0" cy="0"/>
+        </a:xfrm>
+      </p:grpSpPr>
+      <p:pic>
+        <p:nvPicPr>
+          <p:cNvPr id="5" name="Picture 4" descr="chain links">
+            <a:extLst>
+              <a:ext uri="{FF2B5EF4-FFF2-40B4-BE49-F238E27FC236}">
+                <a16:creationId xmlns:a16="http://schemas.microsoft.com/office/drawing/2014/main" id="{8EF47FAB-57E5-5509-2F6F-13A5EFC047C5}"/>
+              </a:ext>
+            </a:extLst>
+          </p:cNvPr>
+          <p:cNvPicPr>
+            <a:picLocks noChangeAspect="1"/>
+          </p:cNvPicPr>
+          <p:nvPr/>
+        </p:nvPicPr>
+        <p:blipFill rotWithShape="1">
+          <a:blip r:embed="rId3">
+            <a:duotone>
+              <a:prstClr val="black"/>
+              <a:schemeClr val="accent5">
+                <a:tint val="45000"/>
+                <a:satMod val="400000"/>
+              </a:schemeClr>
+            </a:duotone>
+            <a:alphaModFix amt="25000"/>
+          </a:blip>
+          <a:srcRect t="23391" r="9091"/>
+          <a:stretch/>
+        </p:blipFill>
+        <p:spPr>
+          <a:xfrm>
+            <a:off x="0" y="10"/>
+            <a:ext cx="12191980" cy="6857990"/>
+          </a:xfrm>
+          <a:prstGeom prst="rect">
+            <a:avLst/>
+          </a:prstGeom>
+        </p:spPr>
+      </p:pic>
+      <p:pic>
+        <p:nvPicPr>
+          <p:cNvPr id="14" name="Picture 13" descr="A group of cubes with a symbol and a blue light&#10;&#10;AI-generated content may be incorrect.">
+            <a:extLst>
+              <a:ext uri="{FF2B5EF4-FFF2-40B4-BE49-F238E27FC236}">
+                <a16:creationId xmlns:a16="http://schemas.microsoft.com/office/drawing/2014/main" id="{4264879D-64EC-50FB-0155-E6162B487321}"/>
+              </a:ext>
+            </a:extLst>
+          </p:cNvPr>
+          <p:cNvPicPr>
+            <a:picLocks noChangeAspect="1"/>
+          </p:cNvPicPr>
+          <p:nvPr/>
+        </p:nvPicPr>
+        <p:blipFill>
+          <a:blip r:embed="rId4"/>
+          <a:stretch>
+            <a:fillRect/>
+          </a:stretch>
+        </p:blipFill>
+        <p:spPr>
+          <a:xfrm>
+            <a:off x="765928" y="0"/>
+            <a:ext cx="10660144" cy="6858000"/>
+          </a:xfrm>
+          <a:prstGeom prst="rect">
+            <a:avLst/>
+          </a:prstGeom>
+        </p:spPr>
+      </p:pic>
+      <p:graphicFrame>
+        <p:nvGraphicFramePr>
+          <p:cNvPr id="17" name="Diagram 16">
+            <a:extLst>
+              <a:ext uri="{FF2B5EF4-FFF2-40B4-BE49-F238E27FC236}">
+                <a16:creationId xmlns:a16="http://schemas.microsoft.com/office/drawing/2014/main" id="{0A1C6F39-AB7F-24BB-C13F-038A22768E44}"/>
+              </a:ext>
+            </a:extLst>
+          </p:cNvPr>
+          <p:cNvGraphicFramePr/>
+          <p:nvPr/>
+        </p:nvGraphicFramePr>
+        <p:xfrm>
+          <a:off x="2220891" y="4632111"/>
+          <a:ext cx="8128000" cy="1408090"/>
+        </p:xfrm>
+        <a:graphic>
+          <a:graphicData uri="http://schemas.openxmlformats.org/drawingml/2006/diagram">
+            <dgm:relIds xmlns:dgm="http://schemas.openxmlformats.org/drawingml/2006/diagram" xmlns:r="http://schemas.openxmlformats.org/officeDocument/2006/relationships" r:dm="rId5" r:lo="rId6" r:qs="rId7" r:cs="rId8"/>
+          </a:graphicData>
+        </a:graphic>
+      </p:graphicFrame>
+      <p:pic>
+        <p:nvPicPr>
+          <p:cNvPr id="19" name="Picture 18" descr="A blue circle with a black background&#10;&#10;AI-generated content may be incorrect.">
+            <a:extLst>
+              <a:ext uri="{FF2B5EF4-FFF2-40B4-BE49-F238E27FC236}">
+                <a16:creationId xmlns:a16="http://schemas.microsoft.com/office/drawing/2014/main" id="{B3D76C5A-794C-B75A-F7F6-D467E2DE1E72}"/>
+              </a:ext>
+            </a:extLst>
+          </p:cNvPr>
+          <p:cNvPicPr>
+            <a:picLocks noChangeAspect="1"/>
+          </p:cNvPicPr>
+          <p:nvPr/>
+        </p:nvPicPr>
+        <p:blipFill>
+          <a:blip r:embed="rId10"/>
+          <a:stretch>
+            <a:fillRect/>
+          </a:stretch>
+        </p:blipFill>
+        <p:spPr>
+          <a:xfrm>
+            <a:off x="2769171" y="4926207"/>
+            <a:ext cx="858165" cy="776435"/>
+          </a:xfrm>
+          <a:prstGeom prst="roundRect">
+            <a:avLst>
+              <a:gd name="adj" fmla="val 16667"/>
+            </a:avLst>
+          </a:prstGeom>
+          <a:ln>
+            <a:noFill/>
+          </a:ln>
+          <a:effectLst>
+            <a:outerShdw blurRad="152400" dist="12000" dir="900000" sy="98000" kx="110000" ky="200000" algn="tl" rotWithShape="0">
+              <a:srgbClr val="000000">
+                <a:alpha val="30000"/>
+              </a:srgbClr>
+            </a:outerShdw>
+          </a:effectLst>
+          <a:scene3d>
+            <a:camera prst="perspectiveRelaxed">
+              <a:rot lat="19800000" lon="1200000" rev="20820000"/>
+            </a:camera>
+            <a:lightRig rig="threePt" dir="t"/>
+          </a:scene3d>
+          <a:sp3d contourW="6350" prstMaterial="matte">
+            <a:bevelT w="101600" h="101600"/>
+            <a:contourClr>
+              <a:srgbClr val="969696"/>
+            </a:contourClr>
+          </a:sp3d>
+        </p:spPr>
+      </p:pic>
+      <p:pic>
+        <p:nvPicPr>
+          <p:cNvPr id="3" name="Picture 2" descr="A white circle with a blue circle with a blue circle with a blue circle with a white circle with a blue circle with a blue circle with a white circle with a blue circle with a blue circle&#10;&#10;AI-generated content may be incorrect.">
+            <a:extLst>
+              <a:ext uri="{FF2B5EF4-FFF2-40B4-BE49-F238E27FC236}">
+                <a16:creationId xmlns:a16="http://schemas.microsoft.com/office/drawing/2014/main" id="{43EA67BE-A6E0-F223-488F-A69FA8DA51D0}"/>
+              </a:ext>
+            </a:extLst>
+          </p:cNvPr>
+          <p:cNvPicPr>
+            <a:picLocks noChangeAspect="1"/>
+          </p:cNvPicPr>
+          <p:nvPr/>
+        </p:nvPicPr>
+        <p:blipFill>
+          <a:blip r:embed="rId11"/>
+          <a:stretch>
+            <a:fillRect/>
+          </a:stretch>
+        </p:blipFill>
+        <p:spPr>
+          <a:xfrm>
+            <a:off x="2827177" y="270455"/>
+            <a:ext cx="6915427" cy="4172765"/>
+          </a:xfrm>
+          <a:prstGeom prst="rect">
+            <a:avLst/>
+          </a:prstGeom>
+          <a:ln>
+            <a:noFill/>
+          </a:ln>
+          <a:effectLst>
+            <a:softEdge rad="112500"/>
+          </a:effectLst>
+        </p:spPr>
+      </p:pic>
+      <p:pic>
+        <p:nvPicPr>
+          <p:cNvPr id="4" name="Picture 3">
+            <a:extLst>
+              <a:ext uri="{FF2B5EF4-FFF2-40B4-BE49-F238E27FC236}">
+                <a16:creationId xmlns:a16="http://schemas.microsoft.com/office/drawing/2014/main" id="{38488C7E-C6CD-C64C-01FB-EB48AD553995}"/>
+              </a:ext>
+            </a:extLst>
+          </p:cNvPr>
+          <p:cNvPicPr>
+            <a:picLocks noChangeAspect="1"/>
+          </p:cNvPicPr>
+          <p:nvPr/>
+        </p:nvPicPr>
+        <p:blipFill>
+          <a:blip r:embed="rId12"/>
+          <a:stretch>
+            <a:fillRect/>
+          </a:stretch>
+        </p:blipFill>
+        <p:spPr>
+          <a:xfrm>
+            <a:off x="4928061" y="4926207"/>
+            <a:ext cx="778462" cy="776435"/>
+          </a:xfrm>
+          <a:prstGeom prst="roundRect">
+            <a:avLst>
+              <a:gd name="adj" fmla="val 16667"/>
+            </a:avLst>
+          </a:prstGeom>
+          <a:ln>
+            <a:noFill/>
+          </a:ln>
+          <a:effectLst>
+            <a:outerShdw blurRad="152400" dist="12000" dir="900000" sy="98000" kx="110000" ky="200000" algn="tl" rotWithShape="0">
+              <a:srgbClr val="000000">
+                <a:alpha val="30000"/>
+              </a:srgbClr>
+            </a:outerShdw>
+          </a:effectLst>
+          <a:scene3d>
+            <a:camera prst="perspectiveRelaxed">
+              <a:rot lat="19800000" lon="1200000" rev="20820000"/>
+            </a:camera>
+            <a:lightRig rig="threePt" dir="t"/>
+          </a:scene3d>
+          <a:sp3d contourW="6350" prstMaterial="matte">
+            <a:bevelT w="101600" h="101600"/>
+            <a:contourClr>
+              <a:srgbClr val="969696"/>
+            </a:contourClr>
+          </a:sp3d>
+        </p:spPr>
+      </p:pic>
+    </p:spTree>
+    <p:extLst>
+      <p:ext uri="{BB962C8B-B14F-4D97-AF65-F5344CB8AC3E}">
+        <p14:creationId xmlns:p14="http://schemas.microsoft.com/office/powerpoint/2010/main" val="1150308760"/>
+      </p:ext>
+    </p:extLst>
+  </p:cSld>
+  <p:clrMapOvr>
+    <a:masterClrMapping/>
+  </p:clrMapOvr>
+</p:sld>
+</file>
+
 <file path=ppt/theme/theme1.xml><?xml version="1.0" encoding="utf-8"?>
 <a:theme xmlns:a="http://schemas.openxmlformats.org/drawingml/2006/main" name="Ion">
   <a:themeElements>

</xml_diff>